<commit_message>
Add presentation demo entry point
</commit_message>
<xml_diff>
--- a/presentation.pptx
+++ b/presentation.pptx
@@ -2,21 +2,21 @@
 <file path=ppt/presentation.xml><?xml version="1.0" encoding="utf-8"?>
 <p:presentation xmlns:p="http://schemas.openxmlformats.org/presentationml/2006/main">
   <p:sldMasterIdLst>
-    <p:sldMasterId xmlns:r="http://schemas.openxmlformats.org/officeDocument/2006/relationships" id="2147483648" r:id="Rbd746e57e5b94b09"/>
+    <p:sldMasterId xmlns:r="http://schemas.openxmlformats.org/officeDocument/2006/relationships" id="2147483648" r:id="R55908d62dd4a402f"/>
   </p:sldMasterIdLst>
   <p:notesMasterIdLst>
-    <p:notesMasterId xmlns:r="http://schemas.openxmlformats.org/officeDocument/2006/relationships" r:id="R3c1bb667e7b549f9"/>
+    <p:notesMasterId xmlns:r="http://schemas.openxmlformats.org/officeDocument/2006/relationships" r:id="R900482a10da24b43"/>
   </p:notesMasterIdLst>
   <p:sldIdLst>
-    <p:sldId xmlns:r="http://schemas.openxmlformats.org/officeDocument/2006/relationships" id="256" r:id="R3d0c9005dfa449df"/>
-    <p:sldId xmlns:r="http://schemas.openxmlformats.org/officeDocument/2006/relationships" id="257" r:id="R19a0d92819534999"/>
-    <p:sldId xmlns:r="http://schemas.openxmlformats.org/officeDocument/2006/relationships" id="258" r:id="Rfcc2fea206bb4985"/>
-    <p:sldId xmlns:r="http://schemas.openxmlformats.org/officeDocument/2006/relationships" id="259" r:id="R7b6f18cbab3b4862"/>
-    <p:sldId xmlns:r="http://schemas.openxmlformats.org/officeDocument/2006/relationships" id="260" r:id="R52805f371e7c4f26"/>
-    <p:sldId xmlns:r="http://schemas.openxmlformats.org/officeDocument/2006/relationships" id="261" r:id="Rd61a9b42abf44c1c"/>
-    <p:sldId xmlns:r="http://schemas.openxmlformats.org/officeDocument/2006/relationships" id="262" r:id="Re903a8cb1c0b473c"/>
-    <p:sldId xmlns:r="http://schemas.openxmlformats.org/officeDocument/2006/relationships" id="263" r:id="R18c70add7c8e4b58"/>
-    <p:sldId xmlns:r="http://schemas.openxmlformats.org/officeDocument/2006/relationships" id="264" r:id="R0791ba6a134e479c"/>
+    <p:sldId xmlns:r="http://schemas.openxmlformats.org/officeDocument/2006/relationships" id="256" r:id="Rd7390ef300b449c5"/>
+    <p:sldId xmlns:r="http://schemas.openxmlformats.org/officeDocument/2006/relationships" id="257" r:id="Rd0d788b386ba4684"/>
+    <p:sldId xmlns:r="http://schemas.openxmlformats.org/officeDocument/2006/relationships" id="258" r:id="R2c28fcac5e4e4234"/>
+    <p:sldId xmlns:r="http://schemas.openxmlformats.org/officeDocument/2006/relationships" id="259" r:id="R18a0ba1f3f2246cd"/>
+    <p:sldId xmlns:r="http://schemas.openxmlformats.org/officeDocument/2006/relationships" id="260" r:id="R704f53a29a63486c"/>
+    <p:sldId xmlns:r="http://schemas.openxmlformats.org/officeDocument/2006/relationships" id="261" r:id="R75864e37bb88419c"/>
+    <p:sldId xmlns:r="http://schemas.openxmlformats.org/officeDocument/2006/relationships" id="262" r:id="R4b18650474714ee6"/>
+    <p:sldId xmlns:r="http://schemas.openxmlformats.org/officeDocument/2006/relationships" id="263" r:id="Rf16df50372224053"/>
+    <p:sldId xmlns:r="http://schemas.openxmlformats.org/officeDocument/2006/relationships" id="264" r:id="R44352fd51bcc4e5f"/>
   </p:sldIdLst>
   <p:sldSz cx="12192000" cy="6858000"/>
   <p:notesSz cx="6858000" cy="9144000"/>
@@ -1021,7 +1021,7 @@
           <p:cNvPr id="3" name="Title">
             <a:extLst xmlns:a="http://schemas.openxmlformats.org/drawingml/2006/main">
               <a:ext uri="{FF2B5EF4-FFF2-40B4-BE49-F238E27FC236}">
-                <a16:creationId xmlns:a16="http://schemas.microsoft.com/office/drawing/2014/main" id="{243C836E-B146-441F-8588-57E53D56C03C}"/>
+                <a16:creationId xmlns:a16="http://schemas.microsoft.com/office/drawing/2014/main" id="{045F108E-58ED-4F16-BEEA-549FFFFF01CB}"/>
               </a:ext>
             </a:extLst>
           </p:cNvPr>
@@ -1250,7 +1250,7 @@
           <p:cNvPr id="2" name="Subtitle">
             <a:extLst xmlns:a="http://schemas.openxmlformats.org/drawingml/2006/main">
               <a:ext uri="{FF2B5EF4-FFF2-40B4-BE49-F238E27FC236}">
-                <a16:creationId xmlns:a16="http://schemas.microsoft.com/office/drawing/2014/main" id="{2D45817F-13C7-4520-BFF0-D0EF3BE542C9}"/>
+                <a16:creationId xmlns:a16="http://schemas.microsoft.com/office/drawing/2014/main" id="{E2CCE004-2936-4A83-8ED3-AFEB23EAF8ED}"/>
               </a:ext>
             </a:extLst>
           </p:cNvPr>
@@ -1496,7 +1496,7 @@
           <p:cNvPr id="2" name="Section title">
             <a:extLst xmlns:a="http://schemas.openxmlformats.org/drawingml/2006/main">
               <a:ext uri="{FF2B5EF4-FFF2-40B4-BE49-F238E27FC236}">
-                <a16:creationId xmlns:a16="http://schemas.microsoft.com/office/drawing/2014/main" id="{23B0854A-3568-496C-A615-CA52E278AA9D}"/>
+                <a16:creationId xmlns:a16="http://schemas.microsoft.com/office/drawing/2014/main" id="{E5F8280C-8A0E-497E-88A8-936CE13EADC1}"/>
               </a:ext>
             </a:extLst>
           </p:cNvPr>
@@ -1742,7 +1742,7 @@
           <p:cNvPr id="3" name="Title">
             <a:extLst xmlns:a="http://schemas.openxmlformats.org/drawingml/2006/main">
               <a:ext uri="{FF2B5EF4-FFF2-40B4-BE49-F238E27FC236}">
-                <a16:creationId xmlns:a16="http://schemas.microsoft.com/office/drawing/2014/main" id="{510E7FD3-BE3B-4110-AEA6-3FFF288D930A}"/>
+                <a16:creationId xmlns:a16="http://schemas.microsoft.com/office/drawing/2014/main" id="{05B60F4C-3C1A-4B7C-B388-A6E72AC9C4E6}"/>
               </a:ext>
             </a:extLst>
           </p:cNvPr>
@@ -1971,7 +1971,7 @@
           <p:cNvPr id="2" name="Body">
             <a:extLst xmlns:a="http://schemas.openxmlformats.org/drawingml/2006/main">
               <a:ext uri="{FF2B5EF4-FFF2-40B4-BE49-F238E27FC236}">
-                <a16:creationId xmlns:a16="http://schemas.microsoft.com/office/drawing/2014/main" id="{A300D36B-18C4-47B2-A481-382D6A468671}"/>
+                <a16:creationId xmlns:a16="http://schemas.microsoft.com/office/drawing/2014/main" id="{DFE49796-2639-4FB2-90AD-994F6365B4F6}"/>
               </a:ext>
             </a:extLst>
           </p:cNvPr>
@@ -2217,7 +2217,7 @@
           <p:cNvPr id="4" name="Title">
             <a:extLst xmlns:a="http://schemas.openxmlformats.org/drawingml/2006/main">
               <a:ext uri="{FF2B5EF4-FFF2-40B4-BE49-F238E27FC236}">
-                <a16:creationId xmlns:a16="http://schemas.microsoft.com/office/drawing/2014/main" id="{4628CA89-5E9B-4974-8D9F-6A7E26DD7CA0}"/>
+                <a16:creationId xmlns:a16="http://schemas.microsoft.com/office/drawing/2014/main" id="{9765AAA2-FBFD-49F1-8A2E-1AF46D823050}"/>
               </a:ext>
             </a:extLst>
           </p:cNvPr>
@@ -2446,7 +2446,7 @@
           <p:cNvPr id="2" name="Left column">
             <a:extLst xmlns:a="http://schemas.openxmlformats.org/drawingml/2006/main">
               <a:ext uri="{FF2B5EF4-FFF2-40B4-BE49-F238E27FC236}">
-                <a16:creationId xmlns:a16="http://schemas.microsoft.com/office/drawing/2014/main" id="{A0FEDB57-8C86-4D1E-8638-0A81D1E32042}"/>
+                <a16:creationId xmlns:a16="http://schemas.microsoft.com/office/drawing/2014/main" id="{54CF6062-1D91-4DAB-B9BC-D8866E24E307}"/>
               </a:ext>
             </a:extLst>
           </p:cNvPr>
@@ -2675,7 +2675,7 @@
           <p:cNvPr id="3" name="Right column">
             <a:extLst xmlns:a="http://schemas.openxmlformats.org/drawingml/2006/main">
               <a:ext uri="{FF2B5EF4-FFF2-40B4-BE49-F238E27FC236}">
-                <a16:creationId xmlns:a16="http://schemas.microsoft.com/office/drawing/2014/main" id="{ABA0595B-F911-4CF1-BA7D-ED743DD946F3}"/>
+                <a16:creationId xmlns:a16="http://schemas.microsoft.com/office/drawing/2014/main" id="{50473252-DD44-4617-9B22-1B9C4EBE6AD0}"/>
               </a:ext>
             </a:extLst>
           </p:cNvPr>
@@ -2921,7 +2921,7 @@
           <p:cNvPr id="3" name="Title">
             <a:extLst xmlns:a="http://schemas.openxmlformats.org/drawingml/2006/main">
               <a:ext uri="{FF2B5EF4-FFF2-40B4-BE49-F238E27FC236}">
-                <a16:creationId xmlns:a16="http://schemas.microsoft.com/office/drawing/2014/main" id="{933D14AA-70A8-41B5-A004-82519DB6A57E}"/>
+                <a16:creationId xmlns:a16="http://schemas.microsoft.com/office/drawing/2014/main" id="{BBD4A561-DC33-4C6A-BD6D-5EDBA34B3A9F}"/>
               </a:ext>
             </a:extLst>
           </p:cNvPr>
@@ -3150,7 +3150,7 @@
           <p:cNvPr id="2" name="Left column">
             <a:extLst xmlns:a="http://schemas.openxmlformats.org/drawingml/2006/main">
               <a:ext uri="{FF2B5EF4-FFF2-40B4-BE49-F238E27FC236}">
-                <a16:creationId xmlns:a16="http://schemas.microsoft.com/office/drawing/2014/main" id="{9290FA07-EF21-4949-83BF-81F0B42B1CCA}"/>
+                <a16:creationId xmlns:a16="http://schemas.microsoft.com/office/drawing/2014/main" id="{C418C170-157B-4E56-94E8-11B634A38750}"/>
               </a:ext>
             </a:extLst>
           </p:cNvPr>
@@ -3417,12 +3417,12 @@
   </p:cSld>
   <p:clrMap bg1="lt1" tx1="dk1" bg2="lt2" tx2="dk2" accent1="accent1" accent2="accent2" accent3="accent3" accent4="accent4" accent5="accent5" accent6="accent6" hlink="hlink" folHlink="folHlink"/>
   <p:sldLayoutIdLst>
-    <p:sldLayoutId xmlns:r="http://schemas.openxmlformats.org/officeDocument/2006/relationships" id="2147483649" r:id="Rdb80ee71b2d9436c"/>
-    <p:sldLayoutId xmlns:r="http://schemas.openxmlformats.org/officeDocument/2006/relationships" id="2147483650" r:id="R39a2ae0932c04416"/>
-    <p:sldLayoutId xmlns:r="http://schemas.openxmlformats.org/officeDocument/2006/relationships" id="2147483651" r:id="R0892bca614e74fbc"/>
-    <p:sldLayoutId xmlns:r="http://schemas.openxmlformats.org/officeDocument/2006/relationships" id="2147483652" r:id="R2d23a1538731427f"/>
-    <p:sldLayoutId xmlns:r="http://schemas.openxmlformats.org/officeDocument/2006/relationships" id="2147483653" r:id="R90b4731c56d547de"/>
-    <p:sldLayoutId xmlns:r="http://schemas.openxmlformats.org/officeDocument/2006/relationships" id="2147483654" r:id="R4c44504c9bd74533"/>
+    <p:sldLayoutId xmlns:r="http://schemas.openxmlformats.org/officeDocument/2006/relationships" id="2147483649" r:id="Ra0e2731c64964e6b"/>
+    <p:sldLayoutId xmlns:r="http://schemas.openxmlformats.org/officeDocument/2006/relationships" id="2147483650" r:id="R512aaba8cab74b69"/>
+    <p:sldLayoutId xmlns:r="http://schemas.openxmlformats.org/officeDocument/2006/relationships" id="2147483651" r:id="R8180c7185ac9476e"/>
+    <p:sldLayoutId xmlns:r="http://schemas.openxmlformats.org/officeDocument/2006/relationships" id="2147483652" r:id="R1eed18b43eca4e42"/>
+    <p:sldLayoutId xmlns:r="http://schemas.openxmlformats.org/officeDocument/2006/relationships" id="2147483653" r:id="R27af0c5dcb98461c"/>
+    <p:sldLayoutId xmlns:r="http://schemas.openxmlformats.org/officeDocument/2006/relationships" id="2147483654" r:id="Re92e759551d7448b"/>
   </p:sldLayoutIdLst>
   <p:txStyles>
     <p:titleStyle>
@@ -4134,7 +4134,7 @@
           <p:cNvPr id="17" name="">
             <a:extLst xmlns:a="http://schemas.openxmlformats.org/drawingml/2006/main">
               <a:ext uri="{FF2B5EF4-FFF2-40B4-BE49-F238E27FC236}">
-                <a16:creationId xmlns:a16="http://schemas.microsoft.com/office/drawing/2014/main" id="{583CA38A-FE67-4FF8-99F9-007384DB5C39}"/>
+                <a16:creationId xmlns:a16="http://schemas.microsoft.com/office/drawing/2014/main" id="{8FE8CDD3-21FE-40FC-A4B1-83F4377264D3}"/>
               </a:ext>
             </a:extLst>
           </p:cNvPr>
@@ -4164,7 +4164,7 @@
           <p:cNvPr id="2" name="">
             <a:extLst xmlns:a="http://schemas.openxmlformats.org/drawingml/2006/main">
               <a:ext uri="{FF2B5EF4-FFF2-40B4-BE49-F238E27FC236}">
-                <a16:creationId xmlns:a16="http://schemas.microsoft.com/office/drawing/2014/main" id="{EE4113E7-D244-4575-BEA1-32B44A40EC2A}"/>
+                <a16:creationId xmlns:a16="http://schemas.microsoft.com/office/drawing/2014/main" id="{B452B8B4-FB76-403E-8C32-0986F8BF0AF7}"/>
               </a:ext>
             </a:extLst>
           </p:cNvPr>
@@ -4194,7 +4194,7 @@
           <p:cNvPr id="3" name="">
             <a:extLst xmlns:a="http://schemas.openxmlformats.org/drawingml/2006/main">
               <a:ext uri="{FF2B5EF4-FFF2-40B4-BE49-F238E27FC236}">
-                <a16:creationId xmlns:a16="http://schemas.microsoft.com/office/drawing/2014/main" id="{831F0AB2-5AC0-4B50-B9F3-E14ABD24F67A}"/>
+                <a16:creationId xmlns:a16="http://schemas.microsoft.com/office/drawing/2014/main" id="{46379345-73E5-4E69-BD46-E119045AC50F}"/>
               </a:ext>
             </a:extLst>
           </p:cNvPr>
@@ -4228,7 +4228,7 @@
           <p:cNvPr id="4" name="">
             <a:extLst xmlns:a="http://schemas.openxmlformats.org/drawingml/2006/main">
               <a:ext uri="{FF2B5EF4-FFF2-40B4-BE49-F238E27FC236}">
-                <a16:creationId xmlns:a16="http://schemas.microsoft.com/office/drawing/2014/main" id="{ABAC3B8A-CF73-4633-8F74-B1062103B4F9}"/>
+                <a16:creationId xmlns:a16="http://schemas.microsoft.com/office/drawing/2014/main" id="{E5B8255C-A8C0-4E85-B5EF-2F5505387332}"/>
               </a:ext>
             </a:extLst>
           </p:cNvPr>
@@ -4262,7 +4262,7 @@
           <p:cNvPr id="5" name="">
             <a:extLst xmlns:a="http://schemas.openxmlformats.org/drawingml/2006/main">
               <a:ext uri="{FF2B5EF4-FFF2-40B4-BE49-F238E27FC236}">
-                <a16:creationId xmlns:a16="http://schemas.microsoft.com/office/drawing/2014/main" id="{8FE53959-4720-4E01-AFC6-7B6242AFB0DF}"/>
+                <a16:creationId xmlns:a16="http://schemas.microsoft.com/office/drawing/2014/main" id="{7A3F577B-A115-445C-AC22-1D9BEDC37CDE}"/>
               </a:ext>
             </a:extLst>
           </p:cNvPr>
@@ -4296,7 +4296,7 @@
           <p:cNvPr id="6" name="">
             <a:extLst xmlns:a="http://schemas.openxmlformats.org/drawingml/2006/main">
               <a:ext uri="{FF2B5EF4-FFF2-40B4-BE49-F238E27FC236}">
-                <a16:creationId xmlns:a16="http://schemas.microsoft.com/office/drawing/2014/main" id="{090C1F09-1F3D-4EC2-99A9-A21E3A23A1CD}"/>
+                <a16:creationId xmlns:a16="http://schemas.microsoft.com/office/drawing/2014/main" id="{70491A4D-496F-43CD-9DAF-F47E7D8E3171}"/>
               </a:ext>
             </a:extLst>
           </p:cNvPr>
@@ -4330,7 +4330,7 @@
           <p:cNvPr id="7" name="">
             <a:extLst xmlns:a="http://schemas.openxmlformats.org/drawingml/2006/main">
               <a:ext uri="{FF2B5EF4-FFF2-40B4-BE49-F238E27FC236}">
-                <a16:creationId xmlns:a16="http://schemas.microsoft.com/office/drawing/2014/main" id="{14B8F089-1971-4C78-BC46-26F6EB42BE83}"/>
+                <a16:creationId xmlns:a16="http://schemas.microsoft.com/office/drawing/2014/main" id="{9C358584-C5DC-4931-9A71-6CB58DA8DB75}"/>
               </a:ext>
             </a:extLst>
           </p:cNvPr>
@@ -4364,7 +4364,7 @@
           <p:cNvPr id="8" name="">
             <a:extLst xmlns:a="http://schemas.openxmlformats.org/drawingml/2006/main">
               <a:ext uri="{FF2B5EF4-FFF2-40B4-BE49-F238E27FC236}">
-                <a16:creationId xmlns:a16="http://schemas.microsoft.com/office/drawing/2014/main" id="{85A5C3B1-454A-493A-8355-A1CE96B62A35}"/>
+                <a16:creationId xmlns:a16="http://schemas.microsoft.com/office/drawing/2014/main" id="{E572C62A-332C-46E7-9E23-59066A05A6F9}"/>
               </a:ext>
             </a:extLst>
           </p:cNvPr>
@@ -4398,7 +4398,7 @@
           <p:cNvPr id="9" name="">
             <a:extLst xmlns:a="http://schemas.openxmlformats.org/drawingml/2006/main">
               <a:ext uri="{FF2B5EF4-FFF2-40B4-BE49-F238E27FC236}">
-                <a16:creationId xmlns:a16="http://schemas.microsoft.com/office/drawing/2014/main" id="{1131A058-CEA5-480B-BB2B-53FEB27119C9}"/>
+                <a16:creationId xmlns:a16="http://schemas.microsoft.com/office/drawing/2014/main" id="{9229184A-DC95-4FE9-BAF9-DC30E1C0F762}"/>
               </a:ext>
             </a:extLst>
           </p:cNvPr>
@@ -4428,7 +4428,7 @@
           <p:cNvPr id="10" name="">
             <a:extLst xmlns:a="http://schemas.openxmlformats.org/drawingml/2006/main">
               <a:ext uri="{FF2B5EF4-FFF2-40B4-BE49-F238E27FC236}">
-                <a16:creationId xmlns:a16="http://schemas.microsoft.com/office/drawing/2014/main" id="{4EBAEAB3-1A7D-487C-9F7A-22D0E70128B5}"/>
+                <a16:creationId xmlns:a16="http://schemas.microsoft.com/office/drawing/2014/main" id="{AE18215A-AC1B-4189-BF9D-6BA25B300805}"/>
               </a:ext>
             </a:extLst>
           </p:cNvPr>
@@ -4460,7 +4460,7 @@
           <p:cNvPr id="11" name="">
             <a:extLst xmlns:a="http://schemas.openxmlformats.org/drawingml/2006/main">
               <a:ext uri="{FF2B5EF4-FFF2-40B4-BE49-F238E27FC236}">
-                <a16:creationId xmlns:a16="http://schemas.microsoft.com/office/drawing/2014/main" id="{247A333D-F512-4C30-A36D-6AF57927E478}"/>
+                <a16:creationId xmlns:a16="http://schemas.microsoft.com/office/drawing/2014/main" id="{B986B85E-A4AC-4E6B-AEC5-FF53960790EE}"/>
               </a:ext>
             </a:extLst>
           </p:cNvPr>
@@ -4580,7 +4580,7 @@
           <p:cNvPr id="12" name="">
             <a:extLst xmlns:a="http://schemas.openxmlformats.org/drawingml/2006/main">
               <a:ext uri="{FF2B5EF4-FFF2-40B4-BE49-F238E27FC236}">
-                <a16:creationId xmlns:a16="http://schemas.microsoft.com/office/drawing/2014/main" id="{19CCC94B-FA11-417C-AECA-0A7D45208AD3}"/>
+                <a16:creationId xmlns:a16="http://schemas.microsoft.com/office/drawing/2014/main" id="{ECDADB7D-9D20-4DD0-B2D3-B45BEF467820}"/>
               </a:ext>
             </a:extLst>
           </p:cNvPr>
@@ -4700,7 +4700,7 @@
           <p:cNvPr id="13" name="">
             <a:extLst xmlns:a="http://schemas.openxmlformats.org/drawingml/2006/main">
               <a:ext uri="{FF2B5EF4-FFF2-40B4-BE49-F238E27FC236}">
-                <a16:creationId xmlns:a16="http://schemas.microsoft.com/office/drawing/2014/main" id="{AFECFF7E-46B6-4461-9837-571744E6A09E}"/>
+                <a16:creationId xmlns:a16="http://schemas.microsoft.com/office/drawing/2014/main" id="{ED8CDCA9-C3D2-485E-9F74-C29A69769A17}"/>
               </a:ext>
             </a:extLst>
           </p:cNvPr>
@@ -4820,7 +4820,7 @@
           <p:cNvPr id="14" name="">
             <a:extLst xmlns:a="http://schemas.openxmlformats.org/drawingml/2006/main">
               <a:ext uri="{FF2B5EF4-FFF2-40B4-BE49-F238E27FC236}">
-                <a16:creationId xmlns:a16="http://schemas.microsoft.com/office/drawing/2014/main" id="{C0C085C6-DC3B-40D7-B6F4-79A0FE9E9088}"/>
+                <a16:creationId xmlns:a16="http://schemas.microsoft.com/office/drawing/2014/main" id="{BCD79A8C-1C53-4981-BCE1-C1F13B4BD524}"/>
               </a:ext>
             </a:extLst>
           </p:cNvPr>
@@ -4940,7 +4940,7 @@
           <p:cNvPr id="15" name="">
             <a:extLst xmlns:a="http://schemas.openxmlformats.org/drawingml/2006/main">
               <a:ext uri="{FF2B5EF4-FFF2-40B4-BE49-F238E27FC236}">
-                <a16:creationId xmlns:a16="http://schemas.microsoft.com/office/drawing/2014/main" id="{07AFD784-5CBA-402F-A48E-3EA6D4D45B86}"/>
+                <a16:creationId xmlns:a16="http://schemas.microsoft.com/office/drawing/2014/main" id="{0E89DACF-79BD-4BCB-84EF-3926EA6438B7}"/>
               </a:ext>
             </a:extLst>
           </p:cNvPr>
@@ -5060,7 +5060,7 @@
           <p:cNvPr id="16" name="">
             <a:extLst xmlns:a="http://schemas.openxmlformats.org/drawingml/2006/main">
               <a:ext uri="{FF2B5EF4-FFF2-40B4-BE49-F238E27FC236}">
-                <a16:creationId xmlns:a16="http://schemas.microsoft.com/office/drawing/2014/main" id="{E7FF44D4-45A5-4ABF-A2DE-846CAD95C620}"/>
+                <a16:creationId xmlns:a16="http://schemas.microsoft.com/office/drawing/2014/main" id="{7C6BE6A6-9EA7-4A18-AF70-340FD94EC283}"/>
               </a:ext>
             </a:extLst>
           </p:cNvPr>
@@ -5178,7 +5178,7 @@
     </p:spTree>
     <p:extLst>
       <p:ext uri="{BB962C8B-B14F-4D97-AF65-F5344CB8AC3E}">
-        <p14:creationId xmlns:p14="http://schemas.microsoft.com/office/powerpoint/2010/main" val="1424318298"/>
+        <p14:creationId xmlns:p14="http://schemas.microsoft.com/office/powerpoint/2010/main" val="281045734"/>
       </p:ext>
     </p:extLst>
   </p:cSld>
@@ -5209,7 +5209,7 @@
           <p:cNvPr id="19" name="">
             <a:extLst xmlns:a="http://schemas.openxmlformats.org/drawingml/2006/main">
               <a:ext uri="{FF2B5EF4-FFF2-40B4-BE49-F238E27FC236}">
-                <a16:creationId xmlns:a16="http://schemas.microsoft.com/office/drawing/2014/main" id="{B63FC587-B0FA-455E-B740-31A2463DC247}"/>
+                <a16:creationId xmlns:a16="http://schemas.microsoft.com/office/drawing/2014/main" id="{3389A9B7-7F8A-4FF6-98FB-F4CF1299F853}"/>
               </a:ext>
             </a:extLst>
           </p:cNvPr>
@@ -5239,7 +5239,7 @@
           <p:cNvPr id="2" name="">
             <a:extLst xmlns:a="http://schemas.openxmlformats.org/drawingml/2006/main">
               <a:ext uri="{FF2B5EF4-FFF2-40B4-BE49-F238E27FC236}">
-                <a16:creationId xmlns:a16="http://schemas.microsoft.com/office/drawing/2014/main" id="{A08E13AC-6C47-40E0-B877-AB7C8FE97FCE}"/>
+                <a16:creationId xmlns:a16="http://schemas.microsoft.com/office/drawing/2014/main" id="{6DA1AFCF-2A9A-4317-B2C5-A90AECA30EA2}"/>
               </a:ext>
             </a:extLst>
           </p:cNvPr>
@@ -5359,7 +5359,7 @@
           <p:cNvPr id="3" name="">
             <a:extLst xmlns:a="http://schemas.openxmlformats.org/drawingml/2006/main">
               <a:ext uri="{FF2B5EF4-FFF2-40B4-BE49-F238E27FC236}">
-                <a16:creationId xmlns:a16="http://schemas.microsoft.com/office/drawing/2014/main" id="{492CAFB0-685E-4A73-9985-C445DD433F4A}"/>
+                <a16:creationId xmlns:a16="http://schemas.microsoft.com/office/drawing/2014/main" id="{BFAB7A1F-0421-4CC9-ACD5-DD04654A265A}"/>
               </a:ext>
             </a:extLst>
           </p:cNvPr>
@@ -5479,7 +5479,7 @@
           <p:cNvPr id="4" name="">
             <a:extLst xmlns:a="http://schemas.openxmlformats.org/drawingml/2006/main">
               <a:ext uri="{FF2B5EF4-FFF2-40B4-BE49-F238E27FC236}">
-                <a16:creationId xmlns:a16="http://schemas.microsoft.com/office/drawing/2014/main" id="{021554B7-D7E1-4560-8F29-5525AA9F64C3}"/>
+                <a16:creationId xmlns:a16="http://schemas.microsoft.com/office/drawing/2014/main" id="{61904E9A-7195-49B0-994F-0C5C46C2ACD2}"/>
               </a:ext>
             </a:extLst>
           </p:cNvPr>
@@ -5599,7 +5599,7 @@
           <p:cNvPr id="5" name="">
             <a:extLst xmlns:a="http://schemas.openxmlformats.org/drawingml/2006/main">
               <a:ext uri="{FF2B5EF4-FFF2-40B4-BE49-F238E27FC236}">
-                <a16:creationId xmlns:a16="http://schemas.microsoft.com/office/drawing/2014/main" id="{47925CB8-6755-47D1-835D-EB87BC1DC739}"/>
+                <a16:creationId xmlns:a16="http://schemas.microsoft.com/office/drawing/2014/main" id="{FFC25655-5DA3-4EA8-A534-2695D9A22AE3}"/>
               </a:ext>
             </a:extLst>
           </p:cNvPr>
@@ -5719,7 +5719,7 @@
           <p:cNvPr id="6" name="">
             <a:extLst xmlns:a="http://schemas.openxmlformats.org/drawingml/2006/main">
               <a:ext uri="{FF2B5EF4-FFF2-40B4-BE49-F238E27FC236}">
-                <a16:creationId xmlns:a16="http://schemas.microsoft.com/office/drawing/2014/main" id="{AA62D882-A600-45E0-8DCA-0C114D660684}"/>
+                <a16:creationId xmlns:a16="http://schemas.microsoft.com/office/drawing/2014/main" id="{00629A56-0BA6-4557-ADCD-646B35DE81C3}"/>
               </a:ext>
             </a:extLst>
           </p:cNvPr>
@@ -5749,7 +5749,7 @@
           <p:cNvPr id="7" name="">
             <a:extLst xmlns:a="http://schemas.openxmlformats.org/drawingml/2006/main">
               <a:ext uri="{FF2B5EF4-FFF2-40B4-BE49-F238E27FC236}">
-                <a16:creationId xmlns:a16="http://schemas.microsoft.com/office/drawing/2014/main" id="{ECF3A614-F20E-494B-9C69-ADE48D929C04}"/>
+                <a16:creationId xmlns:a16="http://schemas.microsoft.com/office/drawing/2014/main" id="{9FD46623-1263-4D98-9C15-E32EA2D2A531}"/>
               </a:ext>
             </a:extLst>
           </p:cNvPr>
@@ -5869,7 +5869,7 @@
           <p:cNvPr id="8" name="">
             <a:extLst xmlns:a="http://schemas.openxmlformats.org/drawingml/2006/main">
               <a:ext uri="{FF2B5EF4-FFF2-40B4-BE49-F238E27FC236}">
-                <a16:creationId xmlns:a16="http://schemas.microsoft.com/office/drawing/2014/main" id="{7FA3FD24-4E2B-462A-9BB8-78290C0A40EA}"/>
+                <a16:creationId xmlns:a16="http://schemas.microsoft.com/office/drawing/2014/main" id="{95366FB8-96C4-4C1F-8B0B-CCBFDCC69796}"/>
               </a:ext>
             </a:extLst>
           </p:cNvPr>
@@ -5989,7 +5989,7 @@
           <p:cNvPr id="9" name="">
             <a:extLst xmlns:a="http://schemas.openxmlformats.org/drawingml/2006/main">
               <a:ext uri="{FF2B5EF4-FFF2-40B4-BE49-F238E27FC236}">
-                <a16:creationId xmlns:a16="http://schemas.microsoft.com/office/drawing/2014/main" id="{4A01AF39-49E5-40ED-9091-FF8F8BEAC02C}"/>
+                <a16:creationId xmlns:a16="http://schemas.microsoft.com/office/drawing/2014/main" id="{BF8FF771-A063-497A-9D49-BBB025E50CF8}"/>
               </a:ext>
             </a:extLst>
           </p:cNvPr>
@@ -6109,7 +6109,7 @@
           <p:cNvPr id="10" name="">
             <a:extLst xmlns:a="http://schemas.openxmlformats.org/drawingml/2006/main">
               <a:ext uri="{FF2B5EF4-FFF2-40B4-BE49-F238E27FC236}">
-                <a16:creationId xmlns:a16="http://schemas.microsoft.com/office/drawing/2014/main" id="{D947E5FB-18F4-4AB7-B8DF-5A89C8C89807}"/>
+                <a16:creationId xmlns:a16="http://schemas.microsoft.com/office/drawing/2014/main" id="{7AB1FA04-99A9-4C75-8361-FE5B163021CC}"/>
               </a:ext>
             </a:extLst>
           </p:cNvPr>
@@ -6139,7 +6139,7 @@
           <p:cNvPr id="11" name="">
             <a:extLst xmlns:a="http://schemas.openxmlformats.org/drawingml/2006/main">
               <a:ext uri="{FF2B5EF4-FFF2-40B4-BE49-F238E27FC236}">
-                <a16:creationId xmlns:a16="http://schemas.microsoft.com/office/drawing/2014/main" id="{2D522439-5E39-40E5-B4E5-01656C2B7B34}"/>
+                <a16:creationId xmlns:a16="http://schemas.microsoft.com/office/drawing/2014/main" id="{9622A8C7-ECA0-4D61-842F-B941A3C13722}"/>
               </a:ext>
             </a:extLst>
           </p:cNvPr>
@@ -6259,7 +6259,7 @@
           <p:cNvPr id="12" name="">
             <a:extLst xmlns:a="http://schemas.openxmlformats.org/drawingml/2006/main">
               <a:ext uri="{FF2B5EF4-FFF2-40B4-BE49-F238E27FC236}">
-                <a16:creationId xmlns:a16="http://schemas.microsoft.com/office/drawing/2014/main" id="{98462AEC-EECF-4961-923F-D5A96E50C123}"/>
+                <a16:creationId xmlns:a16="http://schemas.microsoft.com/office/drawing/2014/main" id="{BCBBF52E-0AC4-4B4E-A0A3-5606970FCED8}"/>
               </a:ext>
             </a:extLst>
           </p:cNvPr>
@@ -6379,7 +6379,7 @@
           <p:cNvPr id="13" name="">
             <a:extLst xmlns:a="http://schemas.openxmlformats.org/drawingml/2006/main">
               <a:ext uri="{FF2B5EF4-FFF2-40B4-BE49-F238E27FC236}">
-                <a16:creationId xmlns:a16="http://schemas.microsoft.com/office/drawing/2014/main" id="{AE38F846-76EF-418E-9EA6-CA83DCEA21B4}"/>
+                <a16:creationId xmlns:a16="http://schemas.microsoft.com/office/drawing/2014/main" id="{F12A0642-A1B2-4FEC-9546-D647331C9F9F}"/>
               </a:ext>
             </a:extLst>
           </p:cNvPr>
@@ -6499,7 +6499,7 @@
           <p:cNvPr id="14" name="">
             <a:extLst xmlns:a="http://schemas.openxmlformats.org/drawingml/2006/main">
               <a:ext uri="{FF2B5EF4-FFF2-40B4-BE49-F238E27FC236}">
-                <a16:creationId xmlns:a16="http://schemas.microsoft.com/office/drawing/2014/main" id="{AA8A0155-4BDE-4874-A2D5-9D43D04A7C51}"/>
+                <a16:creationId xmlns:a16="http://schemas.microsoft.com/office/drawing/2014/main" id="{D97E73BB-5177-469D-94BF-92F04296EBD3}"/>
               </a:ext>
             </a:extLst>
           </p:cNvPr>
@@ -6529,7 +6529,7 @@
           <p:cNvPr id="15" name="">
             <a:extLst xmlns:a="http://schemas.openxmlformats.org/drawingml/2006/main">
               <a:ext uri="{FF2B5EF4-FFF2-40B4-BE49-F238E27FC236}">
-                <a16:creationId xmlns:a16="http://schemas.microsoft.com/office/drawing/2014/main" id="{1D189F36-AEDA-44EF-9B31-9DA4E50C8F2F}"/>
+                <a16:creationId xmlns:a16="http://schemas.microsoft.com/office/drawing/2014/main" id="{73DC1A6A-0DC0-4512-8BF7-9160139C61F7}"/>
               </a:ext>
             </a:extLst>
           </p:cNvPr>
@@ -6649,7 +6649,7 @@
           <p:cNvPr id="16" name="">
             <a:extLst xmlns:a="http://schemas.openxmlformats.org/drawingml/2006/main">
               <a:ext uri="{FF2B5EF4-FFF2-40B4-BE49-F238E27FC236}">
-                <a16:creationId xmlns:a16="http://schemas.microsoft.com/office/drawing/2014/main" id="{197306F3-9EB3-4076-8DDC-306945E3184C}"/>
+                <a16:creationId xmlns:a16="http://schemas.microsoft.com/office/drawing/2014/main" id="{3A6B7B80-EE5A-4DF7-8F55-3FB5C6010322}"/>
               </a:ext>
             </a:extLst>
           </p:cNvPr>
@@ -6769,7 +6769,7 @@
           <p:cNvPr id="17" name="">
             <a:extLst xmlns:a="http://schemas.openxmlformats.org/drawingml/2006/main">
               <a:ext uri="{FF2B5EF4-FFF2-40B4-BE49-F238E27FC236}">
-                <a16:creationId xmlns:a16="http://schemas.microsoft.com/office/drawing/2014/main" id="{07C873A6-AFD2-4D66-ACA6-93FD0BC7D635}"/>
+                <a16:creationId xmlns:a16="http://schemas.microsoft.com/office/drawing/2014/main" id="{629C1CFB-E53B-45B1-A1F2-F0A6A90167B0}"/>
               </a:ext>
             </a:extLst>
           </p:cNvPr>
@@ -6801,7 +6801,7 @@
           <p:cNvPr id="18" name="">
             <a:extLst xmlns:a="http://schemas.openxmlformats.org/drawingml/2006/main">
               <a:ext uri="{FF2B5EF4-FFF2-40B4-BE49-F238E27FC236}">
-                <a16:creationId xmlns:a16="http://schemas.microsoft.com/office/drawing/2014/main" id="{DF561A9A-DB6E-48AA-AA88-727BCD58F713}"/>
+                <a16:creationId xmlns:a16="http://schemas.microsoft.com/office/drawing/2014/main" id="{6BB8800F-F90B-4F38-B704-F421FF933401}"/>
               </a:ext>
             </a:extLst>
           </p:cNvPr>
@@ -6919,7 +6919,7 @@
     </p:spTree>
     <p:extLst>
       <p:ext uri="{BB962C8B-B14F-4D97-AF65-F5344CB8AC3E}">
-        <p14:creationId xmlns:p14="http://schemas.microsoft.com/office/powerpoint/2010/main" val="360658740"/>
+        <p14:creationId xmlns:p14="http://schemas.microsoft.com/office/powerpoint/2010/main" val="366601828"/>
       </p:ext>
     </p:extLst>
   </p:cSld>
@@ -6950,7 +6950,7 @@
           <p:cNvPr id="30" name="">
             <a:extLst xmlns:a="http://schemas.openxmlformats.org/drawingml/2006/main">
               <a:ext uri="{FF2B5EF4-FFF2-40B4-BE49-F238E27FC236}">
-                <a16:creationId xmlns:a16="http://schemas.microsoft.com/office/drawing/2014/main" id="{6AE0A409-4A4D-46D2-B706-7983CB45C859}"/>
+                <a16:creationId xmlns:a16="http://schemas.microsoft.com/office/drawing/2014/main" id="{1D17DA46-01EB-473F-9A98-90146B9CED9C}"/>
               </a:ext>
             </a:extLst>
           </p:cNvPr>
@@ -6980,7 +6980,7 @@
           <p:cNvPr id="2" name="">
             <a:extLst xmlns:a="http://schemas.openxmlformats.org/drawingml/2006/main">
               <a:ext uri="{FF2B5EF4-FFF2-40B4-BE49-F238E27FC236}">
-                <a16:creationId xmlns:a16="http://schemas.microsoft.com/office/drawing/2014/main" id="{724A6FFC-1B63-4E3C-96D7-A0958970A8BB}"/>
+                <a16:creationId xmlns:a16="http://schemas.microsoft.com/office/drawing/2014/main" id="{F77D8715-9744-4D2C-839A-C7D50136AB07}"/>
               </a:ext>
             </a:extLst>
           </p:cNvPr>
@@ -7100,7 +7100,7 @@
           <p:cNvPr id="3" name="">
             <a:extLst xmlns:a="http://schemas.openxmlformats.org/drawingml/2006/main">
               <a:ext uri="{FF2B5EF4-FFF2-40B4-BE49-F238E27FC236}">
-                <a16:creationId xmlns:a16="http://schemas.microsoft.com/office/drawing/2014/main" id="{5085BD51-807F-4816-9616-AA0D3FFB78D6}"/>
+                <a16:creationId xmlns:a16="http://schemas.microsoft.com/office/drawing/2014/main" id="{B314E144-3CC5-4E14-9BF7-0725B617AB8A}"/>
               </a:ext>
             </a:extLst>
           </p:cNvPr>
@@ -7220,7 +7220,7 @@
           <p:cNvPr id="4" name="">
             <a:extLst xmlns:a="http://schemas.openxmlformats.org/drawingml/2006/main">
               <a:ext uri="{FF2B5EF4-FFF2-40B4-BE49-F238E27FC236}">
-                <a16:creationId xmlns:a16="http://schemas.microsoft.com/office/drawing/2014/main" id="{42C4B08A-4596-403D-8A78-D43E313D1A17}"/>
+                <a16:creationId xmlns:a16="http://schemas.microsoft.com/office/drawing/2014/main" id="{5020FE58-CEF0-46C8-9674-21F37085E023}"/>
               </a:ext>
             </a:extLst>
           </p:cNvPr>
@@ -7340,7 +7340,7 @@
           <p:cNvPr id="5" name="">
             <a:extLst xmlns:a="http://schemas.openxmlformats.org/drawingml/2006/main">
               <a:ext uri="{FF2B5EF4-FFF2-40B4-BE49-F238E27FC236}">
-                <a16:creationId xmlns:a16="http://schemas.microsoft.com/office/drawing/2014/main" id="{151EDF58-8F78-48C4-A41B-BC13F1795AF0}"/>
+                <a16:creationId xmlns:a16="http://schemas.microsoft.com/office/drawing/2014/main" id="{B72D6034-34BB-4038-871A-813FBA73B51E}"/>
               </a:ext>
             </a:extLst>
           </p:cNvPr>
@@ -7372,7 +7372,7 @@
           <p:cNvPr id="6" name="">
             <a:extLst xmlns:a="http://schemas.openxmlformats.org/drawingml/2006/main">
               <a:ext uri="{FF2B5EF4-FFF2-40B4-BE49-F238E27FC236}">
-                <a16:creationId xmlns:a16="http://schemas.microsoft.com/office/drawing/2014/main" id="{4BFAAD1F-7F53-4932-8BA1-1EC05DFB75B5}"/>
+                <a16:creationId xmlns:a16="http://schemas.microsoft.com/office/drawing/2014/main" id="{445598F8-291B-4E8D-AB10-BF3617BC07CD}"/>
               </a:ext>
             </a:extLst>
           </p:cNvPr>
@@ -7492,7 +7492,7 @@
           <p:cNvPr id="7" name="">
             <a:extLst xmlns:a="http://schemas.openxmlformats.org/drawingml/2006/main">
               <a:ext uri="{FF2B5EF4-FFF2-40B4-BE49-F238E27FC236}">
-                <a16:creationId xmlns:a16="http://schemas.microsoft.com/office/drawing/2014/main" id="{D8EC0FBE-3628-4E92-8208-6D9AA677871B}"/>
+                <a16:creationId xmlns:a16="http://schemas.microsoft.com/office/drawing/2014/main" id="{FB0D1DD6-FCF8-486D-80C8-F6833638FF39}"/>
               </a:ext>
             </a:extLst>
           </p:cNvPr>
@@ -7612,7 +7612,7 @@
           <p:cNvPr id="8" name="">
             <a:extLst xmlns:a="http://schemas.openxmlformats.org/drawingml/2006/main">
               <a:ext uri="{FF2B5EF4-FFF2-40B4-BE49-F238E27FC236}">
-                <a16:creationId xmlns:a16="http://schemas.microsoft.com/office/drawing/2014/main" id="{7CA460F1-E8B6-4A07-B3B5-99DBB304DBB1}"/>
+                <a16:creationId xmlns:a16="http://schemas.microsoft.com/office/drawing/2014/main" id="{F6516D62-EA0F-4982-BF1F-0F8B5C8C53B8}"/>
               </a:ext>
             </a:extLst>
           </p:cNvPr>
@@ -7644,7 +7644,7 @@
           <p:cNvPr id="9" name="">
             <a:extLst xmlns:a="http://schemas.openxmlformats.org/drawingml/2006/main">
               <a:ext uri="{FF2B5EF4-FFF2-40B4-BE49-F238E27FC236}">
-                <a16:creationId xmlns:a16="http://schemas.microsoft.com/office/drawing/2014/main" id="{1B9F85A3-5AD5-4CCF-81B3-65C62C50DAA1}"/>
+                <a16:creationId xmlns:a16="http://schemas.microsoft.com/office/drawing/2014/main" id="{88A40EE0-ECCD-4BEE-8F9C-636218BEDDDB}"/>
               </a:ext>
             </a:extLst>
           </p:cNvPr>
@@ -7764,7 +7764,7 @@
           <p:cNvPr id="10" name="">
             <a:extLst xmlns:a="http://schemas.openxmlformats.org/drawingml/2006/main">
               <a:ext uri="{FF2B5EF4-FFF2-40B4-BE49-F238E27FC236}">
-                <a16:creationId xmlns:a16="http://schemas.microsoft.com/office/drawing/2014/main" id="{AB57A151-6793-4D96-B9F2-A322D7685238}"/>
+                <a16:creationId xmlns:a16="http://schemas.microsoft.com/office/drawing/2014/main" id="{81639631-78D8-43E3-AD1D-5D2A20884606}"/>
               </a:ext>
             </a:extLst>
           </p:cNvPr>
@@ -7884,7 +7884,7 @@
           <p:cNvPr id="11" name="">
             <a:extLst xmlns:a="http://schemas.openxmlformats.org/drawingml/2006/main">
               <a:ext uri="{FF2B5EF4-FFF2-40B4-BE49-F238E27FC236}">
-                <a16:creationId xmlns:a16="http://schemas.microsoft.com/office/drawing/2014/main" id="{FFB10BF4-7594-4119-BCEA-2D725A6A4C69}"/>
+                <a16:creationId xmlns:a16="http://schemas.microsoft.com/office/drawing/2014/main" id="{AB3AC2DF-31F2-4233-A78B-FFE2E1A9A322}"/>
               </a:ext>
             </a:extLst>
           </p:cNvPr>
@@ -7916,7 +7916,7 @@
           <p:cNvPr id="12" name="">
             <a:extLst xmlns:a="http://schemas.openxmlformats.org/drawingml/2006/main">
               <a:ext uri="{FF2B5EF4-FFF2-40B4-BE49-F238E27FC236}">
-                <a16:creationId xmlns:a16="http://schemas.microsoft.com/office/drawing/2014/main" id="{02543CD5-0723-4968-B458-0FC75B922F5A}"/>
+                <a16:creationId xmlns:a16="http://schemas.microsoft.com/office/drawing/2014/main" id="{9467E38E-BD9F-4F03-87DC-027CCFB79A42}"/>
               </a:ext>
             </a:extLst>
           </p:cNvPr>
@@ -8036,7 +8036,7 @@
           <p:cNvPr id="13" name="">
             <a:extLst xmlns:a="http://schemas.openxmlformats.org/drawingml/2006/main">
               <a:ext uri="{FF2B5EF4-FFF2-40B4-BE49-F238E27FC236}">
-                <a16:creationId xmlns:a16="http://schemas.microsoft.com/office/drawing/2014/main" id="{D29F55EB-6873-4FC2-8DAE-279B182BE6E3}"/>
+                <a16:creationId xmlns:a16="http://schemas.microsoft.com/office/drawing/2014/main" id="{4E5905C5-C57E-4D00-94F5-F9A945715DA8}"/>
               </a:ext>
             </a:extLst>
           </p:cNvPr>
@@ -8156,7 +8156,7 @@
           <p:cNvPr id="14" name="">
             <a:extLst xmlns:a="http://schemas.openxmlformats.org/drawingml/2006/main">
               <a:ext uri="{FF2B5EF4-FFF2-40B4-BE49-F238E27FC236}">
-                <a16:creationId xmlns:a16="http://schemas.microsoft.com/office/drawing/2014/main" id="{9D4149E5-A11B-4034-99B8-9349D1B5CAFF}"/>
+                <a16:creationId xmlns:a16="http://schemas.microsoft.com/office/drawing/2014/main" id="{7DF92E7F-3159-4618-A6A7-0A9059CDE9EF}"/>
               </a:ext>
             </a:extLst>
           </p:cNvPr>
@@ -8188,7 +8188,7 @@
           <p:cNvPr id="15" name="">
             <a:extLst xmlns:a="http://schemas.openxmlformats.org/drawingml/2006/main">
               <a:ext uri="{FF2B5EF4-FFF2-40B4-BE49-F238E27FC236}">
-                <a16:creationId xmlns:a16="http://schemas.microsoft.com/office/drawing/2014/main" id="{F7A5CD2A-5D73-4B42-8FFF-5C88CF45CE53}"/>
+                <a16:creationId xmlns:a16="http://schemas.microsoft.com/office/drawing/2014/main" id="{2F1E0A70-9385-4F9E-B77A-12114FD1B31E}"/>
               </a:ext>
             </a:extLst>
           </p:cNvPr>
@@ -8308,7 +8308,7 @@
           <p:cNvPr id="16" name="">
             <a:extLst xmlns:a="http://schemas.openxmlformats.org/drawingml/2006/main">
               <a:ext uri="{FF2B5EF4-FFF2-40B4-BE49-F238E27FC236}">
-                <a16:creationId xmlns:a16="http://schemas.microsoft.com/office/drawing/2014/main" id="{1C7CF3B8-68C0-45D2-A97D-E43678A335E7}"/>
+                <a16:creationId xmlns:a16="http://schemas.microsoft.com/office/drawing/2014/main" id="{D5D94F4B-0602-4373-98F0-D51E33156A22}"/>
               </a:ext>
             </a:extLst>
           </p:cNvPr>
@@ -8428,7 +8428,7 @@
           <p:cNvPr id="17" name="">
             <a:extLst xmlns:a="http://schemas.openxmlformats.org/drawingml/2006/main">
               <a:ext uri="{FF2B5EF4-FFF2-40B4-BE49-F238E27FC236}">
-                <a16:creationId xmlns:a16="http://schemas.microsoft.com/office/drawing/2014/main" id="{F10A0146-7F2B-49CD-B55C-D6E274A85D7C}"/>
+                <a16:creationId xmlns:a16="http://schemas.microsoft.com/office/drawing/2014/main" id="{6ED58F73-6B90-418B-953E-D9AF1DC824A7}"/>
               </a:ext>
             </a:extLst>
           </p:cNvPr>
@@ -8460,7 +8460,7 @@
           <p:cNvPr id="18" name="">
             <a:extLst xmlns:a="http://schemas.openxmlformats.org/drawingml/2006/main">
               <a:ext uri="{FF2B5EF4-FFF2-40B4-BE49-F238E27FC236}">
-                <a16:creationId xmlns:a16="http://schemas.microsoft.com/office/drawing/2014/main" id="{4545F679-654F-49C1-9598-6FCA28A3183F}"/>
+                <a16:creationId xmlns:a16="http://schemas.microsoft.com/office/drawing/2014/main" id="{F841D768-DC2E-47FC-A462-1B6BBD1A9BC6}"/>
               </a:ext>
             </a:extLst>
           </p:cNvPr>
@@ -8580,7 +8580,7 @@
           <p:cNvPr id="19" name="">
             <a:extLst xmlns:a="http://schemas.openxmlformats.org/drawingml/2006/main">
               <a:ext uri="{FF2B5EF4-FFF2-40B4-BE49-F238E27FC236}">
-                <a16:creationId xmlns:a16="http://schemas.microsoft.com/office/drawing/2014/main" id="{5C52B801-18DE-4C8B-A20A-D412E7156458}"/>
+                <a16:creationId xmlns:a16="http://schemas.microsoft.com/office/drawing/2014/main" id="{D07D275D-FBD2-417C-89A8-372359F3A210}"/>
               </a:ext>
             </a:extLst>
           </p:cNvPr>
@@ -8700,7 +8700,7 @@
           <p:cNvPr id="20" name="">
             <a:extLst xmlns:a="http://schemas.openxmlformats.org/drawingml/2006/main">
               <a:ext uri="{FF2B5EF4-FFF2-40B4-BE49-F238E27FC236}">
-                <a16:creationId xmlns:a16="http://schemas.microsoft.com/office/drawing/2014/main" id="{D950DE4B-7A6A-4957-A515-84BF9DE1D244}"/>
+                <a16:creationId xmlns:a16="http://schemas.microsoft.com/office/drawing/2014/main" id="{26BD2C0E-A978-4359-BF12-6BB4439ED2B9}"/>
               </a:ext>
             </a:extLst>
           </p:cNvPr>
@@ -8730,7 +8730,7 @@
           <p:cNvPr id="21" name="">
             <a:extLst xmlns:a="http://schemas.openxmlformats.org/drawingml/2006/main">
               <a:ext uri="{FF2B5EF4-FFF2-40B4-BE49-F238E27FC236}">
-                <a16:creationId xmlns:a16="http://schemas.microsoft.com/office/drawing/2014/main" id="{BEACD425-AE04-4627-81CF-9ADC82821E13}"/>
+                <a16:creationId xmlns:a16="http://schemas.microsoft.com/office/drawing/2014/main" id="{10E3A47E-DE21-487A-9350-53AC510A249D}"/>
               </a:ext>
             </a:extLst>
           </p:cNvPr>
@@ -8760,7 +8760,7 @@
           <p:cNvPr id="22" name="">
             <a:extLst xmlns:a="http://schemas.openxmlformats.org/drawingml/2006/main">
               <a:ext uri="{FF2B5EF4-FFF2-40B4-BE49-F238E27FC236}">
-                <a16:creationId xmlns:a16="http://schemas.microsoft.com/office/drawing/2014/main" id="{2BD49840-7D3E-48FF-ABBA-CC0C27D9C7F8}"/>
+                <a16:creationId xmlns:a16="http://schemas.microsoft.com/office/drawing/2014/main" id="{447A7FD1-84E7-4DB6-B243-7C9E5C0A7D4E}"/>
               </a:ext>
             </a:extLst>
           </p:cNvPr>
@@ -8790,7 +8790,7 @@
           <p:cNvPr id="23" name="">
             <a:extLst xmlns:a="http://schemas.openxmlformats.org/drawingml/2006/main">
               <a:ext uri="{FF2B5EF4-FFF2-40B4-BE49-F238E27FC236}">
-                <a16:creationId xmlns:a16="http://schemas.microsoft.com/office/drawing/2014/main" id="{5A5E1470-1627-42D3-85AD-DDCD71314A6E}"/>
+                <a16:creationId xmlns:a16="http://schemas.microsoft.com/office/drawing/2014/main" id="{4A787DB3-B319-4FCD-AEE5-238472697B0B}"/>
               </a:ext>
             </a:extLst>
           </p:cNvPr>
@@ -8820,7 +8820,7 @@
           <p:cNvPr id="24" name="">
             <a:extLst xmlns:a="http://schemas.openxmlformats.org/drawingml/2006/main">
               <a:ext uri="{FF2B5EF4-FFF2-40B4-BE49-F238E27FC236}">
-                <a16:creationId xmlns:a16="http://schemas.microsoft.com/office/drawing/2014/main" id="{8BAA3C1D-C3B2-48FE-9ED7-038B86C427F8}"/>
+                <a16:creationId xmlns:a16="http://schemas.microsoft.com/office/drawing/2014/main" id="{84B6CA45-8744-40F5-B3B2-EEA9EAB7E35D}"/>
               </a:ext>
             </a:extLst>
           </p:cNvPr>
@@ -8852,7 +8852,7 @@
           <p:cNvPr id="25" name="">
             <a:extLst xmlns:a="http://schemas.openxmlformats.org/drawingml/2006/main">
               <a:ext uri="{FF2B5EF4-FFF2-40B4-BE49-F238E27FC236}">
-                <a16:creationId xmlns:a16="http://schemas.microsoft.com/office/drawing/2014/main" id="{D2EDC68B-F7D0-47AF-BB22-FFF126495E04}"/>
+                <a16:creationId xmlns:a16="http://schemas.microsoft.com/office/drawing/2014/main" id="{0E74FED3-D454-49A4-B7FC-1345B4E09DB0}"/>
               </a:ext>
             </a:extLst>
           </p:cNvPr>
@@ -8972,7 +8972,7 @@
           <p:cNvPr id="26" name="">
             <a:extLst xmlns:a="http://schemas.openxmlformats.org/drawingml/2006/main">
               <a:ext uri="{FF2B5EF4-FFF2-40B4-BE49-F238E27FC236}">
-                <a16:creationId xmlns:a16="http://schemas.microsoft.com/office/drawing/2014/main" id="{B57E80A1-5C84-4A39-9D5A-458581B27997}"/>
+                <a16:creationId xmlns:a16="http://schemas.microsoft.com/office/drawing/2014/main" id="{C6320E43-E423-44D4-A875-50D386D36A69}"/>
               </a:ext>
             </a:extLst>
           </p:cNvPr>
@@ -9092,7 +9092,7 @@
           <p:cNvPr id="27" name="">
             <a:extLst xmlns:a="http://schemas.openxmlformats.org/drawingml/2006/main">
               <a:ext uri="{FF2B5EF4-FFF2-40B4-BE49-F238E27FC236}">
-                <a16:creationId xmlns:a16="http://schemas.microsoft.com/office/drawing/2014/main" id="{C059DFC3-604C-4563-A31B-80B4AA37B82D}"/>
+                <a16:creationId xmlns:a16="http://schemas.microsoft.com/office/drawing/2014/main" id="{BAA6CD58-1331-4327-84DD-DC4477EE2B28}"/>
               </a:ext>
             </a:extLst>
           </p:cNvPr>
@@ -9212,7 +9212,7 @@
           <p:cNvPr id="28" name="">
             <a:extLst xmlns:a="http://schemas.openxmlformats.org/drawingml/2006/main">
               <a:ext uri="{FF2B5EF4-FFF2-40B4-BE49-F238E27FC236}">
-                <a16:creationId xmlns:a16="http://schemas.microsoft.com/office/drawing/2014/main" id="{FDC850A4-A144-416A-96AA-220804E548E3}"/>
+                <a16:creationId xmlns:a16="http://schemas.microsoft.com/office/drawing/2014/main" id="{CBE0AA0E-6C7B-4B79-A207-08C1096E4972}"/>
               </a:ext>
             </a:extLst>
           </p:cNvPr>
@@ -9332,7 +9332,7 @@
           <p:cNvPr id="29" name="">
             <a:extLst xmlns:a="http://schemas.openxmlformats.org/drawingml/2006/main">
               <a:ext uri="{FF2B5EF4-FFF2-40B4-BE49-F238E27FC236}">
-                <a16:creationId xmlns:a16="http://schemas.microsoft.com/office/drawing/2014/main" id="{09BD8EB9-66CD-4F46-8E88-6B57FF1DA104}"/>
+                <a16:creationId xmlns:a16="http://schemas.microsoft.com/office/drawing/2014/main" id="{29B62AC1-54F3-4A71-A277-E94BCBFA9747}"/>
               </a:ext>
             </a:extLst>
           </p:cNvPr>
@@ -9360,7 +9360,7 @@
     </p:spTree>
     <p:extLst>
       <p:ext uri="{BB962C8B-B14F-4D97-AF65-F5344CB8AC3E}">
-        <p14:creationId xmlns:p14="http://schemas.microsoft.com/office/powerpoint/2010/main" val="1923755877"/>
+        <p14:creationId xmlns:p14="http://schemas.microsoft.com/office/powerpoint/2010/main" val="1242536349"/>
       </p:ext>
     </p:extLst>
   </p:cSld>
@@ -9391,7 +9391,7 @@
           <p:cNvPr id="31" name="">
             <a:extLst xmlns:a="http://schemas.openxmlformats.org/drawingml/2006/main">
               <a:ext uri="{FF2B5EF4-FFF2-40B4-BE49-F238E27FC236}">
-                <a16:creationId xmlns:a16="http://schemas.microsoft.com/office/drawing/2014/main" id="{1ED1C508-DB71-4F7D-86DE-FDA5D743647E}"/>
+                <a16:creationId xmlns:a16="http://schemas.microsoft.com/office/drawing/2014/main" id="{EBED8FA5-835A-481B-A469-7CFF226E8B66}"/>
               </a:ext>
             </a:extLst>
           </p:cNvPr>
@@ -9421,7 +9421,7 @@
           <p:cNvPr id="2" name="">
             <a:extLst xmlns:a="http://schemas.openxmlformats.org/drawingml/2006/main">
               <a:ext uri="{FF2B5EF4-FFF2-40B4-BE49-F238E27FC236}">
-                <a16:creationId xmlns:a16="http://schemas.microsoft.com/office/drawing/2014/main" id="{C81CEFEC-0F2B-49E1-BC4A-1164E0C625C4}"/>
+                <a16:creationId xmlns:a16="http://schemas.microsoft.com/office/drawing/2014/main" id="{9316B0EA-843B-41EF-AE64-09EFBA1B7523}"/>
               </a:ext>
             </a:extLst>
           </p:cNvPr>
@@ -9541,7 +9541,7 @@
           <p:cNvPr id="3" name="">
             <a:extLst xmlns:a="http://schemas.openxmlformats.org/drawingml/2006/main">
               <a:ext uri="{FF2B5EF4-FFF2-40B4-BE49-F238E27FC236}">
-                <a16:creationId xmlns:a16="http://schemas.microsoft.com/office/drawing/2014/main" id="{C4C17403-2E3C-4C92-8AF0-82A7059B6C24}"/>
+                <a16:creationId xmlns:a16="http://schemas.microsoft.com/office/drawing/2014/main" id="{8AEFF20D-BFD7-413A-9745-E52E8DEDFFD7}"/>
               </a:ext>
             </a:extLst>
           </p:cNvPr>
@@ -9661,7 +9661,7 @@
           <p:cNvPr id="4" name="">
             <a:extLst xmlns:a="http://schemas.openxmlformats.org/drawingml/2006/main">
               <a:ext uri="{FF2B5EF4-FFF2-40B4-BE49-F238E27FC236}">
-                <a16:creationId xmlns:a16="http://schemas.microsoft.com/office/drawing/2014/main" id="{B45F2255-1BAA-4311-9E44-3075B5F6FBE8}"/>
+                <a16:creationId xmlns:a16="http://schemas.microsoft.com/office/drawing/2014/main" id="{72FFF8E8-FCB3-45AF-B687-832BD9079A0C}"/>
               </a:ext>
             </a:extLst>
           </p:cNvPr>
@@ -9781,7 +9781,7 @@
           <p:cNvPr id="5" name="">
             <a:extLst xmlns:a="http://schemas.openxmlformats.org/drawingml/2006/main">
               <a:ext uri="{FF2B5EF4-FFF2-40B4-BE49-F238E27FC236}">
-                <a16:creationId xmlns:a16="http://schemas.microsoft.com/office/drawing/2014/main" id="{07060A11-95B8-4DD5-87CA-A59E6391994D}"/>
+                <a16:creationId xmlns:a16="http://schemas.microsoft.com/office/drawing/2014/main" id="{72B21B57-5CDA-4584-863A-FFCC3966EC1A}"/>
               </a:ext>
             </a:extLst>
           </p:cNvPr>
@@ -9813,7 +9813,7 @@
           <p:cNvPr id="6" name="">
             <a:extLst xmlns:a="http://schemas.openxmlformats.org/drawingml/2006/main">
               <a:ext uri="{FF2B5EF4-FFF2-40B4-BE49-F238E27FC236}">
-                <a16:creationId xmlns:a16="http://schemas.microsoft.com/office/drawing/2014/main" id="{AFFA5EA5-8490-4BFB-B3C0-B56B6D31DC50}"/>
+                <a16:creationId xmlns:a16="http://schemas.microsoft.com/office/drawing/2014/main" id="{0E479E1A-B716-4966-A6B2-4A8CE27CB45B}"/>
               </a:ext>
             </a:extLst>
           </p:cNvPr>
@@ -9933,7 +9933,7 @@
           <p:cNvPr id="7" name="">
             <a:extLst xmlns:a="http://schemas.openxmlformats.org/drawingml/2006/main">
               <a:ext uri="{FF2B5EF4-FFF2-40B4-BE49-F238E27FC236}">
-                <a16:creationId xmlns:a16="http://schemas.microsoft.com/office/drawing/2014/main" id="{5A986B99-98BB-41A6-B229-034CDFC01305}"/>
+                <a16:creationId xmlns:a16="http://schemas.microsoft.com/office/drawing/2014/main" id="{74CA6DFC-7171-4398-9178-931A414FF7B1}"/>
               </a:ext>
             </a:extLst>
           </p:cNvPr>
@@ -9965,7 +9965,7 @@
           <p:cNvPr id="8" name="">
             <a:extLst xmlns:a="http://schemas.openxmlformats.org/drawingml/2006/main">
               <a:ext uri="{FF2B5EF4-FFF2-40B4-BE49-F238E27FC236}">
-                <a16:creationId xmlns:a16="http://schemas.microsoft.com/office/drawing/2014/main" id="{DE72D55F-77BA-4BE0-8231-4D4FB9EEC699}"/>
+                <a16:creationId xmlns:a16="http://schemas.microsoft.com/office/drawing/2014/main" id="{6C7120CD-873F-40E3-A205-A0C668E1A517}"/>
               </a:ext>
             </a:extLst>
           </p:cNvPr>
@@ -10085,7 +10085,7 @@
           <p:cNvPr id="9" name="">
             <a:extLst xmlns:a="http://schemas.openxmlformats.org/drawingml/2006/main">
               <a:ext uri="{FF2B5EF4-FFF2-40B4-BE49-F238E27FC236}">
-                <a16:creationId xmlns:a16="http://schemas.microsoft.com/office/drawing/2014/main" id="{32623271-F8D8-4178-A43C-8FE81A4ADFCA}"/>
+                <a16:creationId xmlns:a16="http://schemas.microsoft.com/office/drawing/2014/main" id="{A9557755-553B-4206-9204-7CEEA16306D9}"/>
               </a:ext>
             </a:extLst>
           </p:cNvPr>
@@ -10117,7 +10117,7 @@
           <p:cNvPr id="10" name="">
             <a:extLst xmlns:a="http://schemas.openxmlformats.org/drawingml/2006/main">
               <a:ext uri="{FF2B5EF4-FFF2-40B4-BE49-F238E27FC236}">
-                <a16:creationId xmlns:a16="http://schemas.microsoft.com/office/drawing/2014/main" id="{1B5F7587-2021-422F-B600-556D456CCE2A}"/>
+                <a16:creationId xmlns:a16="http://schemas.microsoft.com/office/drawing/2014/main" id="{FC034B02-F5B0-4A20-A317-76BEC07F6CA9}"/>
               </a:ext>
             </a:extLst>
           </p:cNvPr>
@@ -10237,7 +10237,7 @@
           <p:cNvPr id="11" name="">
             <a:extLst xmlns:a="http://schemas.openxmlformats.org/drawingml/2006/main">
               <a:ext uri="{FF2B5EF4-FFF2-40B4-BE49-F238E27FC236}">
-                <a16:creationId xmlns:a16="http://schemas.microsoft.com/office/drawing/2014/main" id="{2C6D04AE-8284-4493-8B27-F28714891C62}"/>
+                <a16:creationId xmlns:a16="http://schemas.microsoft.com/office/drawing/2014/main" id="{6A6997AE-DC40-4842-A437-51439C444C11}"/>
               </a:ext>
             </a:extLst>
           </p:cNvPr>
@@ -10269,7 +10269,7 @@
           <p:cNvPr id="12" name="">
             <a:extLst xmlns:a="http://schemas.openxmlformats.org/drawingml/2006/main">
               <a:ext uri="{FF2B5EF4-FFF2-40B4-BE49-F238E27FC236}">
-                <a16:creationId xmlns:a16="http://schemas.microsoft.com/office/drawing/2014/main" id="{3F320BC8-44DC-4575-AEDE-C4A88A85871A}"/>
+                <a16:creationId xmlns:a16="http://schemas.microsoft.com/office/drawing/2014/main" id="{5AF87F87-D88D-4B87-B8D2-5085E8CE8565}"/>
               </a:ext>
             </a:extLst>
           </p:cNvPr>
@@ -10389,7 +10389,7 @@
           <p:cNvPr id="13" name="">
             <a:extLst xmlns:a="http://schemas.openxmlformats.org/drawingml/2006/main">
               <a:ext uri="{FF2B5EF4-FFF2-40B4-BE49-F238E27FC236}">
-                <a16:creationId xmlns:a16="http://schemas.microsoft.com/office/drawing/2014/main" id="{9230472B-2822-4670-B104-CD68506F4B3C}"/>
+                <a16:creationId xmlns:a16="http://schemas.microsoft.com/office/drawing/2014/main" id="{BC901589-FC00-407A-9972-417CD1E819E0}"/>
               </a:ext>
             </a:extLst>
           </p:cNvPr>
@@ -10421,7 +10421,7 @@
           <p:cNvPr id="14" name="">
             <a:extLst xmlns:a="http://schemas.openxmlformats.org/drawingml/2006/main">
               <a:ext uri="{FF2B5EF4-FFF2-40B4-BE49-F238E27FC236}">
-                <a16:creationId xmlns:a16="http://schemas.microsoft.com/office/drawing/2014/main" id="{FECA8F87-C98E-41FC-BFEC-6A535D798ADD}"/>
+                <a16:creationId xmlns:a16="http://schemas.microsoft.com/office/drawing/2014/main" id="{23D4BBC1-4E14-4391-A6D4-A3A22BD34C75}"/>
               </a:ext>
             </a:extLst>
           </p:cNvPr>
@@ -10541,7 +10541,7 @@
           <p:cNvPr id="15" name="">
             <a:extLst xmlns:a="http://schemas.openxmlformats.org/drawingml/2006/main">
               <a:ext uri="{FF2B5EF4-FFF2-40B4-BE49-F238E27FC236}">
-                <a16:creationId xmlns:a16="http://schemas.microsoft.com/office/drawing/2014/main" id="{A5BE1EA0-8381-4D7A-B194-5F69B78A7BEB}"/>
+                <a16:creationId xmlns:a16="http://schemas.microsoft.com/office/drawing/2014/main" id="{3137BD13-8230-41DF-8C89-CC03E49FB091}"/>
               </a:ext>
             </a:extLst>
           </p:cNvPr>
@@ -10573,7 +10573,7 @@
           <p:cNvPr id="16" name="">
             <a:extLst xmlns:a="http://schemas.openxmlformats.org/drawingml/2006/main">
               <a:ext uri="{FF2B5EF4-FFF2-40B4-BE49-F238E27FC236}">
-                <a16:creationId xmlns:a16="http://schemas.microsoft.com/office/drawing/2014/main" id="{EC181D70-1DB6-4B0A-A2BC-29E6D86DADCD}"/>
+                <a16:creationId xmlns:a16="http://schemas.microsoft.com/office/drawing/2014/main" id="{59124A0E-E5E6-45F4-969C-952725609D35}"/>
               </a:ext>
             </a:extLst>
           </p:cNvPr>
@@ -10693,7 +10693,7 @@
           <p:cNvPr id="17" name="">
             <a:extLst xmlns:a="http://schemas.openxmlformats.org/drawingml/2006/main">
               <a:ext uri="{FF2B5EF4-FFF2-40B4-BE49-F238E27FC236}">
-                <a16:creationId xmlns:a16="http://schemas.microsoft.com/office/drawing/2014/main" id="{18291A20-E6DA-4D38-ADEE-ECB0465C9538}"/>
+                <a16:creationId xmlns:a16="http://schemas.microsoft.com/office/drawing/2014/main" id="{60B4EEAB-BFBA-4984-B493-4C3FE25A4532}"/>
               </a:ext>
             </a:extLst>
           </p:cNvPr>
@@ -10725,7 +10725,7 @@
           <p:cNvPr id="18" name="">
             <a:extLst xmlns:a="http://schemas.openxmlformats.org/drawingml/2006/main">
               <a:ext uri="{FF2B5EF4-FFF2-40B4-BE49-F238E27FC236}">
-                <a16:creationId xmlns:a16="http://schemas.microsoft.com/office/drawing/2014/main" id="{0B19EF3E-F1B7-411E-B5D5-D5F9EDE1A11D}"/>
+                <a16:creationId xmlns:a16="http://schemas.microsoft.com/office/drawing/2014/main" id="{6CC35FDF-7C6A-4E55-861D-C2E69350CF8F}"/>
               </a:ext>
             </a:extLst>
           </p:cNvPr>
@@ -10845,7 +10845,7 @@
           <p:cNvPr id="19" name="">
             <a:extLst xmlns:a="http://schemas.openxmlformats.org/drawingml/2006/main">
               <a:ext uri="{FF2B5EF4-FFF2-40B4-BE49-F238E27FC236}">
-                <a16:creationId xmlns:a16="http://schemas.microsoft.com/office/drawing/2014/main" id="{15CC5618-7E82-4C1F-9892-EA0710B15783}"/>
+                <a16:creationId xmlns:a16="http://schemas.microsoft.com/office/drawing/2014/main" id="{6E9BBF7A-B2C1-40A6-BAEE-BC1626ADB755}"/>
               </a:ext>
             </a:extLst>
           </p:cNvPr>
@@ -10877,7 +10877,7 @@
           <p:cNvPr id="20" name="">
             <a:extLst xmlns:a="http://schemas.openxmlformats.org/drawingml/2006/main">
               <a:ext uri="{FF2B5EF4-FFF2-40B4-BE49-F238E27FC236}">
-                <a16:creationId xmlns:a16="http://schemas.microsoft.com/office/drawing/2014/main" id="{A5AF7C16-B278-4404-B5DE-C9FB332BCBA6}"/>
+                <a16:creationId xmlns:a16="http://schemas.microsoft.com/office/drawing/2014/main" id="{1E8F841F-F8AE-4C72-93F4-B76747722723}"/>
               </a:ext>
             </a:extLst>
           </p:cNvPr>
@@ -10997,7 +10997,7 @@
           <p:cNvPr id="21" name="">
             <a:extLst xmlns:a="http://schemas.openxmlformats.org/drawingml/2006/main">
               <a:ext uri="{FF2B5EF4-FFF2-40B4-BE49-F238E27FC236}">
-                <a16:creationId xmlns:a16="http://schemas.microsoft.com/office/drawing/2014/main" id="{A4169761-A384-4DF2-9B12-91F623E5B12E}"/>
+                <a16:creationId xmlns:a16="http://schemas.microsoft.com/office/drawing/2014/main" id="{FA238EE9-9F5E-4E25-B585-28161C9EE038}"/>
               </a:ext>
             </a:extLst>
           </p:cNvPr>
@@ -11029,7 +11029,7 @@
           <p:cNvPr id="22" name="">
             <a:extLst xmlns:a="http://schemas.openxmlformats.org/drawingml/2006/main">
               <a:ext uri="{FF2B5EF4-FFF2-40B4-BE49-F238E27FC236}">
-                <a16:creationId xmlns:a16="http://schemas.microsoft.com/office/drawing/2014/main" id="{EE5D8F6B-FE61-417A-B61A-7D4B123C1A39}"/>
+                <a16:creationId xmlns:a16="http://schemas.microsoft.com/office/drawing/2014/main" id="{C8730A41-FA7A-44DC-A2B2-203A67C86D13}"/>
               </a:ext>
             </a:extLst>
           </p:cNvPr>
@@ -11149,7 +11149,7 @@
           <p:cNvPr id="23" name="">
             <a:extLst xmlns:a="http://schemas.openxmlformats.org/drawingml/2006/main">
               <a:ext uri="{FF2B5EF4-FFF2-40B4-BE49-F238E27FC236}">
-                <a16:creationId xmlns:a16="http://schemas.microsoft.com/office/drawing/2014/main" id="{3128BCE0-463D-495F-84FE-7861411D6DE5}"/>
+                <a16:creationId xmlns:a16="http://schemas.microsoft.com/office/drawing/2014/main" id="{DA9EE11C-4A74-4467-B63F-51711DAAB075}"/>
               </a:ext>
             </a:extLst>
           </p:cNvPr>
@@ -11181,7 +11181,7 @@
           <p:cNvPr id="24" name="">
             <a:extLst xmlns:a="http://schemas.openxmlformats.org/drawingml/2006/main">
               <a:ext uri="{FF2B5EF4-FFF2-40B4-BE49-F238E27FC236}">
-                <a16:creationId xmlns:a16="http://schemas.microsoft.com/office/drawing/2014/main" id="{F8592549-7E3F-4528-A7B7-01FAC5D6C5D4}"/>
+                <a16:creationId xmlns:a16="http://schemas.microsoft.com/office/drawing/2014/main" id="{A97151FC-323A-46DB-91A9-7AB5E74C25CB}"/>
               </a:ext>
             </a:extLst>
           </p:cNvPr>
@@ -11301,7 +11301,7 @@
           <p:cNvPr id="25" name="">
             <a:extLst xmlns:a="http://schemas.openxmlformats.org/drawingml/2006/main">
               <a:ext uri="{FF2B5EF4-FFF2-40B4-BE49-F238E27FC236}">
-                <a16:creationId xmlns:a16="http://schemas.microsoft.com/office/drawing/2014/main" id="{C5A3EABF-4733-489F-8B52-F42000FD5D17}"/>
+                <a16:creationId xmlns:a16="http://schemas.microsoft.com/office/drawing/2014/main" id="{D12AE2A1-AF42-4BB3-8D0C-B906005D4C33}"/>
               </a:ext>
             </a:extLst>
           </p:cNvPr>
@@ -11333,7 +11333,7 @@
           <p:cNvPr id="26" name="">
             <a:extLst xmlns:a="http://schemas.openxmlformats.org/drawingml/2006/main">
               <a:ext uri="{FF2B5EF4-FFF2-40B4-BE49-F238E27FC236}">
-                <a16:creationId xmlns:a16="http://schemas.microsoft.com/office/drawing/2014/main" id="{D17600F8-6F98-4C1C-A939-6F53B0BD156D}"/>
+                <a16:creationId xmlns:a16="http://schemas.microsoft.com/office/drawing/2014/main" id="{55106ED1-6CAE-427D-AD0B-D0D062337E3C}"/>
               </a:ext>
             </a:extLst>
           </p:cNvPr>
@@ -11453,7 +11453,7 @@
           <p:cNvPr id="27" name="">
             <a:extLst xmlns:a="http://schemas.openxmlformats.org/drawingml/2006/main">
               <a:ext uri="{FF2B5EF4-FFF2-40B4-BE49-F238E27FC236}">
-                <a16:creationId xmlns:a16="http://schemas.microsoft.com/office/drawing/2014/main" id="{0DAD8E5B-A410-446A-8E67-76E749BA6507}"/>
+                <a16:creationId xmlns:a16="http://schemas.microsoft.com/office/drawing/2014/main" id="{98A8837A-B92E-43EC-9460-712F6CCC7B24}"/>
               </a:ext>
             </a:extLst>
           </p:cNvPr>
@@ -11485,7 +11485,7 @@
           <p:cNvPr id="28" name="">
             <a:extLst xmlns:a="http://schemas.openxmlformats.org/drawingml/2006/main">
               <a:ext uri="{FF2B5EF4-FFF2-40B4-BE49-F238E27FC236}">
-                <a16:creationId xmlns:a16="http://schemas.microsoft.com/office/drawing/2014/main" id="{5BEC5EB4-9FD2-4089-A7C4-E44C5F9C3205}"/>
+                <a16:creationId xmlns:a16="http://schemas.microsoft.com/office/drawing/2014/main" id="{9F03B6F2-DBFD-4EFD-8D98-5B80CD90FF7C}"/>
               </a:ext>
             </a:extLst>
           </p:cNvPr>
@@ -11605,7 +11605,7 @@
           <p:cNvPr id="29" name="">
             <a:extLst xmlns:a="http://schemas.openxmlformats.org/drawingml/2006/main">
               <a:ext uri="{FF2B5EF4-FFF2-40B4-BE49-F238E27FC236}">
-                <a16:creationId xmlns:a16="http://schemas.microsoft.com/office/drawing/2014/main" id="{060CC1F4-0732-487C-AEFD-C9D644CBD2BB}"/>
+                <a16:creationId xmlns:a16="http://schemas.microsoft.com/office/drawing/2014/main" id="{397539D1-AB43-4A91-BDBC-CCF3F5795291}"/>
               </a:ext>
             </a:extLst>
           </p:cNvPr>
@@ -11725,7 +11725,7 @@
           <p:cNvPr id="30" name="">
             <a:extLst xmlns:a="http://schemas.openxmlformats.org/drawingml/2006/main">
               <a:ext uri="{FF2B5EF4-FFF2-40B4-BE49-F238E27FC236}">
-                <a16:creationId xmlns:a16="http://schemas.microsoft.com/office/drawing/2014/main" id="{44DCCA54-C120-4CB0-AEC7-6816E7489CE5}"/>
+                <a16:creationId xmlns:a16="http://schemas.microsoft.com/office/drawing/2014/main" id="{B9C98244-3834-451C-8E1C-25D555CC6B9E}"/>
               </a:ext>
             </a:extLst>
           </p:cNvPr>
@@ -11843,7 +11843,7 @@
     </p:spTree>
     <p:extLst>
       <p:ext uri="{BB962C8B-B14F-4D97-AF65-F5344CB8AC3E}">
-        <p14:creationId xmlns:p14="http://schemas.microsoft.com/office/powerpoint/2010/main" val="532432880"/>
+        <p14:creationId xmlns:p14="http://schemas.microsoft.com/office/powerpoint/2010/main" val="1384427802"/>
       </p:ext>
     </p:extLst>
   </p:cSld>
@@ -11874,7 +11874,7 @@
           <p:cNvPr id="26" name="">
             <a:extLst xmlns:a="http://schemas.openxmlformats.org/drawingml/2006/main">
               <a:ext uri="{FF2B5EF4-FFF2-40B4-BE49-F238E27FC236}">
-                <a16:creationId xmlns:a16="http://schemas.microsoft.com/office/drawing/2014/main" id="{84711FCA-D01D-468B-A81A-A99F9E508BF5}"/>
+                <a16:creationId xmlns:a16="http://schemas.microsoft.com/office/drawing/2014/main" id="{AB5AF0F5-66EC-4385-A526-BA0899AD4AD3}"/>
               </a:ext>
             </a:extLst>
           </p:cNvPr>
@@ -11904,7 +11904,7 @@
           <p:cNvPr id="2" name="">
             <a:extLst xmlns:a="http://schemas.openxmlformats.org/drawingml/2006/main">
               <a:ext uri="{FF2B5EF4-FFF2-40B4-BE49-F238E27FC236}">
-                <a16:creationId xmlns:a16="http://schemas.microsoft.com/office/drawing/2014/main" id="{4ABBAD02-16A6-4282-9E77-B8A111BD6240}"/>
+                <a16:creationId xmlns:a16="http://schemas.microsoft.com/office/drawing/2014/main" id="{804F9EF8-A61B-42E1-8735-007A10E774A2}"/>
               </a:ext>
             </a:extLst>
           </p:cNvPr>
@@ -12024,7 +12024,7 @@
           <p:cNvPr id="3" name="">
             <a:extLst xmlns:a="http://schemas.openxmlformats.org/drawingml/2006/main">
               <a:ext uri="{FF2B5EF4-FFF2-40B4-BE49-F238E27FC236}">
-                <a16:creationId xmlns:a16="http://schemas.microsoft.com/office/drawing/2014/main" id="{CC063CD1-42EF-47F0-82F9-51E8F424FBBC}"/>
+                <a16:creationId xmlns:a16="http://schemas.microsoft.com/office/drawing/2014/main" id="{F29FD329-ED38-4FD0-A007-CC4B9E53413B}"/>
               </a:ext>
             </a:extLst>
           </p:cNvPr>
@@ -12144,7 +12144,7 @@
           <p:cNvPr id="4" name="">
             <a:extLst xmlns:a="http://schemas.openxmlformats.org/drawingml/2006/main">
               <a:ext uri="{FF2B5EF4-FFF2-40B4-BE49-F238E27FC236}">
-                <a16:creationId xmlns:a16="http://schemas.microsoft.com/office/drawing/2014/main" id="{E934D31D-D6D8-4EA2-807F-5FC6AE77516F}"/>
+                <a16:creationId xmlns:a16="http://schemas.microsoft.com/office/drawing/2014/main" id="{04D7BCA0-1AA9-498E-BA2B-F6AE70DE8794}"/>
               </a:ext>
             </a:extLst>
           </p:cNvPr>
@@ -12176,7 +12176,7 @@
           <p:cNvPr id="5" name="">
             <a:extLst xmlns:a="http://schemas.openxmlformats.org/drawingml/2006/main">
               <a:ext uri="{FF2B5EF4-FFF2-40B4-BE49-F238E27FC236}">
-                <a16:creationId xmlns:a16="http://schemas.microsoft.com/office/drawing/2014/main" id="{AAF66BD7-9E3F-464C-B731-9A7A5B1C507B}"/>
+                <a16:creationId xmlns:a16="http://schemas.microsoft.com/office/drawing/2014/main" id="{2DB2E062-234D-41C1-85D1-E5DE2BB5CEF0}"/>
               </a:ext>
             </a:extLst>
           </p:cNvPr>
@@ -12210,7 +12210,7 @@
           <p:cNvPr id="6" name="">
             <a:extLst xmlns:a="http://schemas.openxmlformats.org/drawingml/2006/main">
               <a:ext uri="{FF2B5EF4-FFF2-40B4-BE49-F238E27FC236}">
-                <a16:creationId xmlns:a16="http://schemas.microsoft.com/office/drawing/2014/main" id="{4B2ABA11-7659-4C9D-BACB-6742EF760A0D}"/>
+                <a16:creationId xmlns:a16="http://schemas.microsoft.com/office/drawing/2014/main" id="{FF4D20C3-C08E-44C1-8CAA-B851A074AC23}"/>
               </a:ext>
             </a:extLst>
           </p:cNvPr>
@@ -12244,7 +12244,7 @@
           <p:cNvPr id="7" name="">
             <a:extLst xmlns:a="http://schemas.openxmlformats.org/drawingml/2006/main">
               <a:ext uri="{FF2B5EF4-FFF2-40B4-BE49-F238E27FC236}">
-                <a16:creationId xmlns:a16="http://schemas.microsoft.com/office/drawing/2014/main" id="{C5D4E0F0-AEB3-4EF1-BEA2-727BBA4F2C44}"/>
+                <a16:creationId xmlns:a16="http://schemas.microsoft.com/office/drawing/2014/main" id="{4F7D6148-C8FC-48E4-B726-505D7C868324}"/>
               </a:ext>
             </a:extLst>
           </p:cNvPr>
@@ -12278,7 +12278,7 @@
           <p:cNvPr id="8" name="">
             <a:extLst xmlns:a="http://schemas.openxmlformats.org/drawingml/2006/main">
               <a:ext uri="{FF2B5EF4-FFF2-40B4-BE49-F238E27FC236}">
-                <a16:creationId xmlns:a16="http://schemas.microsoft.com/office/drawing/2014/main" id="{3B78ED75-DCB7-4044-AC0C-70C9E24D9D50}"/>
+                <a16:creationId xmlns:a16="http://schemas.microsoft.com/office/drawing/2014/main" id="{68D0E28D-C9CA-4019-BB6A-0C0C501C7FD2}"/>
               </a:ext>
             </a:extLst>
           </p:cNvPr>
@@ -12312,7 +12312,7 @@
           <p:cNvPr id="9" name="">
             <a:extLst xmlns:a="http://schemas.openxmlformats.org/drawingml/2006/main">
               <a:ext uri="{FF2B5EF4-FFF2-40B4-BE49-F238E27FC236}">
-                <a16:creationId xmlns:a16="http://schemas.microsoft.com/office/drawing/2014/main" id="{F51D7404-832B-429D-A37D-89BE93F5BB37}"/>
+                <a16:creationId xmlns:a16="http://schemas.microsoft.com/office/drawing/2014/main" id="{427010E8-1F47-429B-AC84-6394FBAE379C}"/>
               </a:ext>
             </a:extLst>
           </p:cNvPr>
@@ -12346,7 +12346,7 @@
           <p:cNvPr id="10" name="">
             <a:extLst xmlns:a="http://schemas.openxmlformats.org/drawingml/2006/main">
               <a:ext uri="{FF2B5EF4-FFF2-40B4-BE49-F238E27FC236}">
-                <a16:creationId xmlns:a16="http://schemas.microsoft.com/office/drawing/2014/main" id="{38D23AED-F24F-44B5-A204-C6EF86ADF183}"/>
+                <a16:creationId xmlns:a16="http://schemas.microsoft.com/office/drawing/2014/main" id="{252F9B47-5E15-48EF-A685-30E2655A18A2}"/>
               </a:ext>
             </a:extLst>
           </p:cNvPr>
@@ -12376,7 +12376,7 @@
           <p:cNvPr id="11" name="">
             <a:extLst xmlns:a="http://schemas.openxmlformats.org/drawingml/2006/main">
               <a:ext uri="{FF2B5EF4-FFF2-40B4-BE49-F238E27FC236}">
-                <a16:creationId xmlns:a16="http://schemas.microsoft.com/office/drawing/2014/main" id="{6E1B06DF-20CD-4673-8EDC-65E77FF8A826}"/>
+                <a16:creationId xmlns:a16="http://schemas.microsoft.com/office/drawing/2014/main" id="{7FB8BA50-ACD1-4781-BD5E-4D56590FCDAD}"/>
               </a:ext>
             </a:extLst>
           </p:cNvPr>
@@ -12408,7 +12408,7 @@
           <p:cNvPr id="12" name="">
             <a:extLst xmlns:a="http://schemas.openxmlformats.org/drawingml/2006/main">
               <a:ext uri="{FF2B5EF4-FFF2-40B4-BE49-F238E27FC236}">
-                <a16:creationId xmlns:a16="http://schemas.microsoft.com/office/drawing/2014/main" id="{BFAA8DC7-3406-4394-AFFD-04D45F41C3F7}"/>
+                <a16:creationId xmlns:a16="http://schemas.microsoft.com/office/drawing/2014/main" id="{78719FC9-3205-4FC8-AF2C-A7D5604CA9CA}"/>
               </a:ext>
             </a:extLst>
           </p:cNvPr>
@@ -12528,7 +12528,7 @@
           <p:cNvPr id="13" name="">
             <a:extLst xmlns:a="http://schemas.openxmlformats.org/drawingml/2006/main">
               <a:ext uri="{FF2B5EF4-FFF2-40B4-BE49-F238E27FC236}">
-                <a16:creationId xmlns:a16="http://schemas.microsoft.com/office/drawing/2014/main" id="{AA5ED702-1B33-4761-9E76-A577E6252C55}"/>
+                <a16:creationId xmlns:a16="http://schemas.microsoft.com/office/drawing/2014/main" id="{6AC91839-8736-4D7E-8F54-863EA76DD509}"/>
               </a:ext>
             </a:extLst>
           </p:cNvPr>
@@ -12560,7 +12560,7 @@
           <p:cNvPr id="14" name="">
             <a:extLst xmlns:a="http://schemas.openxmlformats.org/drawingml/2006/main">
               <a:ext uri="{FF2B5EF4-FFF2-40B4-BE49-F238E27FC236}">
-                <a16:creationId xmlns:a16="http://schemas.microsoft.com/office/drawing/2014/main" id="{153BABFB-AA16-4EC3-AF5E-B87261EAF9CA}"/>
+                <a16:creationId xmlns:a16="http://schemas.microsoft.com/office/drawing/2014/main" id="{98D8BF7C-BCF6-4DC5-B98A-DF87F5F1EFA7}"/>
               </a:ext>
             </a:extLst>
           </p:cNvPr>
@@ -12680,7 +12680,7 @@
           <p:cNvPr id="15" name="">
             <a:extLst xmlns:a="http://schemas.openxmlformats.org/drawingml/2006/main">
               <a:ext uri="{FF2B5EF4-FFF2-40B4-BE49-F238E27FC236}">
-                <a16:creationId xmlns:a16="http://schemas.microsoft.com/office/drawing/2014/main" id="{45BCEBE3-5AA6-4E97-B21A-7DDB0CCCA5F0}"/>
+                <a16:creationId xmlns:a16="http://schemas.microsoft.com/office/drawing/2014/main" id="{E6615E93-87DD-4081-9F08-F2F5A4540FFF}"/>
               </a:ext>
             </a:extLst>
           </p:cNvPr>
@@ -12712,7 +12712,7 @@
           <p:cNvPr id="16" name="">
             <a:extLst xmlns:a="http://schemas.openxmlformats.org/drawingml/2006/main">
               <a:ext uri="{FF2B5EF4-FFF2-40B4-BE49-F238E27FC236}">
-                <a16:creationId xmlns:a16="http://schemas.microsoft.com/office/drawing/2014/main" id="{957FABEC-C9C7-41EE-BE79-2A249D379E0B}"/>
+                <a16:creationId xmlns:a16="http://schemas.microsoft.com/office/drawing/2014/main" id="{ACFE1856-EFB7-444E-B575-2287C13DC3E6}"/>
               </a:ext>
             </a:extLst>
           </p:cNvPr>
@@ -12832,7 +12832,7 @@
           <p:cNvPr id="17" name="">
             <a:extLst xmlns:a="http://schemas.openxmlformats.org/drawingml/2006/main">
               <a:ext uri="{FF2B5EF4-FFF2-40B4-BE49-F238E27FC236}">
-                <a16:creationId xmlns:a16="http://schemas.microsoft.com/office/drawing/2014/main" id="{C4A8C897-93F1-4686-90E3-7C2F42BA954C}"/>
+                <a16:creationId xmlns:a16="http://schemas.microsoft.com/office/drawing/2014/main" id="{920E2FF5-C2D7-4F12-8358-263F1C6D2B25}"/>
               </a:ext>
             </a:extLst>
           </p:cNvPr>
@@ -12864,7 +12864,7 @@
           <p:cNvPr id="18" name="">
             <a:extLst xmlns:a="http://schemas.openxmlformats.org/drawingml/2006/main">
               <a:ext uri="{FF2B5EF4-FFF2-40B4-BE49-F238E27FC236}">
-                <a16:creationId xmlns:a16="http://schemas.microsoft.com/office/drawing/2014/main" id="{66790232-CCAF-4393-AEE7-D3D4903CC08E}"/>
+                <a16:creationId xmlns:a16="http://schemas.microsoft.com/office/drawing/2014/main" id="{026C6FAD-4D87-46A8-9C8A-C9B91E1C3F23}"/>
               </a:ext>
             </a:extLst>
           </p:cNvPr>
@@ -12984,7 +12984,7 @@
           <p:cNvPr id="19" name="">
             <a:extLst xmlns:a="http://schemas.openxmlformats.org/drawingml/2006/main">
               <a:ext uri="{FF2B5EF4-FFF2-40B4-BE49-F238E27FC236}">
-                <a16:creationId xmlns:a16="http://schemas.microsoft.com/office/drawing/2014/main" id="{8F12C0A2-5505-435A-B550-69FF21C33722}"/>
+                <a16:creationId xmlns:a16="http://schemas.microsoft.com/office/drawing/2014/main" id="{0BF267F1-DB04-4243-A3B5-548D63CFFC1A}"/>
               </a:ext>
             </a:extLst>
           </p:cNvPr>
@@ -13104,7 +13104,7 @@
           <p:cNvPr id="20" name="">
             <a:extLst xmlns:a="http://schemas.openxmlformats.org/drawingml/2006/main">
               <a:ext uri="{FF2B5EF4-FFF2-40B4-BE49-F238E27FC236}">
-                <a16:creationId xmlns:a16="http://schemas.microsoft.com/office/drawing/2014/main" id="{9EE98C18-35B1-4CC1-B185-C916AA879414}"/>
+                <a16:creationId xmlns:a16="http://schemas.microsoft.com/office/drawing/2014/main" id="{FC2DF643-DDD3-491A-A09B-EFEDF2DBD517}"/>
               </a:ext>
             </a:extLst>
           </p:cNvPr>
@@ -13224,7 +13224,7 @@
           <p:cNvPr id="21" name="">
             <a:extLst xmlns:a="http://schemas.openxmlformats.org/drawingml/2006/main">
               <a:ext uri="{FF2B5EF4-FFF2-40B4-BE49-F238E27FC236}">
-                <a16:creationId xmlns:a16="http://schemas.microsoft.com/office/drawing/2014/main" id="{239CAF79-FB2C-4AFD-84C4-D3210E900BE4}"/>
+                <a16:creationId xmlns:a16="http://schemas.microsoft.com/office/drawing/2014/main" id="{03EF5AEE-EDE6-4DD7-9E8D-CACE9800CB9E}"/>
               </a:ext>
             </a:extLst>
           </p:cNvPr>
@@ -13344,7 +13344,7 @@
           <p:cNvPr id="22" name="">
             <a:extLst xmlns:a="http://schemas.openxmlformats.org/drawingml/2006/main">
               <a:ext uri="{FF2B5EF4-FFF2-40B4-BE49-F238E27FC236}">
-                <a16:creationId xmlns:a16="http://schemas.microsoft.com/office/drawing/2014/main" id="{B4959CA7-B8FB-4374-A905-4AA82EAF52B1}"/>
+                <a16:creationId xmlns:a16="http://schemas.microsoft.com/office/drawing/2014/main" id="{9FE09057-E49F-4573-91A0-E5681DE61E1B}"/>
               </a:ext>
             </a:extLst>
           </p:cNvPr>
@@ -13464,7 +13464,7 @@
           <p:cNvPr id="23" name="">
             <a:extLst xmlns:a="http://schemas.openxmlformats.org/drawingml/2006/main">
               <a:ext uri="{FF2B5EF4-FFF2-40B4-BE49-F238E27FC236}">
-                <a16:creationId xmlns:a16="http://schemas.microsoft.com/office/drawing/2014/main" id="{C07053C8-5583-4AAD-AF12-15B94185A93F}"/>
+                <a16:creationId xmlns:a16="http://schemas.microsoft.com/office/drawing/2014/main" id="{388CDBE4-280D-4299-B1BC-470A1EA9610B}"/>
               </a:ext>
             </a:extLst>
           </p:cNvPr>
@@ -13584,7 +13584,7 @@
           <p:cNvPr id="24" name="">
             <a:extLst xmlns:a="http://schemas.openxmlformats.org/drawingml/2006/main">
               <a:ext uri="{FF2B5EF4-FFF2-40B4-BE49-F238E27FC236}">
-                <a16:creationId xmlns:a16="http://schemas.microsoft.com/office/drawing/2014/main" id="{00905E53-85FA-4C7F-9BFF-4694D1D39459}"/>
+                <a16:creationId xmlns:a16="http://schemas.microsoft.com/office/drawing/2014/main" id="{E4A19509-6E25-4E96-AEB1-80F75C89157A}"/>
               </a:ext>
             </a:extLst>
           </p:cNvPr>
@@ -13704,7 +13704,7 @@
           <p:cNvPr id="25" name="">
             <a:extLst xmlns:a="http://schemas.openxmlformats.org/drawingml/2006/main">
               <a:ext uri="{FF2B5EF4-FFF2-40B4-BE49-F238E27FC236}">
-                <a16:creationId xmlns:a16="http://schemas.microsoft.com/office/drawing/2014/main" id="{587C0835-23FE-4365-8FA6-80C84C07A256}"/>
+                <a16:creationId xmlns:a16="http://schemas.microsoft.com/office/drawing/2014/main" id="{9112EB86-637C-4F17-935A-396413A3DB52}"/>
               </a:ext>
             </a:extLst>
           </p:cNvPr>
@@ -13822,7 +13822,7 @@
     </p:spTree>
     <p:extLst>
       <p:ext uri="{BB962C8B-B14F-4D97-AF65-F5344CB8AC3E}">
-        <p14:creationId xmlns:p14="http://schemas.microsoft.com/office/powerpoint/2010/main" val="463199212"/>
+        <p14:creationId xmlns:p14="http://schemas.microsoft.com/office/powerpoint/2010/main" val="310898963"/>
       </p:ext>
     </p:extLst>
   </p:cSld>
@@ -13853,7 +13853,7 @@
           <p:cNvPr id="21" name="">
             <a:extLst xmlns:a="http://schemas.openxmlformats.org/drawingml/2006/main">
               <a:ext uri="{FF2B5EF4-FFF2-40B4-BE49-F238E27FC236}">
-                <a16:creationId xmlns:a16="http://schemas.microsoft.com/office/drawing/2014/main" id="{D5077665-1560-4108-9220-76C67EF0FCFF}"/>
+                <a16:creationId xmlns:a16="http://schemas.microsoft.com/office/drawing/2014/main" id="{04B4C914-F476-4C60-AC1A-2584CBA76BA6}"/>
               </a:ext>
             </a:extLst>
           </p:cNvPr>
@@ -13883,7 +13883,7 @@
           <p:cNvPr id="2" name="">
             <a:extLst xmlns:a="http://schemas.openxmlformats.org/drawingml/2006/main">
               <a:ext uri="{FF2B5EF4-FFF2-40B4-BE49-F238E27FC236}">
-                <a16:creationId xmlns:a16="http://schemas.microsoft.com/office/drawing/2014/main" id="{2292A16A-F513-450B-8643-1B99F3698DA7}"/>
+                <a16:creationId xmlns:a16="http://schemas.microsoft.com/office/drawing/2014/main" id="{F0E0AD5A-7F29-4BB0-9158-E9C510EF995D}"/>
               </a:ext>
             </a:extLst>
           </p:cNvPr>
@@ -14003,7 +14003,7 @@
           <p:cNvPr id="3" name="">
             <a:extLst xmlns:a="http://schemas.openxmlformats.org/drawingml/2006/main">
               <a:ext uri="{FF2B5EF4-FFF2-40B4-BE49-F238E27FC236}">
-                <a16:creationId xmlns:a16="http://schemas.microsoft.com/office/drawing/2014/main" id="{19F0E0E3-95A0-4BF2-9E54-07B314C216C6}"/>
+                <a16:creationId xmlns:a16="http://schemas.microsoft.com/office/drawing/2014/main" id="{D46DE913-D81B-47E7-B886-3220BBAAEED4}"/>
               </a:ext>
             </a:extLst>
           </p:cNvPr>
@@ -14123,7 +14123,7 @@
           <p:cNvPr id="4" name="">
             <a:extLst xmlns:a="http://schemas.openxmlformats.org/drawingml/2006/main">
               <a:ext uri="{FF2B5EF4-FFF2-40B4-BE49-F238E27FC236}">
-                <a16:creationId xmlns:a16="http://schemas.microsoft.com/office/drawing/2014/main" id="{93A6E806-BAB0-4E82-A8F3-C5BE43BD7B16}"/>
+                <a16:creationId xmlns:a16="http://schemas.microsoft.com/office/drawing/2014/main" id="{E8EFA056-8105-4989-A574-04B40F5B61FA}"/>
               </a:ext>
             </a:extLst>
           </p:cNvPr>
@@ -14243,7 +14243,7 @@
           <p:cNvPr id="5" name="">
             <a:extLst xmlns:a="http://schemas.openxmlformats.org/drawingml/2006/main">
               <a:ext uri="{FF2B5EF4-FFF2-40B4-BE49-F238E27FC236}">
-                <a16:creationId xmlns:a16="http://schemas.microsoft.com/office/drawing/2014/main" id="{6A2D6492-5CC0-4DC5-BD77-A98F3F9BFFD7}"/>
+                <a16:creationId xmlns:a16="http://schemas.microsoft.com/office/drawing/2014/main" id="{3FF90EDC-BE43-48D4-AF52-978C5CCD992A}"/>
               </a:ext>
             </a:extLst>
           </p:cNvPr>
@@ -14275,7 +14275,7 @@
           <p:cNvPr id="6" name="">
             <a:extLst xmlns:a="http://schemas.openxmlformats.org/drawingml/2006/main">
               <a:ext uri="{FF2B5EF4-FFF2-40B4-BE49-F238E27FC236}">
-                <a16:creationId xmlns:a16="http://schemas.microsoft.com/office/drawing/2014/main" id="{ABBEF5E1-36F6-4CE1-84BD-A1F62FC06A22}"/>
+                <a16:creationId xmlns:a16="http://schemas.microsoft.com/office/drawing/2014/main" id="{A8D0C25E-CEC9-4C81-B39E-E0FE0CB78840}"/>
               </a:ext>
             </a:extLst>
           </p:cNvPr>
@@ -14395,7 +14395,7 @@
           <p:cNvPr id="7" name="">
             <a:extLst xmlns:a="http://schemas.openxmlformats.org/drawingml/2006/main">
               <a:ext uri="{FF2B5EF4-FFF2-40B4-BE49-F238E27FC236}">
-                <a16:creationId xmlns:a16="http://schemas.microsoft.com/office/drawing/2014/main" id="{0F5803F4-763D-41EE-97AF-FBC7AE010EA0}"/>
+                <a16:creationId xmlns:a16="http://schemas.microsoft.com/office/drawing/2014/main" id="{E095C270-3C82-43E0-8C6A-3E89E6571EF5}"/>
               </a:ext>
             </a:extLst>
           </p:cNvPr>
@@ -14515,7 +14515,7 @@
           <p:cNvPr id="8" name="">
             <a:extLst xmlns:a="http://schemas.openxmlformats.org/drawingml/2006/main">
               <a:ext uri="{FF2B5EF4-FFF2-40B4-BE49-F238E27FC236}">
-                <a16:creationId xmlns:a16="http://schemas.microsoft.com/office/drawing/2014/main" id="{2F9C73EA-16F5-4BB3-ACBC-9A4FEF0FADBF}"/>
+                <a16:creationId xmlns:a16="http://schemas.microsoft.com/office/drawing/2014/main" id="{12BE17B2-2CDE-412A-B896-A0EC2E134D20}"/>
               </a:ext>
             </a:extLst>
           </p:cNvPr>
@@ -14547,7 +14547,7 @@
           <p:cNvPr id="9" name="">
             <a:extLst xmlns:a="http://schemas.openxmlformats.org/drawingml/2006/main">
               <a:ext uri="{FF2B5EF4-FFF2-40B4-BE49-F238E27FC236}">
-                <a16:creationId xmlns:a16="http://schemas.microsoft.com/office/drawing/2014/main" id="{EA5A3F68-C919-42E6-85B8-8B480A1ABEE5}"/>
+                <a16:creationId xmlns:a16="http://schemas.microsoft.com/office/drawing/2014/main" id="{6D00F0F2-EF7A-45B5-AFE6-5B2CCC567069}"/>
               </a:ext>
             </a:extLst>
           </p:cNvPr>
@@ -14667,7 +14667,7 @@
           <p:cNvPr id="10" name="">
             <a:extLst xmlns:a="http://schemas.openxmlformats.org/drawingml/2006/main">
               <a:ext uri="{FF2B5EF4-FFF2-40B4-BE49-F238E27FC236}">
-                <a16:creationId xmlns:a16="http://schemas.microsoft.com/office/drawing/2014/main" id="{649FD41F-2D38-4675-9B9C-89C6A1C78683}"/>
+                <a16:creationId xmlns:a16="http://schemas.microsoft.com/office/drawing/2014/main" id="{D48B65F9-AD20-4E25-913F-F00E91B0B9F4}"/>
               </a:ext>
             </a:extLst>
           </p:cNvPr>
@@ -14787,7 +14787,7 @@
           <p:cNvPr id="11" name="">
             <a:extLst xmlns:a="http://schemas.openxmlformats.org/drawingml/2006/main">
               <a:ext uri="{FF2B5EF4-FFF2-40B4-BE49-F238E27FC236}">
-                <a16:creationId xmlns:a16="http://schemas.microsoft.com/office/drawing/2014/main" id="{2D1A0FF0-623D-40EA-A1F7-842BCDB789DB}"/>
+                <a16:creationId xmlns:a16="http://schemas.microsoft.com/office/drawing/2014/main" id="{E51947F9-CBFE-4545-B1C6-2FA8AE0C2F01}"/>
               </a:ext>
             </a:extLst>
           </p:cNvPr>
@@ -14819,7 +14819,7 @@
           <p:cNvPr id="12" name="">
             <a:extLst xmlns:a="http://schemas.openxmlformats.org/drawingml/2006/main">
               <a:ext uri="{FF2B5EF4-FFF2-40B4-BE49-F238E27FC236}">
-                <a16:creationId xmlns:a16="http://schemas.microsoft.com/office/drawing/2014/main" id="{2FA28F02-215A-4E62-B04D-99AC9203D902}"/>
+                <a16:creationId xmlns:a16="http://schemas.microsoft.com/office/drawing/2014/main" id="{E2FAF4DA-B25E-414C-95F8-93C9CBF1ECC7}"/>
               </a:ext>
             </a:extLst>
           </p:cNvPr>
@@ -14939,7 +14939,7 @@
           <p:cNvPr id="13" name="">
             <a:extLst xmlns:a="http://schemas.openxmlformats.org/drawingml/2006/main">
               <a:ext uri="{FF2B5EF4-FFF2-40B4-BE49-F238E27FC236}">
-                <a16:creationId xmlns:a16="http://schemas.microsoft.com/office/drawing/2014/main" id="{B0DA89F6-71D2-4424-8BAC-111FFB054065}"/>
+                <a16:creationId xmlns:a16="http://schemas.microsoft.com/office/drawing/2014/main" id="{6FDCEDD4-E90F-48CE-8E13-5D5DE57F22E0}"/>
               </a:ext>
             </a:extLst>
           </p:cNvPr>
@@ -15059,7 +15059,7 @@
           <p:cNvPr id="14" name="">
             <a:extLst xmlns:a="http://schemas.openxmlformats.org/drawingml/2006/main">
               <a:ext uri="{FF2B5EF4-FFF2-40B4-BE49-F238E27FC236}">
-                <a16:creationId xmlns:a16="http://schemas.microsoft.com/office/drawing/2014/main" id="{F02E733D-B390-42C8-8AD0-91F7C1F9AE21}"/>
+                <a16:creationId xmlns:a16="http://schemas.microsoft.com/office/drawing/2014/main" id="{787DF6CE-98FA-4C79-A16A-28EDBC084A88}"/>
               </a:ext>
             </a:extLst>
           </p:cNvPr>
@@ -15091,7 +15091,7 @@
           <p:cNvPr id="15" name="">
             <a:extLst xmlns:a="http://schemas.openxmlformats.org/drawingml/2006/main">
               <a:ext uri="{FF2B5EF4-FFF2-40B4-BE49-F238E27FC236}">
-                <a16:creationId xmlns:a16="http://schemas.microsoft.com/office/drawing/2014/main" id="{31ED62D0-8098-4E44-B086-A53777322DBF}"/>
+                <a16:creationId xmlns:a16="http://schemas.microsoft.com/office/drawing/2014/main" id="{1A9EFE64-2CA1-4F5D-828A-B58C38A2282E}"/>
               </a:ext>
             </a:extLst>
           </p:cNvPr>
@@ -15211,7 +15211,7 @@
           <p:cNvPr id="16" name="">
             <a:extLst xmlns:a="http://schemas.openxmlformats.org/drawingml/2006/main">
               <a:ext uri="{FF2B5EF4-FFF2-40B4-BE49-F238E27FC236}">
-                <a16:creationId xmlns:a16="http://schemas.microsoft.com/office/drawing/2014/main" id="{15F0F9E3-4327-4036-8287-F2E45BE8FC6C}"/>
+                <a16:creationId xmlns:a16="http://schemas.microsoft.com/office/drawing/2014/main" id="{0CDA1FAF-F3BB-4C55-A5E0-DE09772720E2}"/>
               </a:ext>
             </a:extLst>
           </p:cNvPr>
@@ -15331,7 +15331,7 @@
           <p:cNvPr id="17" name="">
             <a:extLst xmlns:a="http://schemas.openxmlformats.org/drawingml/2006/main">
               <a:ext uri="{FF2B5EF4-FFF2-40B4-BE49-F238E27FC236}">
-                <a16:creationId xmlns:a16="http://schemas.microsoft.com/office/drawing/2014/main" id="{4830B283-651F-43EC-AE53-CCD0E0C432EF}"/>
+                <a16:creationId xmlns:a16="http://schemas.microsoft.com/office/drawing/2014/main" id="{F1CA89F4-143D-447F-9BF4-C0E42094429B}"/>
               </a:ext>
             </a:extLst>
           </p:cNvPr>
@@ -15363,7 +15363,7 @@
           <p:cNvPr id="18" name="">
             <a:extLst xmlns:a="http://schemas.openxmlformats.org/drawingml/2006/main">
               <a:ext uri="{FF2B5EF4-FFF2-40B4-BE49-F238E27FC236}">
-                <a16:creationId xmlns:a16="http://schemas.microsoft.com/office/drawing/2014/main" id="{C152E966-2D8D-4E51-9F28-52B83C2C0DD9}"/>
+                <a16:creationId xmlns:a16="http://schemas.microsoft.com/office/drawing/2014/main" id="{97D4D9D8-B1B6-4DE7-A416-FCE3B506D2BC}"/>
               </a:ext>
             </a:extLst>
           </p:cNvPr>
@@ -15483,7 +15483,7 @@
           <p:cNvPr id="19" name="">
             <a:extLst xmlns:a="http://schemas.openxmlformats.org/drawingml/2006/main">
               <a:ext uri="{FF2B5EF4-FFF2-40B4-BE49-F238E27FC236}">
-                <a16:creationId xmlns:a16="http://schemas.microsoft.com/office/drawing/2014/main" id="{6FF91EC3-4738-42E5-A6AF-B7BB8F066E8E}"/>
+                <a16:creationId xmlns:a16="http://schemas.microsoft.com/office/drawing/2014/main" id="{86E71637-10FF-4F58-B042-D64D06E60D25}"/>
               </a:ext>
             </a:extLst>
           </p:cNvPr>
@@ -15603,7 +15603,7 @@
           <p:cNvPr id="20" name="">
             <a:extLst xmlns:a="http://schemas.openxmlformats.org/drawingml/2006/main">
               <a:ext uri="{FF2B5EF4-FFF2-40B4-BE49-F238E27FC236}">
-                <a16:creationId xmlns:a16="http://schemas.microsoft.com/office/drawing/2014/main" id="{BEDE3E9E-814F-40CF-B1FC-24B64F075E68}"/>
+                <a16:creationId xmlns:a16="http://schemas.microsoft.com/office/drawing/2014/main" id="{5C7AD886-C40C-481B-9A41-F49EEAC5A607}"/>
               </a:ext>
             </a:extLst>
           </p:cNvPr>
@@ -15721,7 +15721,7 @@
     </p:spTree>
     <p:extLst>
       <p:ext uri="{BB962C8B-B14F-4D97-AF65-F5344CB8AC3E}">
-        <p14:creationId xmlns:p14="http://schemas.microsoft.com/office/powerpoint/2010/main" val="1936207597"/>
+        <p14:creationId xmlns:p14="http://schemas.microsoft.com/office/powerpoint/2010/main" val="1308002331"/>
       </p:ext>
     </p:extLst>
   </p:cSld>
@@ -15752,7 +15752,7 @@
           <p:cNvPr id="14" name="">
             <a:extLst xmlns:a="http://schemas.openxmlformats.org/drawingml/2006/main">
               <a:ext uri="{FF2B5EF4-FFF2-40B4-BE49-F238E27FC236}">
-                <a16:creationId xmlns:a16="http://schemas.microsoft.com/office/drawing/2014/main" id="{15C1410B-05F7-4DF0-9505-D8CD373D3B4B}"/>
+                <a16:creationId xmlns:a16="http://schemas.microsoft.com/office/drawing/2014/main" id="{F5E37225-7C70-479C-97FC-62C0956823A6}"/>
               </a:ext>
             </a:extLst>
           </p:cNvPr>
@@ -15782,7 +15782,7 @@
           <p:cNvPr id="2" name="">
             <a:extLst xmlns:a="http://schemas.openxmlformats.org/drawingml/2006/main">
               <a:ext uri="{FF2B5EF4-FFF2-40B4-BE49-F238E27FC236}">
-                <a16:creationId xmlns:a16="http://schemas.microsoft.com/office/drawing/2014/main" id="{9A66125C-C3DE-4DF0-B00A-912808290F2F}"/>
+                <a16:creationId xmlns:a16="http://schemas.microsoft.com/office/drawing/2014/main" id="{DD9D95B0-8332-41C2-BE5A-178B3073CB55}"/>
               </a:ext>
             </a:extLst>
           </p:cNvPr>
@@ -15902,7 +15902,7 @@
           <p:cNvPr id="3" name="">
             <a:extLst xmlns:a="http://schemas.openxmlformats.org/drawingml/2006/main">
               <a:ext uri="{FF2B5EF4-FFF2-40B4-BE49-F238E27FC236}">
-                <a16:creationId xmlns:a16="http://schemas.microsoft.com/office/drawing/2014/main" id="{A8DE5897-760C-41B2-A068-721D15710BCF}"/>
+                <a16:creationId xmlns:a16="http://schemas.microsoft.com/office/drawing/2014/main" id="{3B6C0334-6414-4EBC-A6B4-C70C05E9DC5A}"/>
               </a:ext>
             </a:extLst>
           </p:cNvPr>
@@ -16022,7 +16022,7 @@
           <p:cNvPr id="4" name="">
             <a:extLst xmlns:a="http://schemas.openxmlformats.org/drawingml/2006/main">
               <a:ext uri="{FF2B5EF4-FFF2-40B4-BE49-F238E27FC236}">
-                <a16:creationId xmlns:a16="http://schemas.microsoft.com/office/drawing/2014/main" id="{2F281A39-A21A-44EE-9412-66DED77FA493}"/>
+                <a16:creationId xmlns:a16="http://schemas.microsoft.com/office/drawing/2014/main" id="{41B0B7CD-86FA-4133-A937-967821A1FCBF}"/>
               </a:ext>
             </a:extLst>
           </p:cNvPr>
@@ -16142,7 +16142,7 @@
           <p:cNvPr id="5" name="Chart">
             <a:extLst xmlns:a="http://schemas.openxmlformats.org/drawingml/2006/main">
               <a:ext uri="{FF2B5EF4-FFF2-40B4-BE49-F238E27FC236}">
-                <a16:creationId xmlns:a16="http://schemas.microsoft.com/office/drawing/2014/main" id="{9417EA19-E1B1-4248-802F-33B1E81B98AE}"/>
+                <a16:creationId xmlns:a16="http://schemas.microsoft.com/office/drawing/2014/main" id="{327A773D-9959-4368-9CE1-B78A84BE113F}"/>
               </a:ext>
             </a:extLst>
           </p:cNvPr>
@@ -16155,7 +16155,7 @@
         </p:xfrm>
         <a:graphic xmlns:a="http://schemas.openxmlformats.org/drawingml/2006/main">
           <a:graphicData uri="http://schemas.openxmlformats.org/drawingml/2006/chart">
-            <c:chart xmlns:r="http://schemas.openxmlformats.org/officeDocument/2006/relationships" xmlns:c="http://schemas.openxmlformats.org/drawingml/2006/chart" r:id="Rafadb97f6b6040b4"/>
+            <c:chart xmlns:r="http://schemas.openxmlformats.org/officeDocument/2006/relationships" xmlns:c="http://schemas.openxmlformats.org/drawingml/2006/chart" r:id="R724e7a4e08774798"/>
           </a:graphicData>
         </a:graphic>
       </p:graphicFrame>
@@ -16164,7 +16164,7 @@
           <p:cNvPr id="6" name="">
             <a:extLst xmlns:a="http://schemas.openxmlformats.org/drawingml/2006/main">
               <a:ext uri="{FF2B5EF4-FFF2-40B4-BE49-F238E27FC236}">
-                <a16:creationId xmlns:a16="http://schemas.microsoft.com/office/drawing/2014/main" id="{63AFC689-43D6-4A94-8348-237F62518BCC}"/>
+                <a16:creationId xmlns:a16="http://schemas.microsoft.com/office/drawing/2014/main" id="{C08E6235-1531-41CD-8D88-8EE979447D34}"/>
               </a:ext>
             </a:extLst>
           </p:cNvPr>
@@ -16196,7 +16196,7 @@
           <p:cNvPr id="7" name="">
             <a:extLst xmlns:a="http://schemas.openxmlformats.org/drawingml/2006/main">
               <a:ext uri="{FF2B5EF4-FFF2-40B4-BE49-F238E27FC236}">
-                <a16:creationId xmlns:a16="http://schemas.microsoft.com/office/drawing/2014/main" id="{20E6E357-1888-4B2D-B8B5-3FC65E0A1C42}"/>
+                <a16:creationId xmlns:a16="http://schemas.microsoft.com/office/drawing/2014/main" id="{1AAA81C7-C49A-47A5-88BC-CFC4778CD8F1}"/>
               </a:ext>
             </a:extLst>
           </p:cNvPr>
@@ -16316,7 +16316,7 @@
           <p:cNvPr id="8" name="">
             <a:extLst xmlns:a="http://schemas.openxmlformats.org/drawingml/2006/main">
               <a:ext uri="{FF2B5EF4-FFF2-40B4-BE49-F238E27FC236}">
-                <a16:creationId xmlns:a16="http://schemas.microsoft.com/office/drawing/2014/main" id="{F97BCB0D-362A-4C9C-B965-64F98BA98BD0}"/>
+                <a16:creationId xmlns:a16="http://schemas.microsoft.com/office/drawing/2014/main" id="{6686D48B-1ABB-4FD5-8ECB-D480BBA67873}"/>
               </a:ext>
             </a:extLst>
           </p:cNvPr>
@@ -16436,7 +16436,7 @@
           <p:cNvPr id="9" name="">
             <a:extLst xmlns:a="http://schemas.openxmlformats.org/drawingml/2006/main">
               <a:ext uri="{FF2B5EF4-FFF2-40B4-BE49-F238E27FC236}">
-                <a16:creationId xmlns:a16="http://schemas.microsoft.com/office/drawing/2014/main" id="{57B66730-8F82-4082-ABB8-8BF245BBE14E}"/>
+                <a16:creationId xmlns:a16="http://schemas.microsoft.com/office/drawing/2014/main" id="{4CB3B1F6-23B0-463E-93F8-EDA3E0528045}"/>
               </a:ext>
             </a:extLst>
           </p:cNvPr>
@@ -16556,7 +16556,7 @@
           <p:cNvPr id="10" name="">
             <a:extLst xmlns:a="http://schemas.openxmlformats.org/drawingml/2006/main">
               <a:ext uri="{FF2B5EF4-FFF2-40B4-BE49-F238E27FC236}">
-                <a16:creationId xmlns:a16="http://schemas.microsoft.com/office/drawing/2014/main" id="{5D834BCE-EA79-450B-8C69-12B8DAAB11CE}"/>
+                <a16:creationId xmlns:a16="http://schemas.microsoft.com/office/drawing/2014/main" id="{3CCC6044-19CE-4035-8F82-9828D149B3B0}"/>
               </a:ext>
             </a:extLst>
           </p:cNvPr>
@@ -16676,7 +16676,7 @@
           <p:cNvPr id="11" name="">
             <a:extLst xmlns:a="http://schemas.openxmlformats.org/drawingml/2006/main">
               <a:ext uri="{FF2B5EF4-FFF2-40B4-BE49-F238E27FC236}">
-                <a16:creationId xmlns:a16="http://schemas.microsoft.com/office/drawing/2014/main" id="{3C0386A4-A0C5-446B-AA3B-C5A5F7F84869}"/>
+                <a16:creationId xmlns:a16="http://schemas.microsoft.com/office/drawing/2014/main" id="{2D1C32AF-DCBA-42D9-81A4-9EB4CD1F5E75}"/>
               </a:ext>
             </a:extLst>
           </p:cNvPr>
@@ -16796,7 +16796,7 @@
           <p:cNvPr id="12" name="">
             <a:extLst xmlns:a="http://schemas.openxmlformats.org/drawingml/2006/main">
               <a:ext uri="{FF2B5EF4-FFF2-40B4-BE49-F238E27FC236}">
-                <a16:creationId xmlns:a16="http://schemas.microsoft.com/office/drawing/2014/main" id="{E7402AF6-D9C4-4B37-9BB4-BE50DC5F655D}"/>
+                <a16:creationId xmlns:a16="http://schemas.microsoft.com/office/drawing/2014/main" id="{5BC1DFAD-43E4-4C36-A38D-3F4BE06F1D61}"/>
               </a:ext>
             </a:extLst>
           </p:cNvPr>
@@ -16916,7 +16916,7 @@
           <p:cNvPr id="13" name="">
             <a:extLst xmlns:a="http://schemas.openxmlformats.org/drawingml/2006/main">
               <a:ext uri="{FF2B5EF4-FFF2-40B4-BE49-F238E27FC236}">
-                <a16:creationId xmlns:a16="http://schemas.microsoft.com/office/drawing/2014/main" id="{E1A69457-3CD6-400A-88FF-307C1C804221}"/>
+                <a16:creationId xmlns:a16="http://schemas.microsoft.com/office/drawing/2014/main" id="{4870A224-DC84-4376-949D-C1622C650200}"/>
               </a:ext>
             </a:extLst>
           </p:cNvPr>
@@ -17034,7 +17034,7 @@
     </p:spTree>
     <p:extLst>
       <p:ext uri="{BB962C8B-B14F-4D97-AF65-F5344CB8AC3E}">
-        <p14:creationId xmlns:p14="http://schemas.microsoft.com/office/powerpoint/2010/main" val="1779705860"/>
+        <p14:creationId xmlns:p14="http://schemas.microsoft.com/office/powerpoint/2010/main" val="1623094142"/>
       </p:ext>
     </p:extLst>
   </p:cSld>
@@ -17065,7 +17065,7 @@
           <p:cNvPr id="27" name="">
             <a:extLst xmlns:a="http://schemas.openxmlformats.org/drawingml/2006/main">
               <a:ext uri="{FF2B5EF4-FFF2-40B4-BE49-F238E27FC236}">
-                <a16:creationId xmlns:a16="http://schemas.microsoft.com/office/drawing/2014/main" id="{DF247C38-9667-40A4-B185-BD0EBCCFDCB0}"/>
+                <a16:creationId xmlns:a16="http://schemas.microsoft.com/office/drawing/2014/main" id="{92A71C20-DBA0-4870-BDD8-17BFAB0B0E9D}"/>
               </a:ext>
             </a:extLst>
           </p:cNvPr>
@@ -17095,7 +17095,7 @@
           <p:cNvPr id="2" name="">
             <a:extLst xmlns:a="http://schemas.openxmlformats.org/drawingml/2006/main">
               <a:ext uri="{FF2B5EF4-FFF2-40B4-BE49-F238E27FC236}">
-                <a16:creationId xmlns:a16="http://schemas.microsoft.com/office/drawing/2014/main" id="{F877E14B-5CDB-4BC1-869F-5A0ECA6CEADD}"/>
+                <a16:creationId xmlns:a16="http://schemas.microsoft.com/office/drawing/2014/main" id="{56ECF197-1D63-4760-9625-266B3B72810D}"/>
               </a:ext>
             </a:extLst>
           </p:cNvPr>
@@ -17215,7 +17215,7 @@
           <p:cNvPr id="3" name="">
             <a:extLst xmlns:a="http://schemas.openxmlformats.org/drawingml/2006/main">
               <a:ext uri="{FF2B5EF4-FFF2-40B4-BE49-F238E27FC236}">
-                <a16:creationId xmlns:a16="http://schemas.microsoft.com/office/drawing/2014/main" id="{E1B8D6B5-D740-4B8E-9E7B-4FD15302E359}"/>
+                <a16:creationId xmlns:a16="http://schemas.microsoft.com/office/drawing/2014/main" id="{8D9E6E01-837C-4525-8A88-FCCB155E49F5}"/>
               </a:ext>
             </a:extLst>
           </p:cNvPr>
@@ -17335,7 +17335,7 @@
           <p:cNvPr id="4" name="">
             <a:extLst xmlns:a="http://schemas.openxmlformats.org/drawingml/2006/main">
               <a:ext uri="{FF2B5EF4-FFF2-40B4-BE49-F238E27FC236}">
-                <a16:creationId xmlns:a16="http://schemas.microsoft.com/office/drawing/2014/main" id="{9C8EC561-CCD5-4E10-8BF5-2164B65898D5}"/>
+                <a16:creationId xmlns:a16="http://schemas.microsoft.com/office/drawing/2014/main" id="{5CCAAF59-4B8B-4990-AD1E-A19ACD8E2ACF}"/>
               </a:ext>
             </a:extLst>
           </p:cNvPr>
@@ -17455,7 +17455,7 @@
           <p:cNvPr id="5" name="">
             <a:extLst xmlns:a="http://schemas.openxmlformats.org/drawingml/2006/main">
               <a:ext uri="{FF2B5EF4-FFF2-40B4-BE49-F238E27FC236}">
-                <a16:creationId xmlns:a16="http://schemas.microsoft.com/office/drawing/2014/main" id="{3CAF9289-2DB2-4BF0-BAAD-254AB24CDF63}"/>
+                <a16:creationId xmlns:a16="http://schemas.microsoft.com/office/drawing/2014/main" id="{56CC8342-7841-4DDD-A85C-9C20B4D4551C}"/>
               </a:ext>
             </a:extLst>
           </p:cNvPr>
@@ -17487,7 +17487,7 @@
           <p:cNvPr id="6" name="">
             <a:extLst xmlns:a="http://schemas.openxmlformats.org/drawingml/2006/main">
               <a:ext uri="{FF2B5EF4-FFF2-40B4-BE49-F238E27FC236}">
-                <a16:creationId xmlns:a16="http://schemas.microsoft.com/office/drawing/2014/main" id="{8F27B618-07EB-4714-AE74-EDB961929B8E}"/>
+                <a16:creationId xmlns:a16="http://schemas.microsoft.com/office/drawing/2014/main" id="{266B2C9E-CB1A-4559-B3D4-3CA805AC9517}"/>
               </a:ext>
             </a:extLst>
           </p:cNvPr>
@@ -17607,7 +17607,7 @@
           <p:cNvPr id="7" name="">
             <a:extLst xmlns:a="http://schemas.openxmlformats.org/drawingml/2006/main">
               <a:ext uri="{FF2B5EF4-FFF2-40B4-BE49-F238E27FC236}">
-                <a16:creationId xmlns:a16="http://schemas.microsoft.com/office/drawing/2014/main" id="{5701ED4D-80E3-446F-8D18-64F765CF79F7}"/>
+                <a16:creationId xmlns:a16="http://schemas.microsoft.com/office/drawing/2014/main" id="{CD320B78-7847-422F-8DD9-91AD59F1629F}"/>
               </a:ext>
             </a:extLst>
           </p:cNvPr>
@@ -17639,7 +17639,7 @@
           <p:cNvPr id="8" name="">
             <a:extLst xmlns:a="http://schemas.openxmlformats.org/drawingml/2006/main">
               <a:ext uri="{FF2B5EF4-FFF2-40B4-BE49-F238E27FC236}">
-                <a16:creationId xmlns:a16="http://schemas.microsoft.com/office/drawing/2014/main" id="{0DDB8C0E-12F7-4508-9A75-2ECA9E9952A0}"/>
+                <a16:creationId xmlns:a16="http://schemas.microsoft.com/office/drawing/2014/main" id="{6A438782-4029-4273-ABCA-F53D571E3456}"/>
               </a:ext>
             </a:extLst>
           </p:cNvPr>
@@ -17759,7 +17759,7 @@
           <p:cNvPr id="9" name="">
             <a:extLst xmlns:a="http://schemas.openxmlformats.org/drawingml/2006/main">
               <a:ext uri="{FF2B5EF4-FFF2-40B4-BE49-F238E27FC236}">
-                <a16:creationId xmlns:a16="http://schemas.microsoft.com/office/drawing/2014/main" id="{B7F2D04A-7518-4640-A20F-4388D58C7678}"/>
+                <a16:creationId xmlns:a16="http://schemas.microsoft.com/office/drawing/2014/main" id="{28F8E282-0CB5-409D-AC15-ADDFCF4E45BC}"/>
               </a:ext>
             </a:extLst>
           </p:cNvPr>
@@ -17791,7 +17791,7 @@
           <p:cNvPr id="10" name="">
             <a:extLst xmlns:a="http://schemas.openxmlformats.org/drawingml/2006/main">
               <a:ext uri="{FF2B5EF4-FFF2-40B4-BE49-F238E27FC236}">
-                <a16:creationId xmlns:a16="http://schemas.microsoft.com/office/drawing/2014/main" id="{B09FC8BC-6847-4AAE-B53A-0111F8FD89B2}"/>
+                <a16:creationId xmlns:a16="http://schemas.microsoft.com/office/drawing/2014/main" id="{DCACAF29-8644-4998-BAEC-0A64AE0B272C}"/>
               </a:ext>
             </a:extLst>
           </p:cNvPr>
@@ -17911,7 +17911,7 @@
           <p:cNvPr id="11" name="">
             <a:extLst xmlns:a="http://schemas.openxmlformats.org/drawingml/2006/main">
               <a:ext uri="{FF2B5EF4-FFF2-40B4-BE49-F238E27FC236}">
-                <a16:creationId xmlns:a16="http://schemas.microsoft.com/office/drawing/2014/main" id="{5A4FBF1C-837B-4F14-9465-63BDC862D962}"/>
+                <a16:creationId xmlns:a16="http://schemas.microsoft.com/office/drawing/2014/main" id="{3391226E-28A9-4CA9-9E0A-BE1F0BDADFB3}"/>
               </a:ext>
             </a:extLst>
           </p:cNvPr>
@@ -17943,7 +17943,7 @@
           <p:cNvPr id="12" name="">
             <a:extLst xmlns:a="http://schemas.openxmlformats.org/drawingml/2006/main">
               <a:ext uri="{FF2B5EF4-FFF2-40B4-BE49-F238E27FC236}">
-                <a16:creationId xmlns:a16="http://schemas.microsoft.com/office/drawing/2014/main" id="{C913F1B5-012D-4CF5-84BD-A522BBAB671C}"/>
+                <a16:creationId xmlns:a16="http://schemas.microsoft.com/office/drawing/2014/main" id="{E6407218-CAED-48A1-A8FE-F15F5FAA420B}"/>
               </a:ext>
             </a:extLst>
           </p:cNvPr>
@@ -18063,7 +18063,7 @@
           <p:cNvPr id="13" name="">
             <a:extLst xmlns:a="http://schemas.openxmlformats.org/drawingml/2006/main">
               <a:ext uri="{FF2B5EF4-FFF2-40B4-BE49-F238E27FC236}">
-                <a16:creationId xmlns:a16="http://schemas.microsoft.com/office/drawing/2014/main" id="{961ED79F-4464-421E-9262-4A2F300B3F52}"/>
+                <a16:creationId xmlns:a16="http://schemas.microsoft.com/office/drawing/2014/main" id="{03237DE2-2C61-4918-973D-9EDCE9F9738D}"/>
               </a:ext>
             </a:extLst>
           </p:cNvPr>
@@ -18095,7 +18095,7 @@
           <p:cNvPr id="14" name="">
             <a:extLst xmlns:a="http://schemas.openxmlformats.org/drawingml/2006/main">
               <a:ext uri="{FF2B5EF4-FFF2-40B4-BE49-F238E27FC236}">
-                <a16:creationId xmlns:a16="http://schemas.microsoft.com/office/drawing/2014/main" id="{7FBB46CE-0FB3-44CF-B588-E9953F07CF0A}"/>
+                <a16:creationId xmlns:a16="http://schemas.microsoft.com/office/drawing/2014/main" id="{80F95F38-E865-4801-94A8-9FD156834A36}"/>
               </a:ext>
             </a:extLst>
           </p:cNvPr>
@@ -18215,7 +18215,7 @@
           <p:cNvPr id="15" name="">
             <a:extLst xmlns:a="http://schemas.openxmlformats.org/drawingml/2006/main">
               <a:ext uri="{FF2B5EF4-FFF2-40B4-BE49-F238E27FC236}">
-                <a16:creationId xmlns:a16="http://schemas.microsoft.com/office/drawing/2014/main" id="{92047711-8466-4407-A47D-2A40F93481FF}"/>
+                <a16:creationId xmlns:a16="http://schemas.microsoft.com/office/drawing/2014/main" id="{F030DB1B-8949-4647-B092-C839E8808217}"/>
               </a:ext>
             </a:extLst>
           </p:cNvPr>
@@ -18247,7 +18247,7 @@
           <p:cNvPr id="16" name="">
             <a:extLst xmlns:a="http://schemas.openxmlformats.org/drawingml/2006/main">
               <a:ext uri="{FF2B5EF4-FFF2-40B4-BE49-F238E27FC236}">
-                <a16:creationId xmlns:a16="http://schemas.microsoft.com/office/drawing/2014/main" id="{F0F2A1B1-DC73-4AC0-8127-ECC4E1B51ACF}"/>
+                <a16:creationId xmlns:a16="http://schemas.microsoft.com/office/drawing/2014/main" id="{54E0A64E-A303-4709-BB7A-FD1628063645}"/>
               </a:ext>
             </a:extLst>
           </p:cNvPr>
@@ -18367,7 +18367,7 @@
           <p:cNvPr id="17" name="">
             <a:extLst xmlns:a="http://schemas.openxmlformats.org/drawingml/2006/main">
               <a:ext uri="{FF2B5EF4-FFF2-40B4-BE49-F238E27FC236}">
-                <a16:creationId xmlns:a16="http://schemas.microsoft.com/office/drawing/2014/main" id="{187974DD-5B2D-4685-A7CB-B70E3D6DA336}"/>
+                <a16:creationId xmlns:a16="http://schemas.microsoft.com/office/drawing/2014/main" id="{00AD429B-7BB4-40BC-97A7-D394696DC412}"/>
               </a:ext>
             </a:extLst>
           </p:cNvPr>
@@ -18399,7 +18399,7 @@
           <p:cNvPr id="18" name="">
             <a:extLst xmlns:a="http://schemas.openxmlformats.org/drawingml/2006/main">
               <a:ext uri="{FF2B5EF4-FFF2-40B4-BE49-F238E27FC236}">
-                <a16:creationId xmlns:a16="http://schemas.microsoft.com/office/drawing/2014/main" id="{B7B102CA-63F3-4F6A-94C4-EFDD065EBA7C}"/>
+                <a16:creationId xmlns:a16="http://schemas.microsoft.com/office/drawing/2014/main" id="{CEB4CEE1-7B4D-472B-A6E3-298C945C95D3}"/>
               </a:ext>
             </a:extLst>
           </p:cNvPr>
@@ -18519,7 +18519,7 @@
           <p:cNvPr id="19" name="">
             <a:extLst xmlns:a="http://schemas.openxmlformats.org/drawingml/2006/main">
               <a:ext uri="{FF2B5EF4-FFF2-40B4-BE49-F238E27FC236}">
-                <a16:creationId xmlns:a16="http://schemas.microsoft.com/office/drawing/2014/main" id="{1AB59EAD-ED08-4C47-A3D5-A043991710B6}"/>
+                <a16:creationId xmlns:a16="http://schemas.microsoft.com/office/drawing/2014/main" id="{140BCB6A-B106-41CE-9C09-4703584941FE}"/>
               </a:ext>
             </a:extLst>
           </p:cNvPr>
@@ -18551,7 +18551,7 @@
           <p:cNvPr id="20" name="">
             <a:extLst xmlns:a="http://schemas.openxmlformats.org/drawingml/2006/main">
               <a:ext uri="{FF2B5EF4-FFF2-40B4-BE49-F238E27FC236}">
-                <a16:creationId xmlns:a16="http://schemas.microsoft.com/office/drawing/2014/main" id="{2037A250-00C4-4D1F-B4D7-9D16CE6BE96A}"/>
+                <a16:creationId xmlns:a16="http://schemas.microsoft.com/office/drawing/2014/main" id="{4FC4DBDF-B7D0-45B9-B50C-672ABDC510ED}"/>
               </a:ext>
             </a:extLst>
           </p:cNvPr>
@@ -18671,7 +18671,7 @@
           <p:cNvPr id="21" name="">
             <a:extLst xmlns:a="http://schemas.openxmlformats.org/drawingml/2006/main">
               <a:ext uri="{FF2B5EF4-FFF2-40B4-BE49-F238E27FC236}">
-                <a16:creationId xmlns:a16="http://schemas.microsoft.com/office/drawing/2014/main" id="{CA460F6D-6F45-4544-9C82-7E0D7050EAA5}"/>
+                <a16:creationId xmlns:a16="http://schemas.microsoft.com/office/drawing/2014/main" id="{032A765D-885F-49C4-BC52-7993C1CA5CD0}"/>
               </a:ext>
             </a:extLst>
           </p:cNvPr>
@@ -18703,7 +18703,7 @@
           <p:cNvPr id="22" name="">
             <a:extLst xmlns:a="http://schemas.openxmlformats.org/drawingml/2006/main">
               <a:ext uri="{FF2B5EF4-FFF2-40B4-BE49-F238E27FC236}">
-                <a16:creationId xmlns:a16="http://schemas.microsoft.com/office/drawing/2014/main" id="{8997C25F-6CFC-44C4-A1A2-9FCDD2200D6F}"/>
+                <a16:creationId xmlns:a16="http://schemas.microsoft.com/office/drawing/2014/main" id="{266C3577-2C3C-4028-9751-25B854ECA4C1}"/>
               </a:ext>
             </a:extLst>
           </p:cNvPr>
@@ -18823,7 +18823,7 @@
           <p:cNvPr id="23" name="">
             <a:extLst xmlns:a="http://schemas.openxmlformats.org/drawingml/2006/main">
               <a:ext uri="{FF2B5EF4-FFF2-40B4-BE49-F238E27FC236}">
-                <a16:creationId xmlns:a16="http://schemas.microsoft.com/office/drawing/2014/main" id="{19956EFE-B2B1-41A4-86A4-3CEEC160F7D7}"/>
+                <a16:creationId xmlns:a16="http://schemas.microsoft.com/office/drawing/2014/main" id="{77071CA1-67CE-4568-ADCF-F430893EABD5}"/>
               </a:ext>
             </a:extLst>
           </p:cNvPr>
@@ -18855,7 +18855,7 @@
           <p:cNvPr id="24" name="">
             <a:extLst xmlns:a="http://schemas.openxmlformats.org/drawingml/2006/main">
               <a:ext uri="{FF2B5EF4-FFF2-40B4-BE49-F238E27FC236}">
-                <a16:creationId xmlns:a16="http://schemas.microsoft.com/office/drawing/2014/main" id="{E792B9DB-FE52-45AE-8D01-8BA6C2CB4FE0}"/>
+                <a16:creationId xmlns:a16="http://schemas.microsoft.com/office/drawing/2014/main" id="{70EFCE4A-10AE-4185-B971-A35BE420ACB0}"/>
               </a:ext>
             </a:extLst>
           </p:cNvPr>
@@ -18975,7 +18975,7 @@
           <p:cNvPr id="25" name="">
             <a:extLst xmlns:a="http://schemas.openxmlformats.org/drawingml/2006/main">
               <a:ext uri="{FF2B5EF4-FFF2-40B4-BE49-F238E27FC236}">
-                <a16:creationId xmlns:a16="http://schemas.microsoft.com/office/drawing/2014/main" id="{04F80681-E850-45E3-B92E-D579079431D8}"/>
+                <a16:creationId xmlns:a16="http://schemas.microsoft.com/office/drawing/2014/main" id="{A0E04D65-1ADF-43B7-920B-8663C8F21057}"/>
               </a:ext>
             </a:extLst>
           </p:cNvPr>
@@ -19007,7 +19007,7 @@
           <p:cNvPr id="26" name="">
             <a:extLst xmlns:a="http://schemas.openxmlformats.org/drawingml/2006/main">
               <a:ext uri="{FF2B5EF4-FFF2-40B4-BE49-F238E27FC236}">
-                <a16:creationId xmlns:a16="http://schemas.microsoft.com/office/drawing/2014/main" id="{4C571FD7-3B11-458A-9C25-C8879E6114D6}"/>
+                <a16:creationId xmlns:a16="http://schemas.microsoft.com/office/drawing/2014/main" id="{D596BABF-0FCE-430D-99E2-A3E3379287EC}"/>
               </a:ext>
             </a:extLst>
           </p:cNvPr>
@@ -19125,7 +19125,7 @@
     </p:spTree>
     <p:extLst>
       <p:ext uri="{BB962C8B-B14F-4D97-AF65-F5344CB8AC3E}">
-        <p14:creationId xmlns:p14="http://schemas.microsoft.com/office/powerpoint/2010/main" val="106710334"/>
+        <p14:creationId xmlns:p14="http://schemas.microsoft.com/office/powerpoint/2010/main" val="381966454"/>
       </p:ext>
     </p:extLst>
   </p:cSld>
@@ -19153,10 +19153,10 @@
       </p:grpSpPr>
       <p:sp>
         <p:nvSpPr>
-          <p:cNvPr id="15" name="">
+          <p:cNvPr id="17" name="">
             <a:extLst xmlns:a="http://schemas.openxmlformats.org/drawingml/2006/main">
               <a:ext uri="{FF2B5EF4-FFF2-40B4-BE49-F238E27FC236}">
-                <a16:creationId xmlns:a16="http://schemas.microsoft.com/office/drawing/2014/main" id="{F84D22E0-13B8-4012-8E42-D997CFE6FFFB}"/>
+                <a16:creationId xmlns:a16="http://schemas.microsoft.com/office/drawing/2014/main" id="{E1B89C6C-C6EB-44B8-B325-1C32619A9971}"/>
               </a:ext>
             </a:extLst>
           </p:cNvPr>
@@ -19186,7 +19186,7 @@
           <p:cNvPr id="2" name="">
             <a:extLst xmlns:a="http://schemas.openxmlformats.org/drawingml/2006/main">
               <a:ext uri="{FF2B5EF4-FFF2-40B4-BE49-F238E27FC236}">
-                <a16:creationId xmlns:a16="http://schemas.microsoft.com/office/drawing/2014/main" id="{0659E04C-FE06-46AF-95C9-E5D53E156606}"/>
+                <a16:creationId xmlns:a16="http://schemas.microsoft.com/office/drawing/2014/main" id="{FBE99F56-35C9-4F9D-B3F5-DBC88D3458CF}"/>
               </a:ext>
             </a:extLst>
           </p:cNvPr>
@@ -19306,7 +19306,7 @@
           <p:cNvPr id="3" name="">
             <a:extLst xmlns:a="http://schemas.openxmlformats.org/drawingml/2006/main">
               <a:ext uri="{FF2B5EF4-FFF2-40B4-BE49-F238E27FC236}">
-                <a16:creationId xmlns:a16="http://schemas.microsoft.com/office/drawing/2014/main" id="{7FBE5B72-846E-4BE1-B7D7-9E15B2139524}"/>
+                <a16:creationId xmlns:a16="http://schemas.microsoft.com/office/drawing/2014/main" id="{205C07A6-4CF1-4DD2-A65C-7BF157B0D398}"/>
               </a:ext>
             </a:extLst>
           </p:cNvPr>
@@ -19426,7 +19426,7 @@
           <p:cNvPr id="4" name="">
             <a:extLst xmlns:a="http://schemas.openxmlformats.org/drawingml/2006/main">
               <a:ext uri="{FF2B5EF4-FFF2-40B4-BE49-F238E27FC236}">
-                <a16:creationId xmlns:a16="http://schemas.microsoft.com/office/drawing/2014/main" id="{F797B538-A640-4C04-B86B-4C3478B78F49}"/>
+                <a16:creationId xmlns:a16="http://schemas.microsoft.com/office/drawing/2014/main" id="{B9160619-FFA2-47E2-A52B-58E634899225}"/>
               </a:ext>
             </a:extLst>
           </p:cNvPr>
@@ -19458,7 +19458,7 @@
           <p:cNvPr id="5" name="">
             <a:extLst xmlns:a="http://schemas.openxmlformats.org/drawingml/2006/main">
               <a:ext uri="{FF2B5EF4-FFF2-40B4-BE49-F238E27FC236}">
-                <a16:creationId xmlns:a16="http://schemas.microsoft.com/office/drawing/2014/main" id="{4A0C6093-38A8-4AA7-903E-6150154A3A28}"/>
+                <a16:creationId xmlns:a16="http://schemas.microsoft.com/office/drawing/2014/main" id="{20FA1C20-B7F9-4C22-A1CF-73EA5CF09554}"/>
               </a:ext>
             </a:extLst>
           </p:cNvPr>
@@ -19578,7 +19578,7 @@
           <p:cNvPr id="6" name="">
             <a:extLst xmlns:a="http://schemas.openxmlformats.org/drawingml/2006/main">
               <a:ext uri="{FF2B5EF4-FFF2-40B4-BE49-F238E27FC236}">
-                <a16:creationId xmlns:a16="http://schemas.microsoft.com/office/drawing/2014/main" id="{D3DA0D0E-A141-44D3-855E-4A06D67708D8}"/>
+                <a16:creationId xmlns:a16="http://schemas.microsoft.com/office/drawing/2014/main" id="{AC1CCDA8-E6EB-4F68-BFB4-E2CBAEE7C1BA}"/>
               </a:ext>
             </a:extLst>
           </p:cNvPr>
@@ -19698,7 +19698,7 @@
           <p:cNvPr id="7" name="">
             <a:extLst xmlns:a="http://schemas.openxmlformats.org/drawingml/2006/main">
               <a:ext uri="{FF2B5EF4-FFF2-40B4-BE49-F238E27FC236}">
-                <a16:creationId xmlns:a16="http://schemas.microsoft.com/office/drawing/2014/main" id="{4D77935F-73B5-4E11-AE7D-CF4B5ABE416C}"/>
+                <a16:creationId xmlns:a16="http://schemas.microsoft.com/office/drawing/2014/main" id="{659CC4A8-0DEB-4F8C-BF0D-B0282A6B8E3E}"/>
               </a:ext>
             </a:extLst>
           </p:cNvPr>
@@ -19730,7 +19730,7 @@
           <p:cNvPr id="8" name="">
             <a:extLst xmlns:a="http://schemas.openxmlformats.org/drawingml/2006/main">
               <a:ext uri="{FF2B5EF4-FFF2-40B4-BE49-F238E27FC236}">
-                <a16:creationId xmlns:a16="http://schemas.microsoft.com/office/drawing/2014/main" id="{33A2B5F6-7E59-4360-95DC-8DCF59FCDD2F}"/>
+                <a16:creationId xmlns:a16="http://schemas.microsoft.com/office/drawing/2014/main" id="{00D3B574-85A6-4354-8905-71DB74BE9CE5}"/>
               </a:ext>
             </a:extLst>
           </p:cNvPr>
@@ -19850,7 +19850,7 @@
           <p:cNvPr id="9" name="">
             <a:extLst xmlns:a="http://schemas.openxmlformats.org/drawingml/2006/main">
               <a:ext uri="{FF2B5EF4-FFF2-40B4-BE49-F238E27FC236}">
-                <a16:creationId xmlns:a16="http://schemas.microsoft.com/office/drawing/2014/main" id="{885434B5-C112-428D-A832-D129DC8B304A}"/>
+                <a16:creationId xmlns:a16="http://schemas.microsoft.com/office/drawing/2014/main" id="{02344247-D05A-48F7-B898-5EFA654D69A3}"/>
               </a:ext>
             </a:extLst>
           </p:cNvPr>
@@ -19970,7 +19970,7 @@
           <p:cNvPr id="10" name="">
             <a:extLst xmlns:a="http://schemas.openxmlformats.org/drawingml/2006/main">
               <a:ext uri="{FF2B5EF4-FFF2-40B4-BE49-F238E27FC236}">
-                <a16:creationId xmlns:a16="http://schemas.microsoft.com/office/drawing/2014/main" id="{0E582115-1DBE-4308-B9F4-31C952CEA6BE}"/>
+                <a16:creationId xmlns:a16="http://schemas.microsoft.com/office/drawing/2014/main" id="{5A826333-8954-4180-9D79-709206253CC0}"/>
               </a:ext>
             </a:extLst>
           </p:cNvPr>
@@ -20002,7 +20002,7 @@
           <p:cNvPr id="11" name="">
             <a:extLst xmlns:a="http://schemas.openxmlformats.org/drawingml/2006/main">
               <a:ext uri="{FF2B5EF4-FFF2-40B4-BE49-F238E27FC236}">
-                <a16:creationId xmlns:a16="http://schemas.microsoft.com/office/drawing/2014/main" id="{711DBFBA-69D2-4444-8E27-FF89BB5C1DE0}"/>
+                <a16:creationId xmlns:a16="http://schemas.microsoft.com/office/drawing/2014/main" id="{410C7038-8DCF-4583-905C-2DCF4502E91B}"/>
               </a:ext>
             </a:extLst>
           </p:cNvPr>
@@ -20122,7 +20122,7 @@
           <p:cNvPr id="12" name="">
             <a:extLst xmlns:a="http://schemas.openxmlformats.org/drawingml/2006/main">
               <a:ext uri="{FF2B5EF4-FFF2-40B4-BE49-F238E27FC236}">
-                <a16:creationId xmlns:a16="http://schemas.microsoft.com/office/drawing/2014/main" id="{DA5EFF4F-8B99-4C01-B012-6D89B7EAA9D7}"/>
+                <a16:creationId xmlns:a16="http://schemas.microsoft.com/office/drawing/2014/main" id="{49D2BDCB-A0D0-4A04-8B92-CCE098440EF7}"/>
               </a:ext>
             </a:extLst>
           </p:cNvPr>
@@ -20242,7 +20242,159 @@
           <p:cNvPr id="13" name="">
             <a:extLst xmlns:a="http://schemas.openxmlformats.org/drawingml/2006/main">
               <a:ext uri="{FF2B5EF4-FFF2-40B4-BE49-F238E27FC236}">
-                <a16:creationId xmlns:a16="http://schemas.microsoft.com/office/drawing/2014/main" id="{A8192813-6761-4CE4-9767-28F5233561D0}"/>
+                <a16:creationId xmlns:a16="http://schemas.microsoft.com/office/drawing/2014/main" id="{E680DCE4-3EFB-4D6D-93A8-945500C99E05}"/>
+              </a:ext>
+            </a:extLst>
+          </p:cNvPr>
+          <p:cNvSpPr>
+            <a:spLocks xmlns:a="http://schemas.openxmlformats.org/drawingml/2006/main" noGrp="1"/>
+          </p:cNvSpPr>
+          <p:nvPr/>
+        </p:nvSpPr>
+        <p:spPr>
+          <a:xfrm xmlns:a="http://schemas.openxmlformats.org/drawingml/2006/main">
+            <a:off x="800100" y="4905375"/>
+            <a:ext cx="2857500" cy="342900"/>
+          </a:xfrm>
+          <a:prstGeom xmlns:a="http://schemas.openxmlformats.org/drawingml/2006/main" prst="roundRect">
+            <a:avLst>
+              <a:gd name="adj" fmla="val 22222"/>
+            </a:avLst>
+          </a:prstGeom>
+          <a:solidFill xmlns:a="http://schemas.openxmlformats.org/drawingml/2006/main">
+            <a:srgbClr val="162A32"/>
+          </a:solidFill>
+          <a:ln xmlns:a="http://schemas.openxmlformats.org/drawingml/2006/main" w="0">
+            <a:noFill/>
+          </a:ln>
+        </p:spPr>
+      </p:sp>
+      <p:sp>
+        <p:nvSpPr>
+          <p:cNvPr id="14" name="">
+            <a:extLst xmlns:a="http://schemas.openxmlformats.org/drawingml/2006/main">
+              <a:ext uri="{FF2B5EF4-FFF2-40B4-BE49-F238E27FC236}">
+                <a16:creationId xmlns:a16="http://schemas.microsoft.com/office/drawing/2014/main" id="{64F50D72-1BBD-49AC-9B2D-365D2E776AA6}"/>
+              </a:ext>
+            </a:extLst>
+          </p:cNvPr>
+          <p:cNvSpPr>
+            <a:spLocks xmlns:a="http://schemas.openxmlformats.org/drawingml/2006/main" noGrp="1"/>
+          </p:cNvSpPr>
+          <p:nvPr/>
+        </p:nvSpPr>
+        <p:spPr>
+          <a:xfrm xmlns:a="http://schemas.openxmlformats.org/drawingml/2006/main">
+            <a:off x="914400" y="4924425"/>
+            <a:ext cx="2628900" cy="285750"/>
+          </a:xfrm>
+          <a:prstGeom xmlns:a="http://schemas.openxmlformats.org/drawingml/2006/main" prst="rect">
+            <a:avLst/>
+          </a:prstGeom>
+          <a:noFill xmlns:a="http://schemas.openxmlformats.org/drawingml/2006/main"/>
+          <a:ln xmlns:a="http://schemas.openxmlformats.org/drawingml/2006/main" w="0">
+            <a:noFill/>
+          </a:ln>
+        </p:spPr>
+        <p:txBody>
+          <a:bodyPr xmlns:a="http://schemas.openxmlformats.org/drawingml/2006/main" anchor="ctr"/>
+          <a:lstStyle xmlns:a="http://schemas.openxmlformats.org/drawingml/2006/main">
+            <a:defPPr algn="ctr">
+              <a:defRPr sz="975" b="1">
+                <a:solidFill>
+                  <a:srgbClr val="FF8A35"/>
+                </a:solidFill>
+              </a:defRPr>
+            </a:defPPr>
+            <a:lvl1pPr algn="ctr">
+              <a:defRPr sz="975" b="1">
+                <a:solidFill>
+                  <a:srgbClr val="FF8A35"/>
+                </a:solidFill>
+              </a:defRPr>
+            </a:lvl1pPr>
+            <a:lvl2pPr algn="ctr">
+              <a:defRPr sz="975" b="1">
+                <a:solidFill>
+                  <a:srgbClr val="FF8A35"/>
+                </a:solidFill>
+              </a:defRPr>
+            </a:lvl2pPr>
+            <a:lvl3pPr algn="ctr">
+              <a:defRPr sz="975" b="1">
+                <a:solidFill>
+                  <a:srgbClr val="FF8A35"/>
+                </a:solidFill>
+              </a:defRPr>
+            </a:lvl3pPr>
+            <a:lvl4pPr algn="ctr">
+              <a:defRPr sz="975" b="1">
+                <a:solidFill>
+                  <a:srgbClr val="FF8A35"/>
+                </a:solidFill>
+              </a:defRPr>
+            </a:lvl4pPr>
+            <a:lvl5pPr algn="ctr">
+              <a:defRPr sz="975" b="1">
+                <a:solidFill>
+                  <a:srgbClr val="FF8A35"/>
+                </a:solidFill>
+              </a:defRPr>
+            </a:lvl5pPr>
+            <a:lvl6pPr algn="ctr">
+              <a:defRPr sz="975" b="1">
+                <a:solidFill>
+                  <a:srgbClr val="FF8A35"/>
+                </a:solidFill>
+              </a:defRPr>
+            </a:lvl6pPr>
+            <a:lvl7pPr algn="ctr">
+              <a:defRPr sz="975" b="1">
+                <a:solidFill>
+                  <a:srgbClr val="FF8A35"/>
+                </a:solidFill>
+              </a:defRPr>
+            </a:lvl7pPr>
+            <a:lvl8pPr algn="ctr">
+              <a:defRPr sz="975" b="1">
+                <a:solidFill>
+                  <a:srgbClr val="FF8A35"/>
+                </a:solidFill>
+              </a:defRPr>
+            </a:lvl8pPr>
+            <a:lvl9pPr algn="ctr">
+              <a:defRPr sz="975" b="1">
+                <a:solidFill>
+                  <a:srgbClr val="FF8A35"/>
+                </a:solidFill>
+              </a:defRPr>
+            </a:lvl9pPr>
+          </a:lstStyle>
+          <a:p xmlns:a="http://schemas.openxmlformats.org/drawingml/2006/main">
+            <a:pPr algn="ctr">
+              <a:defRPr sz="975" b="1">
+                <a:solidFill>
+                  <a:srgbClr val="FF8A35"/>
+                </a:solidFill>
+              </a:defRPr>
+            </a:pPr>
+            <a:r>
+              <a:rPr sz="975" b="1">
+                <a:solidFill>
+                  <a:srgbClr val="FF8A35"/>
+                </a:solidFill>
+              </a:rPr>
+              <a:t>OPEN http://localhost:8090</a:t>
+            </a:r>
+          </a:p>
+        </p:txBody>
+      </p:sp>
+      <p:sp>
+        <p:nvSpPr>
+          <p:cNvPr id="15" name="">
+            <a:extLst xmlns:a="http://schemas.openxmlformats.org/drawingml/2006/main">
+              <a:ext uri="{FF2B5EF4-FFF2-40B4-BE49-F238E27FC236}">
+                <a16:creationId xmlns:a16="http://schemas.microsoft.com/office/drawing/2014/main" id="{24EAAFD6-AFA7-4A58-AC81-723F7C945DDE}"/>
               </a:ext>
             </a:extLst>
           </p:cNvPr>
@@ -20359,10 +20511,10 @@
       </p:sp>
       <p:sp>
         <p:nvSpPr>
-          <p:cNvPr id="14" name="">
+          <p:cNvPr id="16" name="">
             <a:extLst xmlns:a="http://schemas.openxmlformats.org/drawingml/2006/main">
               <a:ext uri="{FF2B5EF4-FFF2-40B4-BE49-F238E27FC236}">
-                <a16:creationId xmlns:a16="http://schemas.microsoft.com/office/drawing/2014/main" id="{0A05B7D1-E10B-4B14-BB3A-6E617F32BEBB}"/>
+                <a16:creationId xmlns:a16="http://schemas.microsoft.com/office/drawing/2014/main" id="{580BEA76-D538-405E-82BD-D464F74E0EBC}"/>
               </a:ext>
             </a:extLst>
           </p:cNvPr>
@@ -20480,7 +20632,7 @@
     </p:spTree>
     <p:extLst>
       <p:ext uri="{BB962C8B-B14F-4D97-AF65-F5344CB8AC3E}">
-        <p14:creationId xmlns:p14="http://schemas.microsoft.com/office/powerpoint/2010/main" val="2138862117"/>
+        <p14:creationId xmlns:p14="http://schemas.microsoft.com/office/powerpoint/2010/main" val="1419175749"/>
       </p:ext>
     </p:extLst>
   </p:cSld>

</xml_diff>

<commit_message>
Finalize the 17-slide presentation (PDF and PPTX)
- Slide 6: 98 simulator/API/evidence tests; complete 11-twin snapshot
  published every 5 s, frontend polls every 2 s; 20x simulation speed.
- Slide 7: architecture shows the 5 s publication cycle and the 2 s
  frontend poll separately.
- Slide 14: 146 tests passed (98 simulator/API/evidence + 48 data) and
  the clean Ubuntu 24.04 AMD64 verification: 3 min 33 s full-stack
  startup, Eclipse Ditto and 11 twins, scenario matrix and Smart
  Dispatch, Docker restart and post-restart smoke.

presentation.pdf is exported from presentation.pptx, so both hold the
same 17 slides.

Co-Authored-By: Claude Opus 5.5 <noreply@anthropic.com>
</commit_message>
<xml_diff>
--- a/presentation.pptx
+++ b/presentation.pptx
@@ -123,7 +123,7 @@
   <p:extLst>
     <p:ext uri="{521415D9-36F7-43E2-AB2F-B90AF26B5E84}">
       <p14:sectionLst xmlns:p14="http://schemas.microsoft.com/office/powerpoint/2010/main">
-        <p14:section name="Introduction" id="{54b98009-e25a-20f9-c254-21573bb94308}">
+        <p14:section name="Introduction" id="{bf44d7da-edd1-9178-4f2f-1407f90903a2}">
           <p14:sldIdLst>
             <p14:sldId id="256"/>
             <p14:sldId id="257"/>
@@ -131,12 +131,12 @@
             <p14:sldId id="259"/>
           </p14:sldIdLst>
         </p14:section>
-        <p14:section name="Purpose" id="{b09db582-9948-8765-cae6-f213b1bbf6b4}">
+        <p14:section name="Purpose" id="{d2716a25-1fae-608e-527a-cedb34ebf175}">
           <p14:sldIdLst>
             <p14:sldId id="260"/>
           </p14:sldIdLst>
         </p14:section>
-        <p14:section name="Tasks" id="{41fa2b80-da64-911d-7b16-2356e7647f34}">
+        <p14:section name="Tasks" id="{52cd4063-780e-dbf6-65b4-1040756ccdd1}">
           <p14:sldIdLst>
             <p14:sldId id="261"/>
             <p14:sldId id="262"/>
@@ -144,7 +144,7 @@
             <p14:sldId id="264"/>
           </p14:sldIdLst>
         </p14:section>
-        <p14:section name="Results" id="{d07d48dc-7af9-238a-7f87-3374bc427bd7}">
+        <p14:section name="Results" id="{038c8241-eb33-6090-9000-61bb523433b1}">
           <p14:sldIdLst>
             <p14:sldId id="265"/>
             <p14:sldId id="266"/>
@@ -153,13 +153,13 @@
             <p14:sldId id="269"/>
           </p14:sldIdLst>
         </p14:section>
-        <p14:section name="Outcome" id="{ffa0fed3-8173-d47d-be75-3f5881496296}">
+        <p14:section name="Outcome" id="{d72cda6d-1eb7-23c6-2122-dd23d28ccbf4}">
           <p14:sldIdLst>
             <p14:sldId id="270"/>
             <p14:sldId id="271"/>
           </p14:sldIdLst>
         </p14:section>
-        <p14:section name="Conclusion" id="{c94159b1-8053-9565-7d68-9e7d7483f5e0}">
+        <p14:section name="Conclusion" id="{6bf2d992-55bc-db10-f696-3b1f044461cf}">
           <p14:sldIdLst>
             <p14:sldId id="272"/>
           </p14:sldIdLst>
@@ -568,7 +568,7 @@
           <a:p>
             <a:r>
               <a:rPr lang="en-US" dirty="0"/>
-              <a:t>Title page. Project: North Pit Digital Twin, team Ademix, authors Ahmad Shah Yawar and Gulzat Turken. The picture is a real capture of the running stand, not a render: everything on it is twin state returned through Eclipse Ditto every two seconds.</a:t>
+              <a:t>Title page. Project: North Pit Digital Twin, team Ademix, authors Ahmad Shah Yawar and Gulzat Turken. The picture is a real capture of the running stand, not a render: everything on it is twin state returned through Eclipse Ditto: the simulator publishes a complete 11-twin snapshot every 5 s and the frontend polls every 2 s.</a:t>
             </a:r>
             <a:endParaRPr lang="en-US" dirty="0"/>
           </a:p>
@@ -1008,7 +1008,7 @@
           <a:p>
             <a:r>
               <a:rPr lang="en-US" dirty="0"/>
-              <a:t>Sources: smoke_check.py (Ditto source, 11 twins, 143 fields and units); verify_scenarios.py (fixed and Smart Dispatch with baseline, breakdown, road restriction and crusher slowdown, then reset with no stale breakdown, blockage or standby state); the engine’s four-part mass balance, which stays at zero in every scenario; fixed_vs_smart.json and production_recovery.json for the savings and the breakdown cost.</a:t>
+              <a:t>Clean Ubuntu 24.04 AMD64 run: full stack started in 3 min 33 s; Eclipse Ditto and all 11 twins verified; the full scenario matrix and Smart Dispatch passed; Docker restart and the post-restart smoke passed. Test suites: 98 simulator, API and evidence tests and 48 data tests, 146 passed. Sources: smoke_check.py (Ditto source, 11 twins, 143 fields and units); verify_scenarios.py (fixed and Smart Dispatch with baseline, breakdown, road restriction and crusher slowdown, then reset with no stale breakdown, blockage or standby state); the engine’s four-part mass balance, which stays at zero in every scenario; fixed_vs_smart.json and production_recovery.json for the savings and the breakdown cost.</a:t>
             </a:r>
             <a:endParaRPr lang="en-US" dirty="0"/>
           </a:p>
@@ -8831,12 +8831,12 @@
         </p:nvSpPr>
         <p:spPr>
           <a:xfrm>
-            <a:off x="685800" y="1737360"/>
-            <a:ext cx="3423818" cy="1691640"/>
+            <a:off x="685800" y="1600200"/>
+            <a:ext cx="3423818" cy="1298448"/>
           </a:xfrm>
           <a:prstGeom prst="roundRect">
             <a:avLst>
-              <a:gd name="adj" fmla="val 4324"/>
+              <a:gd name="adj" fmla="val 5634"/>
             </a:avLst>
           </a:prstGeom>
           <a:solidFill>
@@ -8858,8 +8858,8 @@
         </p:nvSpPr>
         <p:spPr>
           <a:xfrm>
-            <a:off x="960120" y="1920240"/>
-            <a:ext cx="2875178" cy="640080"/>
+            <a:off x="960120" y="1728216"/>
+            <a:ext cx="2875178" cy="502920"/>
           </a:xfrm>
           <a:prstGeom prst="rect">
             <a:avLst/>
@@ -8878,7 +8878,7 @@
               <a:buNone/>
             </a:pPr>
             <a:r>
-              <a:rPr lang="en-US" sz="3600" b="1" dirty="0">
+              <a:rPr lang="en-US" sz="3000" b="1" dirty="0">
                 <a:solidFill>
                   <a:srgbClr val="14201C"/>
                 </a:solidFill>
@@ -8888,7 +8888,7 @@
               </a:rPr>
               <a:t>143</a:t>
             </a:r>
-            <a:endParaRPr lang="en-US" sz="3600" dirty="0"/>
+            <a:endParaRPr lang="en-US" sz="3000" dirty="0"/>
           </a:p>
         </p:txBody>
       </p:sp>
@@ -8900,8 +8900,8 @@
         </p:nvSpPr>
         <p:spPr>
           <a:xfrm>
-            <a:off x="960120" y="2606040"/>
-            <a:ext cx="2875178" cy="731520"/>
+            <a:off x="960120" y="2258568"/>
+            <a:ext cx="2875178" cy="566928"/>
           </a:xfrm>
           <a:prstGeom prst="rect">
             <a:avLst/>
@@ -8920,7 +8920,7 @@
               <a:buNone/>
             </a:pPr>
             <a:r>
-              <a:rPr lang="en-US" sz="1400" dirty="0">
+              <a:rPr lang="en-US" sz="1300" dirty="0">
                 <a:solidFill>
                   <a:srgbClr val="3F4E49"/>
                 </a:solidFill>
@@ -8930,7 +8930,7 @@
               </a:rPr>
               <a:t>required fields with units across 11 Eclipse Ditto twins, all returned live</a:t>
             </a:r>
-            <a:endParaRPr lang="en-US" sz="1400" dirty="0"/>
+            <a:endParaRPr lang="en-US" sz="1300" dirty="0"/>
           </a:p>
         </p:txBody>
       </p:sp>
@@ -8942,12 +8942,12 @@
         </p:nvSpPr>
         <p:spPr>
           <a:xfrm>
-            <a:off x="4383938" y="1737360"/>
-            <a:ext cx="3423818" cy="1691640"/>
+            <a:off x="4383938" y="1600200"/>
+            <a:ext cx="3423818" cy="1298448"/>
           </a:xfrm>
           <a:prstGeom prst="roundRect">
             <a:avLst>
-              <a:gd name="adj" fmla="val 4324"/>
+              <a:gd name="adj" fmla="val 5634"/>
             </a:avLst>
           </a:prstGeom>
           <a:solidFill>
@@ -8969,8 +8969,8 @@
         </p:nvSpPr>
         <p:spPr>
           <a:xfrm>
-            <a:off x="4658258" y="1920240"/>
-            <a:ext cx="2875178" cy="640080"/>
+            <a:off x="4658258" y="1728216"/>
+            <a:ext cx="2875178" cy="502920"/>
           </a:xfrm>
           <a:prstGeom prst="rect">
             <a:avLst/>
@@ -8989,7 +8989,7 @@
               <a:buNone/>
             </a:pPr>
             <a:r>
-              <a:rPr lang="en-US" sz="3600" b="1" dirty="0">
+              <a:rPr lang="en-US" sz="3000" b="1" dirty="0">
                 <a:solidFill>
                   <a:srgbClr val="14201C"/>
                 </a:solidFill>
@@ -8999,7 +8999,7 @@
               </a:rPr>
               <a:t>8 of 8</a:t>
             </a:r>
-            <a:endParaRPr lang="en-US" sz="3600" dirty="0"/>
+            <a:endParaRPr lang="en-US" sz="3000" dirty="0"/>
           </a:p>
         </p:txBody>
       </p:sp>
@@ -9011,8 +9011,8 @@
         </p:nvSpPr>
         <p:spPr>
           <a:xfrm>
-            <a:off x="4658258" y="2606040"/>
-            <a:ext cx="2875178" cy="731520"/>
+            <a:off x="4658258" y="2258568"/>
+            <a:ext cx="2875178" cy="566928"/>
           </a:xfrm>
           <a:prstGeom prst="rect">
             <a:avLst/>
@@ -9031,7 +9031,7 @@
               <a:buNone/>
             </a:pPr>
             <a:r>
-              <a:rPr lang="en-US" sz="1400" dirty="0">
+              <a:rPr lang="en-US" sz="1300" dirty="0">
                 <a:solidFill>
                   <a:srgbClr val="3F4E49"/>
                 </a:solidFill>
@@ -9041,7 +9041,7 @@
               </a:rPr>
               <a:t>fixed and Smart runs across all four conditions pass live, then reset cleanly</a:t>
             </a:r>
-            <a:endParaRPr lang="en-US" sz="1400" dirty="0"/>
+            <a:endParaRPr lang="en-US" sz="1300" dirty="0"/>
           </a:p>
         </p:txBody>
       </p:sp>
@@ -9053,12 +9053,12 @@
         </p:nvSpPr>
         <p:spPr>
           <a:xfrm>
-            <a:off x="8082077" y="1737360"/>
-            <a:ext cx="3423818" cy="1691640"/>
+            <a:off x="8082077" y="1600200"/>
+            <a:ext cx="3423818" cy="1298448"/>
           </a:xfrm>
           <a:prstGeom prst="roundRect">
             <a:avLst>
-              <a:gd name="adj" fmla="val 4324"/>
+              <a:gd name="adj" fmla="val 5634"/>
             </a:avLst>
           </a:prstGeom>
           <a:solidFill>
@@ -9080,8 +9080,8 @@
         </p:nvSpPr>
         <p:spPr>
           <a:xfrm>
-            <a:off x="8356397" y="1920240"/>
-            <a:ext cx="2875178" cy="640080"/>
+            <a:off x="8356397" y="1728216"/>
+            <a:ext cx="2875178" cy="502920"/>
           </a:xfrm>
           <a:prstGeom prst="rect">
             <a:avLst/>
@@ -9100,7 +9100,7 @@
               <a:buNone/>
             </a:pPr>
             <a:r>
-              <a:rPr lang="en-US" sz="3600" b="1" dirty="0">
+              <a:rPr lang="en-US" sz="3000" b="1" dirty="0">
                 <a:solidFill>
                   <a:srgbClr val="14201C"/>
                 </a:solidFill>
@@ -9110,7 +9110,7 @@
               </a:rPr>
               <a:t>0 t</a:t>
             </a:r>
-            <a:endParaRPr lang="en-US" sz="3600" dirty="0"/>
+            <a:endParaRPr lang="en-US" sz="3000" dirty="0"/>
           </a:p>
         </p:txBody>
       </p:sp>
@@ -9122,8 +9122,8 @@
         </p:nvSpPr>
         <p:spPr>
           <a:xfrm>
-            <a:off x="8356397" y="2606040"/>
-            <a:ext cx="2875178" cy="731520"/>
+            <a:off x="8356397" y="2258568"/>
+            <a:ext cx="2875178" cy="566928"/>
           </a:xfrm>
           <a:prstGeom prst="rect">
             <a:avLst/>
@@ -9142,7 +9142,7 @@
               <a:buNone/>
             </a:pPr>
             <a:r>
-              <a:rPr lang="en-US" sz="1400" dirty="0">
+              <a:rPr lang="en-US" sz="1300" dirty="0">
                 <a:solidFill>
                   <a:srgbClr val="3F4E49"/>
                 </a:solidFill>
@@ -9152,7 +9152,7 @@
               </a:rPr>
               <a:t>ore mass-balance error in every scenario: no tonne created or lost</a:t>
             </a:r>
-            <a:endParaRPr lang="en-US" sz="1400" dirty="0"/>
+            <a:endParaRPr lang="en-US" sz="1300" dirty="0"/>
           </a:p>
         </p:txBody>
       </p:sp>
@@ -9164,12 +9164,12 @@
         </p:nvSpPr>
         <p:spPr>
           <a:xfrm>
-            <a:off x="685800" y="3685032"/>
-            <a:ext cx="3423818" cy="1691640"/>
+            <a:off x="685800" y="3081528"/>
+            <a:ext cx="3423818" cy="1298448"/>
           </a:xfrm>
           <a:prstGeom prst="roundRect">
             <a:avLst>
-              <a:gd name="adj" fmla="val 4324"/>
+              <a:gd name="adj" fmla="val 5634"/>
             </a:avLst>
           </a:prstGeom>
           <a:solidFill>
@@ -9191,8 +9191,8 @@
         </p:nvSpPr>
         <p:spPr>
           <a:xfrm>
-            <a:off x="960120" y="3867912"/>
-            <a:ext cx="2875178" cy="640080"/>
+            <a:off x="960120" y="3209544"/>
+            <a:ext cx="2875178" cy="502920"/>
           </a:xfrm>
           <a:prstGeom prst="rect">
             <a:avLst/>
@@ -9211,7 +9211,7 @@
               <a:buNone/>
             </a:pPr>
             <a:r>
-              <a:rPr lang="en-US" sz="3600" b="1" dirty="0">
+              <a:rPr lang="en-US" sz="3000" b="1" dirty="0">
                 <a:solidFill>
                   <a:srgbClr val="0F7D72"/>
                 </a:solidFill>
@@ -9221,7 +9221,7 @@
               </a:rPr>
               <a:t>−33 %</a:t>
             </a:r>
-            <a:endParaRPr lang="en-US" sz="3600" dirty="0"/>
+            <a:endParaRPr lang="en-US" sz="3000" dirty="0"/>
           </a:p>
         </p:txBody>
       </p:sp>
@@ -9233,8 +9233,8 @@
         </p:nvSpPr>
         <p:spPr>
           <a:xfrm>
-            <a:off x="960120" y="4553712"/>
-            <a:ext cx="2875178" cy="731520"/>
+            <a:off x="960120" y="3739896"/>
+            <a:ext cx="2875178" cy="566928"/>
           </a:xfrm>
           <a:prstGeom prst="rect">
             <a:avLst/>
@@ -9253,7 +9253,7 @@
               <a:buNone/>
             </a:pPr>
             <a:r>
-              <a:rPr lang="en-US" sz="1400" dirty="0">
+              <a:rPr lang="en-US" sz="1300" dirty="0">
                 <a:solidFill>
                   <a:srgbClr val="3F4E49"/>
                 </a:solidFill>
@@ -9263,7 +9263,7 @@
               </a:rPr>
               <a:t>truck-hours per 1,000 t at the same 770 t/h; −50 % under crusher slowdown</a:t>
             </a:r>
-            <a:endParaRPr lang="en-US" sz="1400" dirty="0"/>
+            <a:endParaRPr lang="en-US" sz="1300" dirty="0"/>
           </a:p>
         </p:txBody>
       </p:sp>
@@ -9275,12 +9275,12 @@
         </p:nvSpPr>
         <p:spPr>
           <a:xfrm>
-            <a:off x="4383938" y="3685032"/>
-            <a:ext cx="3423818" cy="1691640"/>
+            <a:off x="4383938" y="3081528"/>
+            <a:ext cx="3423818" cy="1298448"/>
           </a:xfrm>
           <a:prstGeom prst="roundRect">
             <a:avLst>
-              <a:gd name="adj" fmla="val 4324"/>
+              <a:gd name="adj" fmla="val 5634"/>
             </a:avLst>
           </a:prstGeom>
           <a:solidFill>
@@ -9302,8 +9302,8 @@
         </p:nvSpPr>
         <p:spPr>
           <a:xfrm>
-            <a:off x="4658258" y="3867912"/>
-            <a:ext cx="2875178" cy="640080"/>
+            <a:off x="4658258" y="3209544"/>
+            <a:ext cx="2875178" cy="502920"/>
           </a:xfrm>
           <a:prstGeom prst="rect">
             <a:avLst/>
@@ -9322,7 +9322,7 @@
               <a:buNone/>
             </a:pPr>
             <a:r>
-              <a:rPr lang="en-US" sz="3600" b="1" dirty="0">
+              <a:rPr lang="en-US" sz="3000" b="1" dirty="0">
                 <a:solidFill>
                   <a:srgbClr val="0F7D72"/>
                 </a:solidFill>
@@ -9332,7 +9332,7 @@
               </a:rPr>
               <a:t>−79 t</a:t>
             </a:r>
-            <a:endParaRPr lang="en-US" sz="3600" dirty="0"/>
+            <a:endParaRPr lang="en-US" sz="3000" dirty="0"/>
           </a:p>
         </p:txBody>
       </p:sp>
@@ -9344,8 +9344,8 @@
         </p:nvSpPr>
         <p:spPr>
           <a:xfrm>
-            <a:off x="4658258" y="4553712"/>
-            <a:ext cx="2875178" cy="731520"/>
+            <a:off x="4658258" y="3739896"/>
+            <a:ext cx="2875178" cy="566928"/>
           </a:xfrm>
           <a:prstGeom prst="rect">
             <a:avLst/>
@@ -9364,7 +9364,7 @@
               <a:buNone/>
             </a:pPr>
             <a:r>
-              <a:rPr lang="en-US" sz="1400" dirty="0">
+              <a:rPr lang="en-US" sz="1300" dirty="0">
                 <a:solidFill>
                   <a:srgbClr val="3F4E49"/>
                 </a:solidFill>
@@ -9374,7 +9374,7 @@
               </a:rPr>
               <a:t>total cost of a breakdown over 3 h, then output returns to 770 t/h</a:t>
             </a:r>
-            <a:endParaRPr lang="en-US" sz="1400" dirty="0"/>
+            <a:endParaRPr lang="en-US" sz="1300" dirty="0"/>
           </a:p>
         </p:txBody>
       </p:sp>
@@ -9386,12 +9386,12 @@
         </p:nvSpPr>
         <p:spPr>
           <a:xfrm>
-            <a:off x="8082077" y="3685032"/>
-            <a:ext cx="3423818" cy="1691640"/>
+            <a:off x="8082077" y="3081528"/>
+            <a:ext cx="3423818" cy="1298448"/>
           </a:xfrm>
           <a:prstGeom prst="roundRect">
             <a:avLst>
-              <a:gd name="adj" fmla="val 4324"/>
+              <a:gd name="adj" fmla="val 5634"/>
             </a:avLst>
           </a:prstGeom>
           <a:solidFill>
@@ -9413,8 +9413,8 @@
         </p:nvSpPr>
         <p:spPr>
           <a:xfrm>
-            <a:off x="8356397" y="3867912"/>
-            <a:ext cx="2875178" cy="640080"/>
+            <a:off x="8356397" y="3209544"/>
+            <a:ext cx="2875178" cy="502920"/>
           </a:xfrm>
           <a:prstGeom prst="rect">
             <a:avLst/>
@@ -9433,7 +9433,7 @@
               <a:buNone/>
             </a:pPr>
             <a:r>
-              <a:rPr lang="en-US" sz="3600" b="1" dirty="0">
+              <a:rPr lang="en-US" sz="3000" b="1" dirty="0">
                 <a:solidFill>
                   <a:srgbClr val="14201C"/>
                 </a:solidFill>
@@ -9441,9 +9441,9 @@
                 <a:ea typeface="Calibri" pitchFamily="34" charset="-122"/>
                 <a:cs typeface="Calibri" pitchFamily="34" charset="-120"/>
               </a:rPr>
-              <a:t>140</a:t>
-            </a:r>
-            <a:endParaRPr lang="en-US" sz="3600" dirty="0"/>
+              <a:t>146</a:t>
+            </a:r>
+            <a:endParaRPr lang="en-US" sz="3000" dirty="0"/>
           </a:p>
         </p:txBody>
       </p:sp>
@@ -9455,8 +9455,8 @@
         </p:nvSpPr>
         <p:spPr>
           <a:xfrm>
-            <a:off x="8356397" y="4553712"/>
-            <a:ext cx="2875178" cy="731520"/>
+            <a:off x="8356397" y="3739896"/>
+            <a:ext cx="2875178" cy="566928"/>
           </a:xfrm>
           <a:prstGeom prst="rect">
             <a:avLst/>
@@ -9475,7 +9475,7 @@
               <a:buNone/>
             </a:pPr>
             <a:r>
-              <a:rPr lang="en-US" sz="1400" dirty="0">
+              <a:rPr lang="en-US" sz="1300" dirty="0">
                 <a:solidFill>
                   <a:srgbClr val="3F4E49"/>
                 </a:solidFill>
@@ -9483,22 +9483,49 @@
                 <a:ea typeface="Calibri" pitchFamily="34" charset="-122"/>
                 <a:cs typeface="Calibri" pitchFamily="34" charset="-120"/>
               </a:rPr>
-              <a:t>automated tests: 92 simulator and API, 48 data and evidence</a:t>
-            </a:r>
-            <a:endParaRPr lang="en-US" sz="1400" dirty="0"/>
-          </a:p>
-        </p:txBody>
-      </p:sp>
-      <p:sp>
-        <p:nvSpPr>
-          <p:cNvPr id="22" name="Text 20"/>
+              <a:t>tests passed: 98 simulator, API and evidence, plus 48 data tests</a:t>
+            </a:r>
+            <a:endParaRPr lang="en-US" sz="1300" dirty="0"/>
+          </a:p>
+        </p:txBody>
+      </p:sp>
+      <p:sp>
+        <p:nvSpPr>
+          <p:cNvPr id="22" name="Shape 20"/>
+          <p:cNvSpPr/>
+          <p:nvPr/>
+        </p:nvSpPr>
+        <p:spPr>
+          <a:xfrm>
+            <a:off x="685800" y="4581144"/>
+            <a:ext cx="10820095" cy="1371600"/>
+          </a:xfrm>
+          <a:prstGeom prst="roundRect">
+            <a:avLst>
+              <a:gd name="adj" fmla="val 5333"/>
+            </a:avLst>
+          </a:prstGeom>
+          <a:solidFill>
+            <a:srgbClr val="FBF9F4"/>
+          </a:solidFill>
+          <a:ln w="9525">
+            <a:solidFill>
+              <a:srgbClr val="0F7D72"/>
+            </a:solidFill>
+            <a:prstDash val="solid"/>
+          </a:ln>
+        </p:spPr>
+      </p:sp>
+      <p:sp>
+        <p:nvSpPr>
+          <p:cNvPr id="23" name="Text 21"/>
           <p:cNvSpPr txBox="1"/>
           <p:nvPr/>
         </p:nvSpPr>
         <p:spPr>
           <a:xfrm>
-            <a:off x="685800" y="5760720"/>
-            <a:ext cx="10820095" cy="274320"/>
+            <a:off x="960120" y="4745736"/>
+            <a:ext cx="2743200" cy="1005840"/>
           </a:xfrm>
           <a:prstGeom prst="rect">
             <a:avLst/>
@@ -9507,7 +9534,7 @@
           <a:ln/>
         </p:spPr>
         <p:txBody>
-          <a:bodyPr wrap="square" lIns="0" tIns="0" rIns="0" bIns="0" rtlCol="0" anchor="t"/>
+          <a:bodyPr wrap="square" lIns="0" tIns="0" rIns="0" bIns="0" rtlCol="0" anchor="ctr"/>
           <a:lstStyle/>
           <a:p>
             <a:pPr indent="0" marL="0">
@@ -9517,15 +9544,393 @@
               <a:buNone/>
             </a:pPr>
             <a:r>
-              <a:rPr lang="en-US" sz="1200" dirty="0">
-                <a:solidFill>
-                  <a:srgbClr val="5E6D68"/>
+              <a:rPr lang="en-US" sz="1600" b="1" dirty="0">
+                <a:solidFill>
+                  <a:srgbClr val="0F7D72"/>
                 </a:solidFill>
                 <a:latin typeface="Calibri" pitchFamily="34" charset="0"/>
                 <a:ea typeface="Calibri" pitchFamily="34" charset="-122"/>
                 <a:cs typeface="Calibri" pitchFamily="34" charset="-120"/>
               </a:rPr>
-              <a:t>Live checks from integration runs of the combined build; savings and losses are model results, not mine measurements.</a:t>
+              <a:t>Clean Ubuntu 24.04 AMD64 verification</a:t>
+            </a:r>
+            <a:endParaRPr lang="en-US" sz="1600" dirty="0"/>
+          </a:p>
+        </p:txBody>
+      </p:sp>
+      <p:sp>
+        <p:nvSpPr>
+          <p:cNvPr id="24" name="Text 22"/>
+          <p:cNvSpPr txBox="1"/>
+          <p:nvPr/>
+        </p:nvSpPr>
+        <p:spPr>
+          <a:xfrm>
+            <a:off x="3931920" y="4800600"/>
+            <a:ext cx="1619174" cy="411480"/>
+          </a:xfrm>
+          <a:prstGeom prst="rect">
+            <a:avLst/>
+          </a:prstGeom>
+          <a:noFill/>
+          <a:ln/>
+        </p:spPr>
+        <p:txBody>
+          <a:bodyPr wrap="square" lIns="0" tIns="0" rIns="0" bIns="0" rtlCol="0" anchor="t"/>
+          <a:lstStyle/>
+          <a:p>
+            <a:pPr indent="0" marL="0">
+              <a:lnSpc>
+                <a:spcPct val="112000"/>
+              </a:lnSpc>
+              <a:buNone/>
+            </a:pPr>
+            <a:r>
+              <a:rPr lang="en-US" sz="2200" b="1" dirty="0">
+                <a:solidFill>
+                  <a:srgbClr val="14201C"/>
+                </a:solidFill>
+                <a:latin typeface="Calibri" pitchFamily="34" charset="0"/>
+                <a:ea typeface="Calibri" pitchFamily="34" charset="-122"/>
+                <a:cs typeface="Calibri" pitchFamily="34" charset="-120"/>
+              </a:rPr>
+              <a:t>3 min 33 s</a:t>
+            </a:r>
+            <a:endParaRPr lang="en-US" sz="2200" dirty="0"/>
+          </a:p>
+        </p:txBody>
+      </p:sp>
+      <p:sp>
+        <p:nvSpPr>
+          <p:cNvPr id="25" name="Text 23"/>
+          <p:cNvSpPr txBox="1"/>
+          <p:nvPr/>
+        </p:nvSpPr>
+        <p:spPr>
+          <a:xfrm>
+            <a:off x="3931920" y="5257800"/>
+            <a:ext cx="1619174" cy="548640"/>
+          </a:xfrm>
+          <a:prstGeom prst="rect">
+            <a:avLst/>
+          </a:prstGeom>
+          <a:noFill/>
+          <a:ln/>
+        </p:spPr>
+        <p:txBody>
+          <a:bodyPr wrap="square" lIns="0" tIns="0" rIns="0" bIns="0" rtlCol="0" anchor="t"/>
+          <a:lstStyle/>
+          <a:p>
+            <a:pPr indent="0" marL="0">
+              <a:lnSpc>
+                <a:spcPct val="112000"/>
+              </a:lnSpc>
+              <a:buNone/>
+            </a:pPr>
+            <a:r>
+              <a:rPr lang="en-US" sz="1300" dirty="0">
+                <a:solidFill>
+                  <a:srgbClr val="3F4E49"/>
+                </a:solidFill>
+                <a:latin typeface="Calibri" pitchFamily="34" charset="0"/>
+                <a:ea typeface="Calibri" pitchFamily="34" charset="-122"/>
+                <a:cs typeface="Calibri" pitchFamily="34" charset="-120"/>
+              </a:rPr>
+              <a:t>full-stack startup</a:t>
+            </a:r>
+            <a:endParaRPr lang="en-US" sz="1300" dirty="0"/>
+          </a:p>
+        </p:txBody>
+      </p:sp>
+      <p:sp>
+        <p:nvSpPr>
+          <p:cNvPr id="26" name="Text 24"/>
+          <p:cNvSpPr txBox="1"/>
+          <p:nvPr/>
+        </p:nvSpPr>
+        <p:spPr>
+          <a:xfrm>
+            <a:off x="5779694" y="4800600"/>
+            <a:ext cx="1619174" cy="411480"/>
+          </a:xfrm>
+          <a:prstGeom prst="rect">
+            <a:avLst/>
+          </a:prstGeom>
+          <a:noFill/>
+          <a:ln/>
+        </p:spPr>
+        <p:txBody>
+          <a:bodyPr wrap="square" lIns="0" tIns="0" rIns="0" bIns="0" rtlCol="0" anchor="t"/>
+          <a:lstStyle/>
+          <a:p>
+            <a:pPr indent="0" marL="0">
+              <a:lnSpc>
+                <a:spcPct val="112000"/>
+              </a:lnSpc>
+              <a:buNone/>
+            </a:pPr>
+            <a:r>
+              <a:rPr lang="en-US" sz="2200" b="1" dirty="0">
+                <a:solidFill>
+                  <a:srgbClr val="14201C"/>
+                </a:solidFill>
+                <a:latin typeface="Calibri" pitchFamily="34" charset="0"/>
+                <a:ea typeface="Calibri" pitchFamily="34" charset="-122"/>
+                <a:cs typeface="Calibri" pitchFamily="34" charset="-120"/>
+              </a:rPr>
+              <a:t>11 twins</a:t>
+            </a:r>
+            <a:endParaRPr lang="en-US" sz="2200" dirty="0"/>
+          </a:p>
+        </p:txBody>
+      </p:sp>
+      <p:sp>
+        <p:nvSpPr>
+          <p:cNvPr id="27" name="Text 25"/>
+          <p:cNvSpPr txBox="1"/>
+          <p:nvPr/>
+        </p:nvSpPr>
+        <p:spPr>
+          <a:xfrm>
+            <a:off x="5779694" y="5257800"/>
+            <a:ext cx="1619174" cy="548640"/>
+          </a:xfrm>
+          <a:prstGeom prst="rect">
+            <a:avLst/>
+          </a:prstGeom>
+          <a:noFill/>
+          <a:ln/>
+        </p:spPr>
+        <p:txBody>
+          <a:bodyPr wrap="square" lIns="0" tIns="0" rIns="0" bIns="0" rtlCol="0" anchor="t"/>
+          <a:lstStyle/>
+          <a:p>
+            <a:pPr indent="0" marL="0">
+              <a:lnSpc>
+                <a:spcPct val="112000"/>
+              </a:lnSpc>
+              <a:buNone/>
+            </a:pPr>
+            <a:r>
+              <a:rPr lang="en-US" sz="1300" dirty="0">
+                <a:solidFill>
+                  <a:srgbClr val="3F4E49"/>
+                </a:solidFill>
+                <a:latin typeface="Calibri" pitchFamily="34" charset="0"/>
+                <a:ea typeface="Calibri" pitchFamily="34" charset="-122"/>
+                <a:cs typeface="Calibri" pitchFamily="34" charset="-120"/>
+              </a:rPr>
+              <a:t>Eclipse Ditto integration verified</a:t>
+            </a:r>
+            <a:endParaRPr lang="en-US" sz="1300" dirty="0"/>
+          </a:p>
+        </p:txBody>
+      </p:sp>
+      <p:sp>
+        <p:nvSpPr>
+          <p:cNvPr id="28" name="Text 26"/>
+          <p:cNvSpPr txBox="1"/>
+          <p:nvPr/>
+        </p:nvSpPr>
+        <p:spPr>
+          <a:xfrm>
+            <a:off x="7627468" y="4800600"/>
+            <a:ext cx="1619174" cy="411480"/>
+          </a:xfrm>
+          <a:prstGeom prst="rect">
+            <a:avLst/>
+          </a:prstGeom>
+          <a:noFill/>
+          <a:ln/>
+        </p:spPr>
+        <p:txBody>
+          <a:bodyPr wrap="square" lIns="0" tIns="0" rIns="0" bIns="0" rtlCol="0" anchor="t"/>
+          <a:lstStyle/>
+          <a:p>
+            <a:pPr indent="0" marL="0">
+              <a:lnSpc>
+                <a:spcPct val="112000"/>
+              </a:lnSpc>
+              <a:buNone/>
+            </a:pPr>
+            <a:r>
+              <a:rPr lang="en-US" sz="2200" b="1" dirty="0">
+                <a:solidFill>
+                  <a:srgbClr val="14201C"/>
+                </a:solidFill>
+                <a:latin typeface="Calibri" pitchFamily="34" charset="0"/>
+                <a:ea typeface="Calibri" pitchFamily="34" charset="-122"/>
+                <a:cs typeface="Calibri" pitchFamily="34" charset="-120"/>
+              </a:rPr>
+              <a:t>Passed</a:t>
+            </a:r>
+            <a:endParaRPr lang="en-US" sz="2200" dirty="0"/>
+          </a:p>
+        </p:txBody>
+      </p:sp>
+      <p:sp>
+        <p:nvSpPr>
+          <p:cNvPr id="29" name="Text 27"/>
+          <p:cNvSpPr txBox="1"/>
+          <p:nvPr/>
+        </p:nvSpPr>
+        <p:spPr>
+          <a:xfrm>
+            <a:off x="7627468" y="5257800"/>
+            <a:ext cx="1619174" cy="548640"/>
+          </a:xfrm>
+          <a:prstGeom prst="rect">
+            <a:avLst/>
+          </a:prstGeom>
+          <a:noFill/>
+          <a:ln/>
+        </p:spPr>
+        <p:txBody>
+          <a:bodyPr wrap="square" lIns="0" tIns="0" rIns="0" bIns="0" rtlCol="0" anchor="t"/>
+          <a:lstStyle/>
+          <a:p>
+            <a:pPr indent="0" marL="0">
+              <a:lnSpc>
+                <a:spcPct val="112000"/>
+              </a:lnSpc>
+              <a:buNone/>
+            </a:pPr>
+            <a:r>
+              <a:rPr lang="en-US" sz="1300" dirty="0">
+                <a:solidFill>
+                  <a:srgbClr val="3F4E49"/>
+                </a:solidFill>
+                <a:latin typeface="Calibri" pitchFamily="34" charset="0"/>
+                <a:ea typeface="Calibri" pitchFamily="34" charset="-122"/>
+                <a:cs typeface="Calibri" pitchFamily="34" charset="-120"/>
+              </a:rPr>
+              <a:t>full scenario matrix and Smart Dispatch</a:t>
+            </a:r>
+            <a:endParaRPr lang="en-US" sz="1300" dirty="0"/>
+          </a:p>
+        </p:txBody>
+      </p:sp>
+      <p:sp>
+        <p:nvSpPr>
+          <p:cNvPr id="30" name="Text 28"/>
+          <p:cNvSpPr txBox="1"/>
+          <p:nvPr/>
+        </p:nvSpPr>
+        <p:spPr>
+          <a:xfrm>
+            <a:off x="9475241" y="4800600"/>
+            <a:ext cx="1619174" cy="411480"/>
+          </a:xfrm>
+          <a:prstGeom prst="rect">
+            <a:avLst/>
+          </a:prstGeom>
+          <a:noFill/>
+          <a:ln/>
+        </p:spPr>
+        <p:txBody>
+          <a:bodyPr wrap="square" lIns="0" tIns="0" rIns="0" bIns="0" rtlCol="0" anchor="t"/>
+          <a:lstStyle/>
+          <a:p>
+            <a:pPr indent="0" marL="0">
+              <a:lnSpc>
+                <a:spcPct val="112000"/>
+              </a:lnSpc>
+              <a:buNone/>
+            </a:pPr>
+            <a:r>
+              <a:rPr lang="en-US" sz="2200" b="1" dirty="0">
+                <a:solidFill>
+                  <a:srgbClr val="14201C"/>
+                </a:solidFill>
+                <a:latin typeface="Calibri" pitchFamily="34" charset="0"/>
+                <a:ea typeface="Calibri" pitchFamily="34" charset="-122"/>
+                <a:cs typeface="Calibri" pitchFamily="34" charset="-120"/>
+              </a:rPr>
+              <a:t>Passed</a:t>
+            </a:r>
+            <a:endParaRPr lang="en-US" sz="2200" dirty="0"/>
+          </a:p>
+        </p:txBody>
+      </p:sp>
+      <p:sp>
+        <p:nvSpPr>
+          <p:cNvPr id="31" name="Text 29"/>
+          <p:cNvSpPr txBox="1"/>
+          <p:nvPr/>
+        </p:nvSpPr>
+        <p:spPr>
+          <a:xfrm>
+            <a:off x="9475241" y="5257800"/>
+            <a:ext cx="1619174" cy="548640"/>
+          </a:xfrm>
+          <a:prstGeom prst="rect">
+            <a:avLst/>
+          </a:prstGeom>
+          <a:noFill/>
+          <a:ln/>
+        </p:spPr>
+        <p:txBody>
+          <a:bodyPr wrap="square" lIns="0" tIns="0" rIns="0" bIns="0" rtlCol="0" anchor="t"/>
+          <a:lstStyle/>
+          <a:p>
+            <a:pPr indent="0" marL="0">
+              <a:lnSpc>
+                <a:spcPct val="112000"/>
+              </a:lnSpc>
+              <a:buNone/>
+            </a:pPr>
+            <a:r>
+              <a:rPr lang="en-US" sz="1300" dirty="0">
+                <a:solidFill>
+                  <a:srgbClr val="3F4E49"/>
+                </a:solidFill>
+                <a:latin typeface="Calibri" pitchFamily="34" charset="0"/>
+                <a:ea typeface="Calibri" pitchFamily="34" charset="-122"/>
+                <a:cs typeface="Calibri" pitchFamily="34" charset="-120"/>
+              </a:rPr>
+              <a:t>Docker restart and post-restart smoke</a:t>
+            </a:r>
+            <a:endParaRPr lang="en-US" sz="1300" dirty="0"/>
+          </a:p>
+        </p:txBody>
+      </p:sp>
+      <p:sp>
+        <p:nvSpPr>
+          <p:cNvPr id="32" name="Text 30"/>
+          <p:cNvSpPr txBox="1"/>
+          <p:nvPr/>
+        </p:nvSpPr>
+        <p:spPr>
+          <a:xfrm>
+            <a:off x="685800" y="6062472"/>
+            <a:ext cx="10820095" cy="256032"/>
+          </a:xfrm>
+          <a:prstGeom prst="rect">
+            <a:avLst/>
+          </a:prstGeom>
+          <a:noFill/>
+          <a:ln/>
+        </p:spPr>
+        <p:txBody>
+          <a:bodyPr wrap="square" lIns="0" tIns="0" rIns="0" bIns="0" rtlCol="0" anchor="t"/>
+          <a:lstStyle/>
+          <a:p>
+            <a:pPr indent="0" marL="0">
+              <a:lnSpc>
+                <a:spcPct val="112000"/>
+              </a:lnSpc>
+              <a:buNone/>
+            </a:pPr>
+            <a:r>
+              <a:rPr lang="en-US" sz="1200" dirty="0">
+                <a:solidFill>
+                  <a:srgbClr val="5E6D68"/>
+                </a:solidFill>
+                <a:latin typeface="Calibri" pitchFamily="34" charset="0"/>
+                <a:ea typeface="Calibri" pitchFamily="34" charset="-122"/>
+                <a:cs typeface="Calibri" pitchFamily="34" charset="-120"/>
+              </a:rPr>
+              <a:t>Savings and losses are model results, not mine measurements.</a:t>
             </a:r>
             <a:endParaRPr lang="en-US" sz="1200" dirty="0"/>
           </a:p>
@@ -16370,7 +16775,7 @@
                           <a:ea typeface="Calibri" pitchFamily="34" charset="-122"/>
                           <a:cs typeface="Calibri" pitchFamily="34" charset="-120"/>
                         </a:rPr>
-                        <a:t>Simulate it: FIFO queues, cycle times, mass balance</a:t>
+                        <a:t>Simulate it at 20× speed: FIFO queues, cycle times, mass balance</a:t>
                       </a:r>
                       <a:endParaRPr lang="en-US" sz="1700" dirty="0">
                         <a:latin typeface="Calibri" charset="0"/>
@@ -16438,7 +16843,7 @@
                           <a:ea typeface="Calibri" pitchFamily="34" charset="-122"/>
                           <a:cs typeface="Calibri" pitchFamily="34" charset="-120"/>
                         </a:rPr>
-                        <a:t>Python engine, 92 tests</a:t>
+                        <a:t>98 simulator, API and evidence tests</a:t>
                       </a:r>
                       <a:endParaRPr lang="en-US" sz="1700" dirty="0">
                         <a:latin typeface="Calibri" charset="0"/>
@@ -16576,7 +16981,7 @@
                           <a:ea typeface="Calibri" pitchFamily="34" charset="-122"/>
                           <a:cs typeface="Calibri" pitchFamily="34" charset="-120"/>
                         </a:rPr>
-                        <a:t>Stream live state through MQTT and Ditto every 2 s</a:t>
+                        <a:t>Publish all 11 twins through MQTT to Ditto every 5 s; the frontend polls every 2 s</a:t>
                       </a:r>
                       <a:endParaRPr lang="en-US" sz="1700" dirty="0">
                         <a:latin typeface="Calibri" charset="0"/>
@@ -17920,7 +18325,7 @@
                 <a:ea typeface="Calibri" pitchFamily="34" charset="-122"/>
                 <a:cs typeface="Calibri" pitchFamily="34" charset="-120"/>
               </a:rPr>
-              <a:t>Ditto Protocol updates, a full snapshot every two seconds</a:t>
+              <a:t>Ditto Protocol updates: a complete 11-twin snapshot every 5 seconds</a:t>
             </a:r>
             <a:endParaRPr lang="en-US" sz="1400" dirty="0"/>
           </a:p>
@@ -18192,7 +18597,7 @@
                 <a:ea typeface="Calibri" pitchFamily="34" charset="-122"/>
                 <a:cs typeface="Calibri" pitchFamily="34" charset="-120"/>
               </a:rPr>
-              <a:t>One bulk Ditto read per poll; scenario and dispatch controls</a:t>
+              <a:t>One bulk Ditto read per frontend poll, every 2 seconds; scenario and dispatch controls</a:t>
             </a:r>
             <a:endParaRPr lang="en-US" sz="1400" dirty="0"/>
           </a:p>
@@ -18343,7 +18748,7 @@
         <p:spPr>
           <a:xfrm>
             <a:off x="685800" y="4389120"/>
-            <a:ext cx="2430704" cy="685800"/>
+            <a:ext cx="1889699" cy="685800"/>
           </a:xfrm>
           <a:prstGeom prst="rect">
             <a:avLst/>
@@ -18385,7 +18790,7 @@
         <p:spPr>
           <a:xfrm>
             <a:off x="685800" y="5120640"/>
-            <a:ext cx="2430704" cy="640080"/>
+            <a:ext cx="1889699" cy="640080"/>
           </a:xfrm>
           <a:prstGeom prst="rect">
             <a:avLst/>
@@ -18426,8 +18831,8 @@
         </p:nvSpPr>
         <p:spPr>
           <a:xfrm>
-            <a:off x="3390824" y="4389120"/>
-            <a:ext cx="2430704" cy="685800"/>
+            <a:off x="2849819" y="4389120"/>
+            <a:ext cx="1889699" cy="685800"/>
           </a:xfrm>
           <a:prstGeom prst="rect">
             <a:avLst/>
@@ -18468,8 +18873,8 @@
         </p:nvSpPr>
         <p:spPr>
           <a:xfrm>
-            <a:off x="3390824" y="5120640"/>
-            <a:ext cx="2430704" cy="640080"/>
+            <a:off x="2849819" y="5120640"/>
+            <a:ext cx="1889699" cy="640080"/>
           </a:xfrm>
           <a:prstGeom prst="rect">
             <a:avLst/>
@@ -18510,8 +18915,8 @@
         </p:nvSpPr>
         <p:spPr>
           <a:xfrm>
-            <a:off x="6095848" y="4389120"/>
-            <a:ext cx="2430704" cy="685800"/>
+            <a:off x="5013838" y="4389120"/>
+            <a:ext cx="1889699" cy="685800"/>
           </a:xfrm>
           <a:prstGeom prst="rect">
             <a:avLst/>
@@ -18538,7 +18943,7 @@
                 <a:ea typeface="Calibri" pitchFamily="34" charset="-122"/>
                 <a:cs typeface="Calibri" pitchFamily="34" charset="-120"/>
               </a:rPr>
-              <a:t>2 s</a:t>
+              <a:t>5 s</a:t>
             </a:r>
             <a:endParaRPr lang="en-US" sz="4000" dirty="0"/>
           </a:p>
@@ -18552,8 +18957,8 @@
         </p:nvSpPr>
         <p:spPr>
           <a:xfrm>
-            <a:off x="6095848" y="5120640"/>
-            <a:ext cx="2430704" cy="640080"/>
+            <a:off x="5013838" y="5120640"/>
+            <a:ext cx="1889699" cy="640080"/>
           </a:xfrm>
           <a:prstGeom prst="rect">
             <a:avLst/>
@@ -18580,7 +18985,7 @@
                 <a:ea typeface="Calibri" pitchFamily="34" charset="-122"/>
                 <a:cs typeface="Calibri" pitchFamily="34" charset="-120"/>
               </a:rPr>
-              <a:t>between twin updates on screen</a:t>
+              <a:t>simulator publishes a complete snapshot</a:t>
             </a:r>
             <a:endParaRPr lang="en-US" sz="1300" dirty="0"/>
           </a:p>
@@ -18594,8 +18999,8 @@
         </p:nvSpPr>
         <p:spPr>
           <a:xfrm>
-            <a:off x="8800871" y="4389120"/>
-            <a:ext cx="2430704" cy="685800"/>
+            <a:off x="7177857" y="4389120"/>
+            <a:ext cx="1889699" cy="685800"/>
           </a:xfrm>
           <a:prstGeom prst="rect">
             <a:avLst/>
@@ -18622,7 +19027,7 @@
                 <a:ea typeface="Calibri" pitchFamily="34" charset="-122"/>
                 <a:cs typeface="Calibri" pitchFamily="34" charset="-120"/>
               </a:rPr>
-              <a:t>20×</a:t>
+              <a:t>2 s</a:t>
             </a:r>
             <a:endParaRPr lang="en-US" sz="4000" dirty="0"/>
           </a:p>
@@ -18636,8 +19041,92 @@
         </p:nvSpPr>
         <p:spPr>
           <a:xfrm>
-            <a:off x="8800871" y="5120640"/>
-            <a:ext cx="2430704" cy="640080"/>
+            <a:off x="7177857" y="5120640"/>
+            <a:ext cx="1889699" cy="640080"/>
+          </a:xfrm>
+          <a:prstGeom prst="rect">
+            <a:avLst/>
+          </a:prstGeom>
+          <a:noFill/>
+          <a:ln/>
+        </p:spPr>
+        <p:txBody>
+          <a:bodyPr wrap="square" lIns="0" tIns="0" rIns="0" bIns="0" rtlCol="0" anchor="t"/>
+          <a:lstStyle/>
+          <a:p>
+            <a:pPr indent="0" marL="0">
+              <a:lnSpc>
+                <a:spcPct val="112000"/>
+              </a:lnSpc>
+              <a:buNone/>
+            </a:pPr>
+            <a:r>
+              <a:rPr lang="en-US" sz="1300" dirty="0">
+                <a:solidFill>
+                  <a:srgbClr val="3F4E49"/>
+                </a:solidFill>
+                <a:latin typeface="Calibri" pitchFamily="34" charset="0"/>
+                <a:ea typeface="Calibri" pitchFamily="34" charset="-122"/>
+                <a:cs typeface="Calibri" pitchFamily="34" charset="-120"/>
+              </a:rPr>
+              <a:t>frontend polls the Ademix API</a:t>
+            </a:r>
+            <a:endParaRPr lang="en-US" sz="1300" dirty="0"/>
+          </a:p>
+        </p:txBody>
+      </p:sp>
+      <p:sp>
+        <p:nvSpPr>
+          <p:cNvPr id="31" name="Text 29"/>
+          <p:cNvSpPr txBox="1"/>
+          <p:nvPr/>
+        </p:nvSpPr>
+        <p:spPr>
+          <a:xfrm>
+            <a:off x="9341876" y="4389120"/>
+            <a:ext cx="1889699" cy="685800"/>
+          </a:xfrm>
+          <a:prstGeom prst="rect">
+            <a:avLst/>
+          </a:prstGeom>
+          <a:noFill/>
+          <a:ln/>
+        </p:spPr>
+        <p:txBody>
+          <a:bodyPr wrap="square" lIns="0" tIns="0" rIns="0" bIns="0" rtlCol="0" anchor="t"/>
+          <a:lstStyle/>
+          <a:p>
+            <a:pPr indent="0" marL="0">
+              <a:lnSpc>
+                <a:spcPct val="112000"/>
+              </a:lnSpc>
+              <a:buNone/>
+            </a:pPr>
+            <a:r>
+              <a:rPr lang="en-US" sz="4000" b="1" dirty="0">
+                <a:solidFill>
+                  <a:srgbClr val="14201C"/>
+                </a:solidFill>
+                <a:latin typeface="Calibri" pitchFamily="34" charset="0"/>
+                <a:ea typeface="Calibri" pitchFamily="34" charset="-122"/>
+                <a:cs typeface="Calibri" pitchFamily="34" charset="-120"/>
+              </a:rPr>
+              <a:t>20×</a:t>
+            </a:r>
+            <a:endParaRPr lang="en-US" sz="4000" dirty="0"/>
+          </a:p>
+        </p:txBody>
+      </p:sp>
+      <p:sp>
+        <p:nvSpPr>
+          <p:cNvPr id="32" name="Text 30"/>
+          <p:cNvSpPr txBox="1"/>
+          <p:nvPr/>
+        </p:nvSpPr>
+        <p:spPr>
+          <a:xfrm>
+            <a:off x="9341876" y="5120640"/>
+            <a:ext cx="1889699" cy="640080"/>
           </a:xfrm>
           <a:prstGeom prst="rect">
             <a:avLst/>

</xml_diff>